<commit_message>
Strip the pitch deck back to anchors
The slides were carrying the pitch: full sentences, paragraphs of context,
lines the founder intends to say out loud. A judge who can read the pitch
off the wall stops listening to the person giving it, and presentation is
scored on the presenter.

Cuts the deck from roughly 800 words to 246 — about 25 a slide, most of
it headings and labels. Everything removed moved into the speaker notes
as talking points, so nothing is lost, it just isn't projected: the
supporting prose, the lines to land slowly, and which two slides carry
the heaviest scoring weight.

Type sizes go up as the word counts come down, so each slide reads as one
idea from the back of a room.

Renames the generator to .cjs — apps/keydate is an ES-module package, so
the .js extension made node parse it as ESM and refuse `require`.

Co-Authored-By: Claude Opus 5 <noreply@anthropic.com>
Claude-Session: https://claude.ai/code/session_019WKzGoyENXa8KtvmiHdCC2
</commit_message>
<xml_diff>
--- a/apps/keydate/pitch/KeyDate-JCI-Edmonton.pptx
+++ b/apps/keydate/pitch/KeyDate-JCI-Edmonton.pptx
@@ -511,7 +511,9 @@
           <a:p>
             <a:r>
               <a:rPr lang="en-US" dirty="0"/>
-              <a:t>Ask someone in their twenties when they'll own a home. They won't give you a year — they'll give you a feeling.</a:t>
+              <a:t>OPEN COLD. Do not read the slide.
+"Ask someone in their twenties when they'll own a home. They won't give you a year. They'll give you a feeling — probably never."
+Pause. Then move to slide 2.</a:t>
             </a:r>
             <a:endParaRPr lang="en-US" dirty="0"/>
           </a:p>
@@ -599,7 +601,9 @@
           <a:p>
             <a:r>
               <a:rPr lang="en-US" dirty="0"/>
-              <a:t>Memorise these three lines. Never read the close.</a:t>
+              <a:t>MEMORISE THIS. Never read the close.
+"Owning a home isn't impossible. It just doesn't have a date yet. We're giving it one."
+Then stop talking.</a:t>
             </a:r>
             <a:endParaRPr lang="en-US" dirty="0"/>
           </a:p>
@@ -687,7 +691,12 @@
           <a:p>
             <a:r>
               <a:rPr lang="en-US" dirty="0"/>
-              <a:t>SWAP IN YOUR REAL DETAIL HERE — the specific month, the specific spreadsheet, the specific person who gave you bad advice. Name one concrete thing. Specifics are what make a room lean in; generalities are what make them check the time.</a:t>
+              <a:t>THIS IS THE SLIDE THAT NEEDS YOUR REAL DETAIL. Pick ONE and tell it properly:
+· the month you nearly gave up
+· the person who gave you advice that turned out to be wrong
+· the number you were short by
+Talking points: rebuilt the spreadsheet every month · every source said something different · the target moved every time you looked at it.
+One concrete detail beats three general ones.</a:t>
             </a:r>
             <a:endParaRPr lang="en-US" dirty="0"/>
           </a:p>
@@ -775,7 +784,8 @@
           <a:p>
             <a:r>
               <a:rPr lang="en-US" dirty="0"/>
-              <a:t>Slow down. These are the three questions you genuinely could not answer. Say them like you are still annoyed about it.</a:t>
+              <a:t>Say these like you are still annoyed about it. They were YOUR questions.
+Talking point to land after: "Every tool I found answered a different question than the one I was actually asking."</a:t>
             </a:r>
             <a:endParaRPr lang="en-US" dirty="0"/>
           </a:p>
@@ -863,7 +873,9 @@
           <a:p>
             <a:r>
               <a:rPr lang="en-US" dirty="0"/>
-              <a:t>One number beat, then straight back to the story. Do not linger — the numbers are evidence for the feeling, not the point.</a:t>
+              <a:t>Do not linger — this is evidence for a feeling, not the argument.
+Talking points: "If it was that hard for me, what is it for someone starting now?" · "Most of you in this room bought somewhere inside that gap too."
+If challenged: 2006 is CREA's own figure for a record year. No income number is quoted on purpose — the series isn't cleanly comparable that far back.</a:t>
             </a:r>
             <a:endParaRPr lang="en-US" dirty="0"/>
           </a:p>
@@ -951,7 +963,8 @@
           <a:p>
             <a:r>
               <a:rPr lang="en-US" dirty="0"/>
-              <a:t>Hold up the phone here. Have your own plan already on screen — never type live, never rely on venue wifi.</a:t>
+              <a:t>HOLD UP THE PHONE HERE. Have your own plan already on screen — never type live, never rely on venue wifi.
+Talking points: income, savings, monthly · built on the real Canadian rules — FHSA, Home Buyers' Plan, the stress test · every dollar saved builds the house on screen.</a:t>
             </a:r>
             <a:endParaRPr lang="en-US" dirty="0"/>
           </a:p>
@@ -1039,7 +1052,9 @@
           <a:p>
             <a:r>
               <a:rPr lang="en-US" dirty="0"/>
-              <a:t>"I can't make the house cheaper" pre-empts the sharpest question in the room and buys credibility for everything after. Never cut it.</a:t>
+              <a:t>KEY LINE — do not cut for time: "I can't make the house cheaper. I can give people the answer I never got."
+It pre-empts the sharpest question in the room and buys credibility for everything after it.
+Talking point: today the answer is no, so people close the tab and stop saving entirely.</a:t>
             </a:r>
             <a:endParaRPr lang="en-US" dirty="0"/>
           </a:p>
@@ -1127,7 +1142,9 @@
           <a:p>
             <a:r>
               <a:rPr lang="en-US" dirty="0"/>
-              <a:t>Slow down on "The rulebook does." This is one of your two biggest scoring lines — international impact is written into the 35-point criterion.</a:t>
+              <a:t>BIGGEST SCORING SLIDE — impact is 35 of 115 points, and "international" is written into it.
+Talking points: when people can't see a path they stop building wealth at all — renters instead of owners, wealth that never compounds · every one of these countries has the same two problems: a generation priced out, and government programs nobody understands · KeyDate is a rules engine with a Canadian rulebook loaded.
+Slow down on "The rulebook swaps."</a:t>
             </a:r>
             <a:endParaRPr lang="en-US" dirty="0"/>
           </a:p>
@@ -1215,7 +1232,9 @@
           <a:p>
             <a:r>
               <a:rPr lang="en-US" dirty="0"/>
-              <a:t>Second big scoring line. Land "never say that sentence" slowly — this covers both community impact and ethical sustainability, worth 20 points.</a:t>
+              <a:t>SECOND BIGGEST SCORING SLIDE — community + sustainability is 20 points.
+Talking points: the obvious way to monetise this is selling users to mortgage brokers — people who just told you their income, their savings, and exactly when they'll need a mortgage · most valuable lead list in the country · our privacy policy says we never will, in writing, live today · the moment I'm paid to push you toward a house I stop being able to tell you the truth.
+Land the last line slowly.</a:t>
             </a:r>
             <a:endParaRPr lang="en-US" dirty="0"/>
           </a:p>
@@ -1303,7 +1322,8 @@
           <a:p>
             <a:r>
               <a:rPr lang="en-US" dirty="0"/>
-              <a:t>Leadership is 15 points and you are solo — so lead with evidence of execution, not claims about character.</a:t>
+              <a:t>Leadership is 15 points and you are solo — lead with evidence, not adjectives.
+Talking points: live at keydate.ca right now · incorporated · privacy policy, terms and content moderation done before the first user — because I'd rather be trusted than fast · I built and shipped it myself.</a:t>
             </a:r>
             <a:endParaRPr lang="en-US" dirty="0"/>
           </a:p>
@@ -1684,7 +1704,7 @@
         </p:nvSpPr>
         <p:spPr>
           <a:xfrm>
-            <a:off x="685800" y="1481328"/>
+            <a:off x="685800" y="1554480"/>
             <a:ext cx="576072" cy="576072"/>
           </a:xfrm>
           <a:prstGeom prst="ellipse">
@@ -1711,7 +1731,7 @@
         </p:nvSpPr>
         <p:spPr>
           <a:xfrm>
-            <a:off x="1207008" y="1714500"/>
+            <a:off x="1207008" y="1787652"/>
             <a:ext cx="630936" cy="102870"/>
           </a:xfrm>
           <a:prstGeom prst="rect">
@@ -1736,7 +1756,7 @@
         </p:nvSpPr>
         <p:spPr>
           <a:xfrm>
-            <a:off x="1591056" y="1714500"/>
+            <a:off x="1591056" y="1787652"/>
             <a:ext cx="102870" cy="274320"/>
           </a:xfrm>
           <a:prstGeom prst="rect">
@@ -1761,8 +1781,8 @@
         </p:nvSpPr>
         <p:spPr>
           <a:xfrm>
-            <a:off x="685800" y="2148840"/>
-            <a:ext cx="8229600" cy="914400"/>
+            <a:off x="685800" y="2240280"/>
+            <a:ext cx="8229600" cy="1005840"/>
           </a:xfrm>
           <a:prstGeom prst="rect">
             <a:avLst/>
@@ -1778,7 +1798,7 @@
               <a:buNone/>
             </a:pPr>
             <a:r>
-              <a:rPr lang="en-US" sz="6000" b="1" dirty="0">
+              <a:rPr lang="en-US" sz="6600" b="1" dirty="0">
                 <a:solidFill>
                   <a:srgbClr val="FFFFFF"/>
                 </a:solidFill>
@@ -1792,7 +1812,7 @@
               <a:buNone/>
             </a:pPr>
             <a:r>
-              <a:rPr lang="en-US" sz="6000" b="1" dirty="0">
+              <a:rPr lang="en-US" sz="6600" b="1" dirty="0">
                 <a:solidFill>
                   <a:srgbClr val="3FA672"/>
                 </a:solidFill>
@@ -1802,7 +1822,7 @@
               </a:rPr>
               <a:t>Date</a:t>
             </a:r>
-            <a:endParaRPr lang="en-US" sz="6000" dirty="0"/>
+            <a:endParaRPr lang="en-US" sz="6600" dirty="0"/>
           </a:p>
         </p:txBody>
       </p:sp>
@@ -1814,8 +1834,8 @@
         </p:nvSpPr>
         <p:spPr>
           <a:xfrm>
-            <a:off x="685800" y="3127248"/>
-            <a:ext cx="8412480" cy="1371600"/>
+            <a:off x="685800" y="3337560"/>
+            <a:ext cx="9144000" cy="1463040"/>
           </a:xfrm>
           <a:prstGeom prst="rect">
             <a:avLst/>
@@ -1829,12 +1849,12 @@
           <a:p>
             <a:pPr indent="0" marL="0">
               <a:lnSpc>
-                <a:spcPts val="3800"/>
+                <a:spcPts val="4200"/>
               </a:lnSpc>
               <a:buNone/>
             </a:pPr>
             <a:r>
-              <a:rPr lang="en-US" sz="3000" dirty="0">
+              <a:rPr lang="en-US" sz="3200" dirty="0">
                 <a:solidFill>
                   <a:srgbClr val="E3F2E9"/>
                 </a:solidFill>
@@ -1844,17 +1864,17 @@
               </a:rPr>
               <a:t>Owning a home isn’t impossible.</a:t>
             </a:r>
-            <a:endParaRPr lang="en-US" sz="3000" dirty="0"/>
+            <a:endParaRPr lang="en-US" sz="3200" dirty="0"/>
           </a:p>
           <a:p>
             <a:pPr indent="0" marL="0">
               <a:lnSpc>
-                <a:spcPts val="3800"/>
+                <a:spcPts val="4200"/>
               </a:lnSpc>
               <a:buNone/>
             </a:pPr>
             <a:r>
-              <a:rPr lang="en-US" sz="3000" dirty="0">
+              <a:rPr lang="en-US" sz="3200" dirty="0">
                 <a:solidFill>
                   <a:srgbClr val="E3F2E9"/>
                 </a:solidFill>
@@ -1864,7 +1884,7 @@
               </a:rPr>
               <a:t>It has a date.</a:t>
             </a:r>
-            <a:endParaRPr lang="en-US" sz="3000" dirty="0"/>
+            <a:endParaRPr lang="en-US" sz="3200" dirty="0"/>
           </a:p>
         </p:txBody>
       </p:sp>
@@ -1876,7 +1896,7 @@
         </p:nvSpPr>
         <p:spPr>
           <a:xfrm>
-            <a:off x="685800" y="5715000"/>
+            <a:off x="685800" y="5760720"/>
             <a:ext cx="7315200" cy="320040"/>
           </a:xfrm>
           <a:prstGeom prst="rect">
@@ -1915,7 +1935,7 @@
         </p:nvSpPr>
         <p:spPr>
           <a:xfrm>
-            <a:off x="8759952" y="5715000"/>
+            <a:off x="8759952" y="5760720"/>
             <a:ext cx="2743200" cy="320040"/>
           </a:xfrm>
           <a:prstGeom prst="rect">
@@ -1932,9 +1952,9 @@
               <a:buNone/>
             </a:pPr>
             <a:r>
-              <a:rPr lang="en-US" sz="1400" dirty="0">
-                <a:solidFill>
-                  <a:srgbClr val="E3F2E9"/>
+              <a:rPr lang="en-US" sz="1400" b="1" dirty="0">
+                <a:solidFill>
+                  <a:srgbClr val="E8B84B"/>
                 </a:solidFill>
                 <a:latin typeface="Calibri" pitchFamily="34" charset="0"/>
                 <a:ea typeface="Calibri" pitchFamily="34" charset="-122"/>
@@ -1986,7 +2006,7 @@
         </p:nvSpPr>
         <p:spPr>
           <a:xfrm>
-            <a:off x="685800" y="1371600"/>
+            <a:off x="685800" y="1463040"/>
             <a:ext cx="576072" cy="576072"/>
           </a:xfrm>
           <a:prstGeom prst="ellipse">
@@ -2013,7 +2033,7 @@
         </p:nvSpPr>
         <p:spPr>
           <a:xfrm>
-            <a:off x="1207008" y="1604772"/>
+            <a:off x="1207008" y="1696212"/>
             <a:ext cx="630936" cy="102870"/>
           </a:xfrm>
           <a:prstGeom prst="rect">
@@ -2038,7 +2058,7 @@
         </p:nvSpPr>
         <p:spPr>
           <a:xfrm>
-            <a:off x="1591056" y="1604772"/>
+            <a:off x="1591056" y="1696212"/>
             <a:ext cx="102870" cy="274320"/>
           </a:xfrm>
           <a:prstGeom prst="rect">
@@ -2063,8 +2083,8 @@
         </p:nvSpPr>
         <p:spPr>
           <a:xfrm>
-            <a:off x="685800" y="2331720"/>
-            <a:ext cx="10607040" cy="731520"/>
+            <a:off x="685800" y="2377440"/>
+            <a:ext cx="10607040" cy="1645920"/>
           </a:xfrm>
           <a:prstGeom prst="rect">
             <a:avLst/>
@@ -2077,10 +2097,13 @@
           <a:lstStyle/>
           <a:p>
             <a:pPr indent="0" marL="0">
-              <a:buNone/>
-            </a:pPr>
-            <a:r>
-              <a:rPr lang="en-US" sz="3800" dirty="0">
+              <a:lnSpc>
+                <a:spcPts val="5400"/>
+              </a:lnSpc>
+              <a:buNone/>
+            </a:pPr>
+            <a:r>
+              <a:rPr lang="en-US" sz="4000" dirty="0">
                 <a:solidFill>
                   <a:srgbClr val="E3F2E9"/>
                 </a:solidFill>
@@ -2088,38 +2111,19 @@
                 <a:ea typeface="Cambria" pitchFamily="34" charset="-122"/>
                 <a:cs typeface="Cambria" pitchFamily="34" charset="-120"/>
               </a:rPr>
-              <a:t>Owning a home isn’t impossible.</a:t>
-            </a:r>
-            <a:endParaRPr lang="en-US" sz="3800" dirty="0"/>
-          </a:p>
-        </p:txBody>
-      </p:sp>
-      <p:sp>
-        <p:nvSpPr>
-          <p:cNvPr id="6" name="Text 4"/>
-          <p:cNvSpPr/>
-          <p:nvPr/>
-        </p:nvSpPr>
-        <p:spPr>
-          <a:xfrm>
-            <a:off x="685800" y="3063240"/>
-            <a:ext cx="10607040" cy="731520"/>
-          </a:xfrm>
-          <a:prstGeom prst="rect">
-            <a:avLst/>
-          </a:prstGeom>
-          <a:noFill/>
-          <a:ln/>
-        </p:spPr>
-        <p:txBody>
-          <a:bodyPr wrap="square" lIns="0" tIns="0" rIns="0" bIns="0" rtlCol="0" anchor="ctr"/>
-          <a:lstStyle/>
+              <a:t>It just doesn’t have</a:t>
+            </a:r>
+            <a:endParaRPr lang="en-US" sz="4000" dirty="0"/>
+          </a:p>
           <a:p>
             <a:pPr indent="0" marL="0">
-              <a:buNone/>
-            </a:pPr>
-            <a:r>
-              <a:rPr lang="en-US" sz="3800" dirty="0">
+              <a:lnSpc>
+                <a:spcPts val="5400"/>
+              </a:lnSpc>
+              <a:buNone/>
+            </a:pPr>
+            <a:r>
+              <a:rPr lang="en-US" sz="4000" dirty="0">
                 <a:solidFill>
                   <a:srgbClr val="E3F2E9"/>
                 </a:solidFill>
@@ -2127,22 +2131,22 @@
                 <a:ea typeface="Cambria" pitchFamily="34" charset="-122"/>
                 <a:cs typeface="Cambria" pitchFamily="34" charset="-120"/>
               </a:rPr>
-              <a:t>It just doesn’t have a date yet.</a:t>
-            </a:r>
-            <a:endParaRPr lang="en-US" sz="3800" dirty="0"/>
-          </a:p>
-        </p:txBody>
-      </p:sp>
-      <p:sp>
-        <p:nvSpPr>
-          <p:cNvPr id="7" name="Text 5"/>
-          <p:cNvSpPr/>
-          <p:nvPr/>
-        </p:nvSpPr>
-        <p:spPr>
-          <a:xfrm>
-            <a:off x="685800" y="3931920"/>
-            <a:ext cx="10607040" cy="914400"/>
+              <a:t>a date yet.</a:t>
+            </a:r>
+            <a:endParaRPr lang="en-US" sz="4000" dirty="0"/>
+          </a:p>
+        </p:txBody>
+      </p:sp>
+      <p:sp>
+        <p:nvSpPr>
+          <p:cNvPr id="6" name="Text 4"/>
+          <p:cNvSpPr/>
+          <p:nvPr/>
+        </p:nvSpPr>
+        <p:spPr>
+          <a:xfrm>
+            <a:off x="685800" y="4206240"/>
+            <a:ext cx="10607040" cy="1005840"/>
           </a:xfrm>
           <a:prstGeom prst="rect">
             <a:avLst/>
@@ -2158,7 +2162,7 @@
               <a:buNone/>
             </a:pPr>
             <a:r>
-              <a:rPr lang="en-US" sz="5000" b="1" dirty="0">
+              <a:rPr lang="en-US" sz="5400" b="1" dirty="0">
                 <a:solidFill>
                   <a:srgbClr val="E8B84B"/>
                 </a:solidFill>
@@ -2168,19 +2172,19 @@
               </a:rPr>
               <a:t>We’re giving it one.</a:t>
             </a:r>
-            <a:endParaRPr lang="en-US" sz="5000" dirty="0"/>
-          </a:p>
-        </p:txBody>
-      </p:sp>
-      <p:sp>
-        <p:nvSpPr>
-          <p:cNvPr id="8" name="Text 6"/>
-          <p:cNvSpPr/>
-          <p:nvPr/>
-        </p:nvSpPr>
-        <p:spPr>
-          <a:xfrm>
-            <a:off x="685800" y="5669280"/>
+            <a:endParaRPr lang="en-US" sz="5400" dirty="0"/>
+          </a:p>
+        </p:txBody>
+      </p:sp>
+      <p:sp>
+        <p:nvSpPr>
+          <p:cNvPr id="7" name="Text 5"/>
+          <p:cNvSpPr/>
+          <p:nvPr/>
+        </p:nvSpPr>
+        <p:spPr>
+          <a:xfrm>
+            <a:off x="685800" y="5760720"/>
             <a:ext cx="5486400" cy="365760"/>
           </a:xfrm>
           <a:prstGeom prst="rect">
@@ -2213,13 +2217,13 @@
       </p:sp>
       <p:sp>
         <p:nvSpPr>
-          <p:cNvPr id="9" name="Text 7"/>
-          <p:cNvSpPr/>
-          <p:nvPr/>
-        </p:nvSpPr>
-        <p:spPr>
-          <a:xfrm>
-            <a:off x="6931152" y="5669280"/>
+          <p:cNvPr id="8" name="Text 6"/>
+          <p:cNvSpPr/>
+          <p:nvPr/>
+        </p:nvSpPr>
+        <p:spPr>
+          <a:xfrm>
+            <a:off x="6931152" y="5760720"/>
             <a:ext cx="4572000" cy="365760"/>
           </a:xfrm>
           <a:prstGeom prst="rect">
@@ -2290,8 +2294,8 @@
         </p:nvSpPr>
         <p:spPr>
           <a:xfrm>
-            <a:off x="685800" y="475488"/>
-            <a:ext cx="7315200" cy="274320"/>
+            <a:off x="685800" y="502920"/>
+            <a:ext cx="9144000" cy="274320"/>
           </a:xfrm>
           <a:prstGeom prst="rect">
             <a:avLst/>
@@ -2329,8 +2333,8 @@
         </p:nvSpPr>
         <p:spPr>
           <a:xfrm>
-            <a:off x="685800" y="1417320"/>
-            <a:ext cx="10607040" cy="914400"/>
+            <a:off x="685800" y="1691640"/>
+            <a:ext cx="10607040" cy="1005840"/>
           </a:xfrm>
           <a:prstGeom prst="rect">
             <a:avLst/>
@@ -2346,7 +2350,7 @@
               <a:buNone/>
             </a:pPr>
             <a:r>
-              <a:rPr lang="en-US" sz="4600" b="1" dirty="0">
+              <a:rPr lang="en-US" sz="5000" b="1" dirty="0">
                 <a:solidFill>
                   <a:srgbClr val="17302A"/>
                 </a:solidFill>
@@ -2356,7 +2360,7 @@
               </a:rPr>
               <a:t>I bought my first place.</a:t>
             </a:r>
-            <a:endParaRPr lang="en-US" sz="4600" dirty="0"/>
+            <a:endParaRPr lang="en-US" sz="5000" dirty="0"/>
           </a:p>
         </p:txBody>
       </p:sp>
@@ -2368,8 +2372,8 @@
         </p:nvSpPr>
         <p:spPr>
           <a:xfrm>
-            <a:off x="685800" y="2514600"/>
-            <a:ext cx="10607040" cy="640080"/>
+            <a:off x="685800" y="2788920"/>
+            <a:ext cx="10607040" cy="914400"/>
           </a:xfrm>
           <a:prstGeom prst="rect">
             <a:avLst/>
@@ -2385,73 +2389,34 @@
               <a:buNone/>
             </a:pPr>
             <a:r>
-              <a:rPr lang="en-US" sz="3200" dirty="0">
-                <a:solidFill>
-                  <a:srgbClr val="5C6F66"/>
+              <a:rPr lang="en-US" sz="4200" b="1" dirty="0">
+                <a:solidFill>
+                  <a:srgbClr val="1E4D3B"/>
                 </a:solidFill>
                 <a:latin typeface="Cambria" pitchFamily="34" charset="0"/>
                 <a:ea typeface="Cambria" pitchFamily="34" charset="-122"/>
                 <a:cs typeface="Cambria" pitchFamily="34" charset="-120"/>
               </a:rPr>
-              <a:t>I got there.</a:t>
-            </a:r>
-            <a:endParaRPr lang="en-US" sz="3200" dirty="0"/>
-          </a:p>
-        </p:txBody>
-      </p:sp>
-      <p:sp>
-        <p:nvSpPr>
-          <p:cNvPr id="5" name="Text 3"/>
-          <p:cNvSpPr/>
-          <p:nvPr/>
-        </p:nvSpPr>
-        <p:spPr>
-          <a:xfrm>
-            <a:off x="685800" y="3200400"/>
-            <a:ext cx="10607040" cy="822960"/>
-          </a:xfrm>
-          <a:prstGeom prst="rect">
-            <a:avLst/>
-          </a:prstGeom>
-          <a:noFill/>
-          <a:ln/>
-        </p:spPr>
-        <p:txBody>
-          <a:bodyPr wrap="square" lIns="0" tIns="0" rIns="0" bIns="0" rtlCol="0" anchor="ctr"/>
-          <a:lstStyle/>
-          <a:p>
-            <a:pPr indent="0" marL="0">
-              <a:buNone/>
-            </a:pPr>
-            <a:r>
-              <a:rPr lang="en-US" sz="3800" b="1" dirty="0">
-                <a:solidFill>
-                  <a:srgbClr val="1E4D3B"/>
-                </a:solidFill>
-                <a:latin typeface="Cambria" pitchFamily="34" charset="0"/>
-                <a:ea typeface="Cambria" pitchFamily="34" charset="-122"/>
-                <a:cs typeface="Cambria" pitchFamily="34" charset="-120"/>
-              </a:rPr>
-              <a:t>I was guessing the entire way.</a:t>
-            </a:r>
-            <a:endParaRPr lang="en-US" sz="3800" dirty="0"/>
-          </a:p>
-        </p:txBody>
-      </p:sp>
-      <p:sp>
-        <p:nvSpPr>
-          <p:cNvPr id="6" name="Shape 4"/>
-          <p:cNvSpPr/>
-          <p:nvPr/>
-        </p:nvSpPr>
-        <p:spPr>
-          <a:xfrm>
-            <a:off x="685800" y="4434840"/>
-            <a:ext cx="10607040" cy="1234440"/>
+              <a:t>I was guessing the whole way.</a:t>
+            </a:r>
+            <a:endParaRPr lang="en-US" sz="4200" dirty="0"/>
+          </a:p>
+        </p:txBody>
+      </p:sp>
+      <p:sp>
+        <p:nvSpPr>
+          <p:cNvPr id="5" name="Shape 3"/>
+          <p:cNvSpPr/>
+          <p:nvPr/>
+        </p:nvSpPr>
+        <p:spPr>
+          <a:xfrm>
+            <a:off x="685800" y="4297680"/>
+            <a:ext cx="3364992" cy="777240"/>
           </a:xfrm>
           <a:prstGeom prst="roundRect">
             <a:avLst>
-              <a:gd name="adj" fmla="val 11852"/>
+              <a:gd name="adj" fmla="val 16471"/>
             </a:avLst>
           </a:prstGeom>
           <a:solidFill>
@@ -2467,43 +2432,172 @@
       </p:sp>
       <p:sp>
         <p:nvSpPr>
-          <p:cNvPr id="7" name="Text 5"/>
-          <p:cNvSpPr/>
-          <p:nvPr/>
-        </p:nvSpPr>
-        <p:spPr>
-          <a:xfrm>
-            <a:off x="1143000" y="4434840"/>
-            <a:ext cx="9692640" cy="1234440"/>
-          </a:xfrm>
-          <a:prstGeom prst="rect">
-            <a:avLst/>
-          </a:prstGeom>
-          <a:noFill/>
-          <a:ln/>
-        </p:spPr>
-        <p:txBody>
-          <a:bodyPr wrap="square" lIns="0" tIns="0" rIns="0" bIns="0" rtlCol="0" anchor="ctr"/>
-          <a:lstStyle/>
-          <a:p>
-            <a:pPr indent="0" marL="0">
-              <a:lnSpc>
-                <a:spcPts val="2500"/>
-              </a:lnSpc>
-              <a:buNone/>
-            </a:pPr>
-            <a:r>
-              <a:rPr lang="en-US" sz="1700" dirty="0">
-                <a:solidFill>
-                  <a:srgbClr val="17302A"/>
+          <p:cNvPr id="6" name="Text 4"/>
+          <p:cNvSpPr/>
+          <p:nvPr/>
+        </p:nvSpPr>
+        <p:spPr>
+          <a:xfrm>
+            <a:off x="685800" y="4297680"/>
+            <a:ext cx="3364992" cy="777240"/>
+          </a:xfrm>
+          <a:prstGeom prst="rect">
+            <a:avLst/>
+          </a:prstGeom>
+          <a:noFill/>
+          <a:ln/>
+        </p:spPr>
+        <p:txBody>
+          <a:bodyPr wrap="square" lIns="0" tIns="0" rIns="0" bIns="0" rtlCol="0" anchor="ctr"/>
+          <a:lstStyle/>
+          <a:p>
+            <a:pPr algn="ctr" indent="0" marL="0">
+              <a:buNone/>
+            </a:pPr>
+            <a:r>
+              <a:rPr lang="en-US" sz="1600" b="1" dirty="0">
+                <a:solidFill>
+                  <a:srgbClr val="1E4D3B"/>
                 </a:solidFill>
                 <a:latin typeface="Calibri" pitchFamily="34" charset="0"/>
                 <a:ea typeface="Calibri" pitchFamily="34" charset="-122"/>
                 <a:cs typeface="Calibri" pitchFamily="34" charset="-120"/>
               </a:rPr>
-              <a:t>Spreadsheets I rebuilt every month. Advice that contradicted itself. A goal that moved every time I looked at it.</a:t>
-            </a:r>
-            <a:endParaRPr lang="en-US" sz="1700" dirty="0"/>
+              <a:t>Spreadsheets</a:t>
+            </a:r>
+            <a:endParaRPr lang="en-US" sz="1600" dirty="0"/>
+          </a:p>
+        </p:txBody>
+      </p:sp>
+      <p:sp>
+        <p:nvSpPr>
+          <p:cNvPr id="7" name="Shape 5"/>
+          <p:cNvSpPr/>
+          <p:nvPr/>
+        </p:nvSpPr>
+        <p:spPr>
+          <a:xfrm>
+            <a:off x="4306824" y="4297680"/>
+            <a:ext cx="3364992" cy="777240"/>
+          </a:xfrm>
+          <a:prstGeom prst="roundRect">
+            <a:avLst>
+              <a:gd name="adj" fmla="val 16471"/>
+            </a:avLst>
+          </a:prstGeom>
+          <a:solidFill>
+            <a:srgbClr val="E3F2E9"/>
+          </a:solidFill>
+          <a:ln w="12700">
+            <a:solidFill>
+              <a:srgbClr val="3FA672"/>
+            </a:solidFill>
+            <a:prstDash val="solid"/>
+          </a:ln>
+        </p:spPr>
+      </p:sp>
+      <p:sp>
+        <p:nvSpPr>
+          <p:cNvPr id="8" name="Text 6"/>
+          <p:cNvSpPr/>
+          <p:nvPr/>
+        </p:nvSpPr>
+        <p:spPr>
+          <a:xfrm>
+            <a:off x="4306824" y="4297680"/>
+            <a:ext cx="3364992" cy="777240"/>
+          </a:xfrm>
+          <a:prstGeom prst="rect">
+            <a:avLst/>
+          </a:prstGeom>
+          <a:noFill/>
+          <a:ln/>
+        </p:spPr>
+        <p:txBody>
+          <a:bodyPr wrap="square" lIns="0" tIns="0" rIns="0" bIns="0" rtlCol="0" anchor="ctr"/>
+          <a:lstStyle/>
+          <a:p>
+            <a:pPr algn="ctr" indent="0" marL="0">
+              <a:buNone/>
+            </a:pPr>
+            <a:r>
+              <a:rPr lang="en-US" sz="1600" b="1" dirty="0">
+                <a:solidFill>
+                  <a:srgbClr val="1E4D3B"/>
+                </a:solidFill>
+                <a:latin typeface="Calibri" pitchFamily="34" charset="0"/>
+                <a:ea typeface="Calibri" pitchFamily="34" charset="-122"/>
+                <a:cs typeface="Calibri" pitchFamily="34" charset="-120"/>
+              </a:rPr>
+              <a:t>Contradictory advice</a:t>
+            </a:r>
+            <a:endParaRPr lang="en-US" sz="1600" dirty="0"/>
+          </a:p>
+        </p:txBody>
+      </p:sp>
+      <p:sp>
+        <p:nvSpPr>
+          <p:cNvPr id="9" name="Shape 7"/>
+          <p:cNvSpPr/>
+          <p:nvPr/>
+        </p:nvSpPr>
+        <p:spPr>
+          <a:xfrm>
+            <a:off x="7927848" y="4297680"/>
+            <a:ext cx="3364992" cy="777240"/>
+          </a:xfrm>
+          <a:prstGeom prst="roundRect">
+            <a:avLst>
+              <a:gd name="adj" fmla="val 16471"/>
+            </a:avLst>
+          </a:prstGeom>
+          <a:solidFill>
+            <a:srgbClr val="E3F2E9"/>
+          </a:solidFill>
+          <a:ln w="12700">
+            <a:solidFill>
+              <a:srgbClr val="3FA672"/>
+            </a:solidFill>
+            <a:prstDash val="solid"/>
+          </a:ln>
+        </p:spPr>
+      </p:sp>
+      <p:sp>
+        <p:nvSpPr>
+          <p:cNvPr id="10" name="Text 8"/>
+          <p:cNvSpPr/>
+          <p:nvPr/>
+        </p:nvSpPr>
+        <p:spPr>
+          <a:xfrm>
+            <a:off x="7927848" y="4297680"/>
+            <a:ext cx="3364992" cy="777240"/>
+          </a:xfrm>
+          <a:prstGeom prst="rect">
+            <a:avLst/>
+          </a:prstGeom>
+          <a:noFill/>
+          <a:ln/>
+        </p:spPr>
+        <p:txBody>
+          <a:bodyPr wrap="square" lIns="0" tIns="0" rIns="0" bIns="0" rtlCol="0" anchor="ctr"/>
+          <a:lstStyle/>
+          <a:p>
+            <a:pPr algn="ctr" indent="0" marL="0">
+              <a:buNone/>
+            </a:pPr>
+            <a:r>
+              <a:rPr lang="en-US" sz="1600" b="1" dirty="0">
+                <a:solidFill>
+                  <a:srgbClr val="1E4D3B"/>
+                </a:solidFill>
+                <a:latin typeface="Calibri" pitchFamily="34" charset="0"/>
+                <a:ea typeface="Calibri" pitchFamily="34" charset="-122"/>
+                <a:cs typeface="Calibri" pitchFamily="34" charset="-120"/>
+              </a:rPr>
+              <a:t>A goal that kept moving</a:t>
+            </a:r>
+            <a:endParaRPr lang="en-US" sz="1600" dirty="0"/>
           </a:p>
         </p:txBody>
       </p:sp>
@@ -2547,7 +2641,7 @@
         </p:nvSpPr>
         <p:spPr>
           <a:xfrm>
-            <a:off x="685800" y="1143000"/>
+            <a:off x="685800" y="1188720"/>
             <a:ext cx="384048" cy="384048"/>
           </a:xfrm>
           <a:prstGeom prst="ellipse">
@@ -2574,7 +2668,7 @@
         </p:nvSpPr>
         <p:spPr>
           <a:xfrm>
-            <a:off x="1033272" y="1298448"/>
+            <a:off x="1033272" y="1344168"/>
             <a:ext cx="420624" cy="68580"/>
           </a:xfrm>
           <a:prstGeom prst="rect">
@@ -2599,7 +2693,7 @@
         </p:nvSpPr>
         <p:spPr>
           <a:xfrm>
-            <a:off x="1289304" y="1298448"/>
+            <a:off x="1289304" y="1344168"/>
             <a:ext cx="68580" cy="182880"/>
           </a:xfrm>
           <a:prstGeom prst="rect">
@@ -2624,8 +2718,8 @@
         </p:nvSpPr>
         <p:spPr>
           <a:xfrm>
-            <a:off x="685800" y="1874520"/>
-            <a:ext cx="10607040" cy="1005840"/>
+            <a:off x="685800" y="1965960"/>
+            <a:ext cx="10607040" cy="1097280"/>
           </a:xfrm>
           <a:prstGeom prst="rect">
             <a:avLst/>
@@ -2641,7 +2735,7 @@
               <a:buNone/>
             </a:pPr>
             <a:r>
-              <a:rPr lang="en-US" sz="4600" b="1" dirty="0">
+              <a:rPr lang="en-US" sz="5000" b="1" dirty="0">
                 <a:solidFill>
                   <a:srgbClr val="E8B84B"/>
                 </a:solidFill>
@@ -2651,7 +2745,7 @@
               </a:rPr>
               <a:t>Nobody could tell me when.</a:t>
             </a:r>
-            <a:endParaRPr lang="en-US" sz="4600" dirty="0"/>
+            <a:endParaRPr lang="en-US" sz="5000" dirty="0"/>
           </a:p>
         </p:txBody>
       </p:sp>
@@ -2663,8 +2757,8 @@
         </p:nvSpPr>
         <p:spPr>
           <a:xfrm>
-            <a:off x="731520" y="3255264"/>
-            <a:ext cx="146304" cy="146304"/>
+            <a:off x="731520" y="3557016"/>
+            <a:ext cx="164592" cy="164592"/>
           </a:xfrm>
           <a:prstGeom prst="ellipse">
             <a:avLst/>
@@ -2688,8 +2782,8 @@
         </p:nvSpPr>
         <p:spPr>
           <a:xfrm>
-            <a:off x="1143000" y="3154680"/>
-            <a:ext cx="9875520" cy="457200"/>
+            <a:off x="1188720" y="3429000"/>
+            <a:ext cx="9875520" cy="502920"/>
           </a:xfrm>
           <a:prstGeom prst="rect">
             <a:avLst/>
@@ -2705,7 +2799,7 @@
               <a:buNone/>
             </a:pPr>
             <a:r>
-              <a:rPr lang="en-US" sz="2500" dirty="0">
+              <a:rPr lang="en-US" sz="2800" dirty="0">
                 <a:solidFill>
                   <a:srgbClr val="E3F2E9"/>
                 </a:solidFill>
@@ -2715,7 +2809,7 @@
               </a:rPr>
               <a:t>How much do I actually need?</a:t>
             </a:r>
-            <a:endParaRPr lang="en-US" sz="2500" dirty="0"/>
+            <a:endParaRPr lang="en-US" sz="2800" dirty="0"/>
           </a:p>
         </p:txBody>
       </p:sp>
@@ -2727,8 +2821,8 @@
         </p:nvSpPr>
         <p:spPr>
           <a:xfrm>
-            <a:off x="731520" y="3913632"/>
-            <a:ext cx="146304" cy="146304"/>
+            <a:off x="731520" y="4306824"/>
+            <a:ext cx="164592" cy="164592"/>
           </a:xfrm>
           <a:prstGeom prst="ellipse">
             <a:avLst/>
@@ -2752,8 +2846,8 @@
         </p:nvSpPr>
         <p:spPr>
           <a:xfrm>
-            <a:off x="1143000" y="3813048"/>
-            <a:ext cx="9875520" cy="457200"/>
+            <a:off x="1188720" y="4178808"/>
+            <a:ext cx="9875520" cy="502920"/>
           </a:xfrm>
           <a:prstGeom prst="rect">
             <a:avLst/>
@@ -2769,7 +2863,7 @@
               <a:buNone/>
             </a:pPr>
             <a:r>
-              <a:rPr lang="en-US" sz="2500" dirty="0">
+              <a:rPr lang="en-US" sz="2800" dirty="0">
                 <a:solidFill>
                   <a:srgbClr val="E3F2E9"/>
                 </a:solidFill>
@@ -2779,7 +2873,7 @@
               </a:rPr>
               <a:t>Am I even close?</a:t>
             </a:r>
-            <a:endParaRPr lang="en-US" sz="2500" dirty="0"/>
+            <a:endParaRPr lang="en-US" sz="2800" dirty="0"/>
           </a:p>
         </p:txBody>
       </p:sp>
@@ -2791,8 +2885,8 @@
         </p:nvSpPr>
         <p:spPr>
           <a:xfrm>
-            <a:off x="731520" y="4572000"/>
-            <a:ext cx="146304" cy="146304"/>
+            <a:off x="731520" y="5056632"/>
+            <a:ext cx="164592" cy="164592"/>
           </a:xfrm>
           <a:prstGeom prst="ellipse">
             <a:avLst/>
@@ -2816,8 +2910,8 @@
         </p:nvSpPr>
         <p:spPr>
           <a:xfrm>
-            <a:off x="1143000" y="4471416"/>
-            <a:ext cx="9875520" cy="457200"/>
+            <a:off x="1188720" y="4928616"/>
+            <a:ext cx="9875520" cy="502920"/>
           </a:xfrm>
           <a:prstGeom prst="rect">
             <a:avLst/>
@@ -2833,7 +2927,7 @@
               <a:buNone/>
             </a:pPr>
             <a:r>
-              <a:rPr lang="en-US" sz="2500" dirty="0">
+              <a:rPr lang="en-US" sz="2800" dirty="0">
                 <a:solidFill>
                   <a:srgbClr val="E3F2E9"/>
                 </a:solidFill>
@@ -2841,48 +2935,9 @@
                 <a:ea typeface="Cambria" pitchFamily="34" charset="-122"/>
                 <a:cs typeface="Cambria" pitchFamily="34" charset="-120"/>
               </a:rPr>
-              <a:t>Is this the year — or is it five years away?</a:t>
-            </a:r>
-            <a:endParaRPr lang="en-US" sz="2500" dirty="0"/>
-          </a:p>
-        </p:txBody>
-      </p:sp>
-      <p:sp>
-        <p:nvSpPr>
-          <p:cNvPr id="12" name="Text 10"/>
-          <p:cNvSpPr/>
-          <p:nvPr/>
-        </p:nvSpPr>
-        <p:spPr>
-          <a:xfrm>
-            <a:off x="685800" y="5440680"/>
-            <a:ext cx="10607040" cy="548640"/>
-          </a:xfrm>
-          <a:prstGeom prst="rect">
-            <a:avLst/>
-          </a:prstGeom>
-          <a:noFill/>
-          <a:ln/>
-        </p:spPr>
-        <p:txBody>
-          <a:bodyPr wrap="square" lIns="0" tIns="0" rIns="0" bIns="0" rtlCol="0" anchor="ctr"/>
-          <a:lstStyle/>
-          <a:p>
-            <a:pPr indent="0" marL="0">
-              <a:buNone/>
-            </a:pPr>
-            <a:r>
-              <a:rPr lang="en-US" sz="1700" i="1" dirty="0">
-                <a:solidFill>
-                  <a:srgbClr val="E3F2E9"/>
-                </a:solidFill>
-                <a:latin typeface="Calibri" pitchFamily="34" charset="0"/>
-                <a:ea typeface="Calibri" pitchFamily="34" charset="-122"/>
-                <a:cs typeface="Calibri" pitchFamily="34" charset="-120"/>
-              </a:rPr>
-              <a:t>Every tool I found answered a different question than the one I was actually asking.</a:t>
-            </a:r>
-            <a:endParaRPr lang="en-US" sz="1700" dirty="0"/>
+              <a:t>Is this the year, or five years away?</a:t>
+            </a:r>
+            <a:endParaRPr lang="en-US" sz="2800" dirty="0"/>
           </a:p>
         </p:txBody>
       </p:sp>
@@ -2926,8 +2981,8 @@
         </p:nvSpPr>
         <p:spPr>
           <a:xfrm>
-            <a:off x="685800" y="475488"/>
-            <a:ext cx="7315200" cy="274320"/>
+            <a:off x="685800" y="502920"/>
+            <a:ext cx="9144000" cy="274320"/>
           </a:xfrm>
           <a:prstGeom prst="rect">
             <a:avLst/>
@@ -2965,8 +3020,8 @@
         </p:nvSpPr>
         <p:spPr>
           <a:xfrm>
-            <a:off x="685800" y="804672"/>
-            <a:ext cx="10817352" cy="868680"/>
+            <a:off x="685800" y="914400"/>
+            <a:ext cx="10607040" cy="822960"/>
           </a:xfrm>
           <a:prstGeom prst="rect">
             <a:avLst/>
@@ -2990,7 +3045,7 @@
                 <a:ea typeface="Cambria" pitchFamily="34" charset="-122"/>
                 <a:cs typeface="Cambria" pitchFamily="34" charset="-120"/>
               </a:rPr>
-              <a:t>The same house, one generation apart</a:t>
+              <a:t>One generation apart</a:t>
             </a:r>
             <a:endParaRPr lang="en-US" sz="4000" dirty="0"/>
           </a:p>
@@ -3004,12 +3059,12 @@
         </p:nvSpPr>
         <p:spPr>
           <a:xfrm>
-            <a:off x="685800" y="2103120"/>
-            <a:ext cx="4951476" cy="2011680"/>
+            <a:off x="685800" y="2240280"/>
+            <a:ext cx="4951476" cy="2148840"/>
           </a:xfrm>
           <a:prstGeom prst="roundRect">
             <a:avLst>
-              <a:gd name="adj" fmla="val 6364"/>
+              <a:gd name="adj" fmla="val 5957"/>
             </a:avLst>
           </a:prstGeom>
           <a:solidFill>
@@ -3031,8 +3086,8 @@
         </p:nvSpPr>
         <p:spPr>
           <a:xfrm>
-            <a:off x="1097280" y="2359152"/>
-            <a:ext cx="2743200" cy="320040"/>
+            <a:off x="1097280" y="2532888"/>
+            <a:ext cx="2743200" cy="347472"/>
           </a:xfrm>
           <a:prstGeom prst="rect">
             <a:avLst/>
@@ -3048,7 +3103,7 @@
               <a:buNone/>
             </a:pPr>
             <a:r>
-              <a:rPr lang="en-US" sz="1500" b="1" dirty="0">
+              <a:rPr lang="en-US" sz="1600" b="1" dirty="0">
                 <a:solidFill>
                   <a:srgbClr val="5C6F66"/>
                 </a:solidFill>
@@ -3058,7 +3113,7 @@
               </a:rPr>
               <a:t>2006</a:t>
             </a:r>
-            <a:endParaRPr lang="en-US" sz="1500" dirty="0"/>
+            <a:endParaRPr lang="en-US" sz="1600" dirty="0"/>
           </a:p>
         </p:txBody>
       </p:sp>
@@ -3070,8 +3125,8 @@
         </p:nvSpPr>
         <p:spPr>
           <a:xfrm>
-            <a:off x="1097280" y="2761488"/>
-            <a:ext cx="4023360" cy="822960"/>
+            <a:off x="1097280" y="3017520"/>
+            <a:ext cx="4114800" cy="914400"/>
           </a:xfrm>
           <a:prstGeom prst="rect">
             <a:avLst/>
@@ -3087,7 +3142,7 @@
               <a:buNone/>
             </a:pPr>
             <a:r>
-              <a:rPr lang="en-US" sz="4400" b="1" dirty="0">
+              <a:rPr lang="en-US" sz="4800" b="1" dirty="0">
                 <a:solidFill>
                   <a:srgbClr val="17302A"/>
                 </a:solidFill>
@@ -3097,63 +3152,24 @@
               </a:rPr>
               <a:t>$276,974</a:t>
             </a:r>
-            <a:endParaRPr lang="en-US" sz="4400" dirty="0"/>
-          </a:p>
-        </p:txBody>
-      </p:sp>
-      <p:sp>
-        <p:nvSpPr>
-          <p:cNvPr id="7" name="Text 5"/>
-          <p:cNvSpPr/>
-          <p:nvPr/>
-        </p:nvSpPr>
-        <p:spPr>
-          <a:xfrm>
-            <a:off x="1097280" y="3566160"/>
-            <a:ext cx="4023360" cy="320040"/>
-          </a:xfrm>
-          <a:prstGeom prst="rect">
-            <a:avLst/>
-          </a:prstGeom>
-          <a:noFill/>
-          <a:ln/>
-        </p:spPr>
-        <p:txBody>
-          <a:bodyPr wrap="square" lIns="0" tIns="0" rIns="0" bIns="0" rtlCol="0" anchor="ctr"/>
-          <a:lstStyle/>
-          <a:p>
-            <a:pPr indent="0" marL="0">
-              <a:buNone/>
-            </a:pPr>
-            <a:r>
-              <a:rPr lang="en-US" sz="1300" dirty="0">
-                <a:solidFill>
-                  <a:srgbClr val="5C6F66"/>
-                </a:solidFill>
-                <a:latin typeface="Calibri" pitchFamily="34" charset="0"/>
-                <a:ea typeface="Calibri" pitchFamily="34" charset="-122"/>
-                <a:cs typeface="Calibri" pitchFamily="34" charset="-120"/>
-              </a:rPr>
-              <a:t>average Canadian home</a:t>
-            </a:r>
-            <a:endParaRPr lang="en-US" sz="1300" dirty="0"/>
-          </a:p>
-        </p:txBody>
-      </p:sp>
-      <p:sp>
-        <p:nvSpPr>
-          <p:cNvPr id="8" name="Shape 6"/>
-          <p:cNvSpPr/>
-          <p:nvPr/>
-        </p:nvSpPr>
-        <p:spPr>
-          <a:xfrm>
-            <a:off x="6551676" y="2103120"/>
-            <a:ext cx="4951476" cy="2011680"/>
+            <a:endParaRPr lang="en-US" sz="4800" dirty="0"/>
+          </a:p>
+        </p:txBody>
+      </p:sp>
+      <p:sp>
+        <p:nvSpPr>
+          <p:cNvPr id="7" name="Shape 5"/>
+          <p:cNvSpPr/>
+          <p:nvPr/>
+        </p:nvSpPr>
+        <p:spPr>
+          <a:xfrm>
+            <a:off x="6551676" y="2240280"/>
+            <a:ext cx="4951476" cy="2148840"/>
           </a:xfrm>
           <a:prstGeom prst="roundRect">
             <a:avLst>
-              <a:gd name="adj" fmla="val 6364"/>
+              <a:gd name="adj" fmla="val 5957"/>
             </a:avLst>
           </a:prstGeom>
           <a:solidFill>
@@ -3169,14 +3185,14 @@
       </p:sp>
       <p:sp>
         <p:nvSpPr>
-          <p:cNvPr id="9" name="Text 7"/>
-          <p:cNvSpPr/>
-          <p:nvPr/>
-        </p:nvSpPr>
-        <p:spPr>
-          <a:xfrm>
-            <a:off x="6963156" y="2359152"/>
-            <a:ext cx="2743200" cy="320040"/>
+          <p:cNvPr id="8" name="Text 6"/>
+          <p:cNvSpPr/>
+          <p:nvPr/>
+        </p:nvSpPr>
+        <p:spPr>
+          <a:xfrm>
+            <a:off x="6963156" y="2532888"/>
+            <a:ext cx="2743200" cy="347472"/>
           </a:xfrm>
           <a:prstGeom prst="rect">
             <a:avLst/>
@@ -3192,7 +3208,7 @@
               <a:buNone/>
             </a:pPr>
             <a:r>
-              <a:rPr lang="en-US" sz="1500" b="1" dirty="0">
+              <a:rPr lang="en-US" sz="1600" b="1" dirty="0">
                 <a:solidFill>
                   <a:srgbClr val="E8B84B"/>
                 </a:solidFill>
@@ -3202,20 +3218,20 @@
               </a:rPr>
               <a:t>TODAY</a:t>
             </a:r>
-            <a:endParaRPr lang="en-US" sz="1500" dirty="0"/>
-          </a:p>
-        </p:txBody>
-      </p:sp>
-      <p:sp>
-        <p:nvSpPr>
-          <p:cNvPr id="10" name="Text 8"/>
-          <p:cNvSpPr/>
-          <p:nvPr/>
-        </p:nvSpPr>
-        <p:spPr>
-          <a:xfrm>
-            <a:off x="6963156" y="2761488"/>
-            <a:ext cx="4023360" cy="822960"/>
+            <a:endParaRPr lang="en-US" sz="1600" dirty="0"/>
+          </a:p>
+        </p:txBody>
+      </p:sp>
+      <p:sp>
+        <p:nvSpPr>
+          <p:cNvPr id="9" name="Text 7"/>
+          <p:cNvSpPr/>
+          <p:nvPr/>
+        </p:nvSpPr>
+        <p:spPr>
+          <a:xfrm>
+            <a:off x="6963156" y="3017520"/>
+            <a:ext cx="4114800" cy="914400"/>
           </a:xfrm>
           <a:prstGeom prst="rect">
             <a:avLst/>
@@ -3231,7 +3247,7 @@
               <a:buNone/>
             </a:pPr>
             <a:r>
-              <a:rPr lang="en-US" sz="4400" b="1" dirty="0">
+              <a:rPr lang="en-US" sz="4800" b="1" dirty="0">
                 <a:solidFill>
                   <a:srgbClr val="FFFFFF"/>
                 </a:solidFill>
@@ -3241,7 +3257,46 @@
               </a:rPr>
               <a:t>$696,078</a:t>
             </a:r>
-            <a:endParaRPr lang="en-US" sz="4400" dirty="0"/>
+            <a:endParaRPr lang="en-US" sz="4800" dirty="0"/>
+          </a:p>
+        </p:txBody>
+      </p:sp>
+      <p:sp>
+        <p:nvSpPr>
+          <p:cNvPr id="10" name="Text 8"/>
+          <p:cNvSpPr/>
+          <p:nvPr/>
+        </p:nvSpPr>
+        <p:spPr>
+          <a:xfrm>
+            <a:off x="5637276" y="3108960"/>
+            <a:ext cx="914400" cy="548640"/>
+          </a:xfrm>
+          <a:prstGeom prst="rect">
+            <a:avLst/>
+          </a:prstGeom>
+          <a:noFill/>
+          <a:ln/>
+        </p:spPr>
+        <p:txBody>
+          <a:bodyPr wrap="square" lIns="0" tIns="0" rIns="0" bIns="0" rtlCol="0" anchor="ctr"/>
+          <a:lstStyle/>
+          <a:p>
+            <a:pPr algn="ctr" indent="0" marL="0">
+              <a:buNone/>
+            </a:pPr>
+            <a:r>
+              <a:rPr lang="en-US" sz="2600" b="1" dirty="0">
+                <a:solidFill>
+                  <a:srgbClr val="3FA672"/>
+                </a:solidFill>
+                <a:latin typeface="Cambria" pitchFamily="34" charset="0"/>
+                <a:ea typeface="Cambria" pitchFamily="34" charset="-122"/>
+                <a:cs typeface="Cambria" pitchFamily="34" charset="-120"/>
+              </a:rPr>
+              <a:t>2.5×</a:t>
+            </a:r>
+            <a:endParaRPr lang="en-US" sz="2600" dirty="0"/>
           </a:p>
         </p:txBody>
       </p:sp>
@@ -3253,8 +3308,8 @@
         </p:nvSpPr>
         <p:spPr>
           <a:xfrm>
-            <a:off x="6963156" y="3566160"/>
-            <a:ext cx="4023360" cy="320040"/>
+            <a:off x="685800" y="4709160"/>
+            <a:ext cx="10607040" cy="365760"/>
           </a:xfrm>
           <a:prstGeom prst="rect">
             <a:avLst/>
@@ -3270,140 +3325,23 @@
               <a:buNone/>
             </a:pPr>
             <a:r>
-              <a:rPr lang="en-US" sz="1300" dirty="0">
-                <a:solidFill>
-                  <a:srgbClr val="E3F2E9"/>
+              <a:rPr lang="en-US" sz="1500" dirty="0">
+                <a:solidFill>
+                  <a:srgbClr val="5C6F66"/>
                 </a:solidFill>
                 <a:latin typeface="Calibri" pitchFamily="34" charset="0"/>
                 <a:ea typeface="Calibri" pitchFamily="34" charset="-122"/>
                 <a:cs typeface="Calibri" pitchFamily="34" charset="-120"/>
               </a:rPr>
-              <a:t>average Canadian home</a:t>
-            </a:r>
-            <a:endParaRPr lang="en-US" sz="1300" dirty="0"/>
+              <a:t>Average Canadian home</a:t>
+            </a:r>
+            <a:endParaRPr lang="en-US" sz="1500" dirty="0"/>
           </a:p>
         </p:txBody>
       </p:sp>
       <p:sp>
         <p:nvSpPr>
           <p:cNvPr id="12" name="Text 10"/>
-          <p:cNvSpPr/>
-          <p:nvPr/>
-        </p:nvSpPr>
-        <p:spPr>
-          <a:xfrm>
-            <a:off x="5637276" y="2834640"/>
-            <a:ext cx="914400" cy="548640"/>
-          </a:xfrm>
-          <a:prstGeom prst="rect">
-            <a:avLst/>
-          </a:prstGeom>
-          <a:noFill/>
-          <a:ln/>
-        </p:spPr>
-        <p:txBody>
-          <a:bodyPr wrap="square" lIns="0" tIns="0" rIns="0" bIns="0" rtlCol="0" anchor="ctr"/>
-          <a:lstStyle/>
-          <a:p>
-            <a:pPr algn="ctr" indent="0" marL="0">
-              <a:buNone/>
-            </a:pPr>
-            <a:r>
-              <a:rPr lang="en-US" sz="2400" b="1" dirty="0">
-                <a:solidFill>
-                  <a:srgbClr val="3FA672"/>
-                </a:solidFill>
-                <a:latin typeface="Cambria" pitchFamily="34" charset="0"/>
-                <a:ea typeface="Cambria" pitchFamily="34" charset="-122"/>
-                <a:cs typeface="Cambria" pitchFamily="34" charset="-120"/>
-              </a:rPr>
-              <a:t>2.5×</a:t>
-            </a:r>
-            <a:endParaRPr lang="en-US" sz="2400" dirty="0"/>
-          </a:p>
-        </p:txBody>
-      </p:sp>
-      <p:sp>
-        <p:nvSpPr>
-          <p:cNvPr id="13" name="Text 11"/>
-          <p:cNvSpPr/>
-          <p:nvPr/>
-        </p:nvSpPr>
-        <p:spPr>
-          <a:xfrm>
-            <a:off x="685800" y="4663440"/>
-            <a:ext cx="10607040" cy="548640"/>
-          </a:xfrm>
-          <a:prstGeom prst="rect">
-            <a:avLst/>
-          </a:prstGeom>
-          <a:noFill/>
-          <a:ln/>
-        </p:spPr>
-        <p:txBody>
-          <a:bodyPr wrap="square" lIns="0" tIns="0" rIns="0" bIns="0" rtlCol="0" anchor="ctr"/>
-          <a:lstStyle/>
-          <a:p>
-            <a:pPr indent="0" marL="0">
-              <a:buNone/>
-            </a:pPr>
-            <a:r>
-              <a:rPr lang="en-US" sz="2400" i="1" dirty="0">
-                <a:solidFill>
-                  <a:srgbClr val="1E4D3B"/>
-                </a:solidFill>
-                <a:latin typeface="Cambria" pitchFamily="34" charset="0"/>
-                <a:ea typeface="Cambria" pitchFamily="34" charset="-122"/>
-                <a:cs typeface="Cambria" pitchFamily="34" charset="-120"/>
-              </a:rPr>
-              <a:t>If it was that hard for me — what is it for someone starting now?</a:t>
-            </a:r>
-            <a:endParaRPr lang="en-US" sz="2400" dirty="0"/>
-          </a:p>
-        </p:txBody>
-      </p:sp>
-      <p:sp>
-        <p:nvSpPr>
-          <p:cNvPr id="14" name="Text 12"/>
-          <p:cNvSpPr/>
-          <p:nvPr/>
-        </p:nvSpPr>
-        <p:spPr>
-          <a:xfrm>
-            <a:off x="685800" y="5303520"/>
-            <a:ext cx="10607040" cy="457200"/>
-          </a:xfrm>
-          <a:prstGeom prst="rect">
-            <a:avLst/>
-          </a:prstGeom>
-          <a:noFill/>
-          <a:ln/>
-        </p:spPr>
-        <p:txBody>
-          <a:bodyPr wrap="square" lIns="0" tIns="0" rIns="0" bIns="0" rtlCol="0" anchor="ctr"/>
-          <a:lstStyle/>
-          <a:p>
-            <a:pPr indent="0" marL="0">
-              <a:buNone/>
-            </a:pPr>
-            <a:r>
-              <a:rPr lang="en-US" sz="1600" dirty="0">
-                <a:solidFill>
-                  <a:srgbClr val="5C6F66"/>
-                </a:solidFill>
-                <a:latin typeface="Calibri" pitchFamily="34" charset="0"/>
-                <a:ea typeface="Calibri" pitchFamily="34" charset="-122"/>
-                <a:cs typeface="Calibri" pitchFamily="34" charset="-120"/>
-              </a:rPr>
-              <a:t>Most of you in this room bought somewhere inside that gap too.</a:t>
-            </a:r>
-            <a:endParaRPr lang="en-US" sz="1600" dirty="0"/>
-          </a:p>
-        </p:txBody>
-      </p:sp>
-      <p:sp>
-        <p:nvSpPr>
-          <p:cNvPr id="15" name="Text 13"/>
           <p:cNvSpPr/>
           <p:nvPr/>
         </p:nvSpPr>
@@ -3480,8 +3418,8 @@
         </p:nvSpPr>
         <p:spPr>
           <a:xfrm>
-            <a:off x="685800" y="475488"/>
-            <a:ext cx="7315200" cy="274320"/>
+            <a:off x="685800" y="502920"/>
+            <a:ext cx="9144000" cy="274320"/>
           </a:xfrm>
           <a:prstGeom prst="rect">
             <a:avLst/>
@@ -3519,8 +3457,8 @@
         </p:nvSpPr>
         <p:spPr>
           <a:xfrm>
-            <a:off x="685800" y="804672"/>
-            <a:ext cx="10817352" cy="868680"/>
+            <a:off x="685800" y="914400"/>
+            <a:ext cx="10607040" cy="822960"/>
           </a:xfrm>
           <a:prstGeom prst="rect">
             <a:avLst/>
@@ -3558,8 +3496,8 @@
         </p:nvSpPr>
         <p:spPr>
           <a:xfrm>
-            <a:off x="685800" y="2011680"/>
-            <a:ext cx="566928" cy="566928"/>
+            <a:off x="685800" y="2331720"/>
+            <a:ext cx="640080" cy="640080"/>
           </a:xfrm>
           <a:prstGeom prst="ellipse">
             <a:avLst/>
@@ -3583,8 +3521,8 @@
         </p:nvSpPr>
         <p:spPr>
           <a:xfrm>
-            <a:off x="685800" y="2011680"/>
-            <a:ext cx="566928" cy="566928"/>
+            <a:off x="685800" y="2331720"/>
+            <a:ext cx="640080" cy="640080"/>
           </a:xfrm>
           <a:prstGeom prst="rect">
             <a:avLst/>
@@ -3600,7 +3538,7 @@
               <a:buNone/>
             </a:pPr>
             <a:r>
-              <a:rPr lang="en-US" sz="2200" b="1" dirty="0">
+              <a:rPr lang="en-US" sz="2400" b="1" dirty="0">
                 <a:solidFill>
                   <a:srgbClr val="E8B84B"/>
                 </a:solidFill>
@@ -3610,7 +3548,7 @@
               </a:rPr>
               <a:t>1</a:t>
             </a:r>
-            <a:endParaRPr lang="en-US" sz="2200" dirty="0"/>
+            <a:endParaRPr lang="en-US" sz="2400" dirty="0"/>
           </a:p>
         </p:txBody>
       </p:sp>
@@ -3622,8 +3560,8 @@
         </p:nvSpPr>
         <p:spPr>
           <a:xfrm>
-            <a:off x="1554480" y="1965960"/>
-            <a:ext cx="3657600" cy="411480"/>
+            <a:off x="1645920" y="2377440"/>
+            <a:ext cx="5852160" cy="548640"/>
           </a:xfrm>
           <a:prstGeom prst="rect">
             <a:avLst/>
@@ -3639,7 +3577,7 @@
               <a:buNone/>
             </a:pPr>
             <a:r>
-              <a:rPr lang="en-US" sz="2100" b="1" dirty="0">
+              <a:rPr lang="en-US" sz="2800" b="1" dirty="0">
                 <a:solidFill>
                   <a:srgbClr val="17302A"/>
                 </a:solidFill>
@@ -3647,64 +3585,22 @@
                 <a:ea typeface="Cambria" pitchFamily="34" charset="-122"/>
                 <a:cs typeface="Cambria" pitchFamily="34" charset="-120"/>
               </a:rPr>
-              <a:t>Tell it three things</a:t>
-            </a:r>
-            <a:endParaRPr lang="en-US" sz="2100" dirty="0"/>
-          </a:p>
-        </p:txBody>
-      </p:sp>
-      <p:sp>
-        <p:nvSpPr>
-          <p:cNvPr id="7" name="Text 5"/>
-          <p:cNvSpPr/>
-          <p:nvPr/>
-        </p:nvSpPr>
-        <p:spPr>
-          <a:xfrm>
-            <a:off x="1554480" y="2423160"/>
-            <a:ext cx="6309360" cy="731520"/>
-          </a:xfrm>
-          <a:prstGeom prst="rect">
-            <a:avLst/>
-          </a:prstGeom>
-          <a:noFill/>
-          <a:ln/>
-        </p:spPr>
-        <p:txBody>
-          <a:bodyPr wrap="square" lIns="0" tIns="0" rIns="0" bIns="0" rtlCol="0" anchor="ctr"/>
-          <a:lstStyle/>
-          <a:p>
-            <a:pPr indent="0" marL="0">
-              <a:lnSpc>
-                <a:spcPts val="2000"/>
-              </a:lnSpc>
-              <a:buNone/>
-            </a:pPr>
-            <a:r>
-              <a:rPr lang="en-US" sz="1450" dirty="0">
-                <a:solidFill>
-                  <a:srgbClr val="5C6F66"/>
-                </a:solidFill>
-                <a:latin typeface="Calibri" pitchFamily="34" charset="0"/>
-                <a:ea typeface="Calibri" pitchFamily="34" charset="-122"/>
-                <a:cs typeface="Calibri" pitchFamily="34" charset="-120"/>
-              </a:rPr>
-              <a:t>Your income, what you’ve saved, and what you can put away each month.</a:t>
-            </a:r>
-            <a:endParaRPr lang="en-US" sz="1450" dirty="0"/>
-          </a:p>
-        </p:txBody>
-      </p:sp>
-      <p:sp>
-        <p:nvSpPr>
-          <p:cNvPr id="8" name="Shape 6"/>
-          <p:cNvSpPr/>
-          <p:nvPr/>
-        </p:nvSpPr>
-        <p:spPr>
-          <a:xfrm>
-            <a:off x="685800" y="3383280"/>
-            <a:ext cx="566928" cy="566928"/>
+              <a:t>Three questions</a:t>
+            </a:r>
+            <a:endParaRPr lang="en-US" sz="2800" dirty="0"/>
+          </a:p>
+        </p:txBody>
+      </p:sp>
+      <p:sp>
+        <p:nvSpPr>
+          <p:cNvPr id="7" name="Shape 5"/>
+          <p:cNvSpPr/>
+          <p:nvPr/>
+        </p:nvSpPr>
+        <p:spPr>
+          <a:xfrm>
+            <a:off x="685800" y="3429000"/>
+            <a:ext cx="640080" cy="640080"/>
           </a:xfrm>
           <a:prstGeom prst="ellipse">
             <a:avLst/>
@@ -3722,14 +3618,14 @@
       </p:sp>
       <p:sp>
         <p:nvSpPr>
-          <p:cNvPr id="9" name="Text 7"/>
-          <p:cNvSpPr/>
-          <p:nvPr/>
-        </p:nvSpPr>
-        <p:spPr>
-          <a:xfrm>
-            <a:off x="685800" y="3383280"/>
-            <a:ext cx="566928" cy="566928"/>
+          <p:cNvPr id="8" name="Text 6"/>
+          <p:cNvSpPr/>
+          <p:nvPr/>
+        </p:nvSpPr>
+        <p:spPr>
+          <a:xfrm>
+            <a:off x="685800" y="3429000"/>
+            <a:ext cx="640080" cy="640080"/>
           </a:xfrm>
           <a:prstGeom prst="rect">
             <a:avLst/>
@@ -3745,7 +3641,7 @@
               <a:buNone/>
             </a:pPr>
             <a:r>
-              <a:rPr lang="en-US" sz="2200" b="1" dirty="0">
+              <a:rPr lang="en-US" sz="2400" b="1" dirty="0">
                 <a:solidFill>
                   <a:srgbClr val="E8B84B"/>
                 </a:solidFill>
@@ -3755,20 +3651,20 @@
               </a:rPr>
               <a:t>2</a:t>
             </a:r>
-            <a:endParaRPr lang="en-US" sz="2200" dirty="0"/>
-          </a:p>
-        </p:txBody>
-      </p:sp>
-      <p:sp>
-        <p:nvSpPr>
-          <p:cNvPr id="10" name="Text 8"/>
-          <p:cNvSpPr/>
-          <p:nvPr/>
-        </p:nvSpPr>
-        <p:spPr>
-          <a:xfrm>
-            <a:off x="1554480" y="3337560"/>
-            <a:ext cx="3657600" cy="411480"/>
+            <a:endParaRPr lang="en-US" sz="2400" dirty="0"/>
+          </a:p>
+        </p:txBody>
+      </p:sp>
+      <p:sp>
+        <p:nvSpPr>
+          <p:cNvPr id="9" name="Text 7"/>
+          <p:cNvSpPr/>
+          <p:nvPr/>
+        </p:nvSpPr>
+        <p:spPr>
+          <a:xfrm>
+            <a:off x="1645920" y="3474720"/>
+            <a:ext cx="5852160" cy="548640"/>
           </a:xfrm>
           <a:prstGeom prst="rect">
             <a:avLst/>
@@ -3784,7 +3680,7 @@
               <a:buNone/>
             </a:pPr>
             <a:r>
-              <a:rPr lang="en-US" sz="2100" b="1" dirty="0">
+              <a:rPr lang="en-US" sz="2800" b="1" dirty="0">
                 <a:solidFill>
                   <a:srgbClr val="17302A"/>
                 </a:solidFill>
@@ -3792,64 +3688,22 @@
                 <a:ea typeface="Cambria" pitchFamily="34" charset="-122"/>
                 <a:cs typeface="Cambria" pitchFamily="34" charset="-120"/>
               </a:rPr>
-              <a:t>Get a date</a:t>
-            </a:r>
-            <a:endParaRPr lang="en-US" sz="2100" dirty="0"/>
-          </a:p>
-        </p:txBody>
-      </p:sp>
-      <p:sp>
-        <p:nvSpPr>
-          <p:cNvPr id="11" name="Text 9"/>
-          <p:cNvSpPr/>
-          <p:nvPr/>
-        </p:nvSpPr>
-        <p:spPr>
-          <a:xfrm>
-            <a:off x="1554480" y="3794760"/>
-            <a:ext cx="6309360" cy="731520"/>
-          </a:xfrm>
-          <a:prstGeom prst="rect">
-            <a:avLst/>
-          </a:prstGeom>
-          <a:noFill/>
-          <a:ln/>
-        </p:spPr>
-        <p:txBody>
-          <a:bodyPr wrap="square" lIns="0" tIns="0" rIns="0" bIns="0" rtlCol="0" anchor="ctr"/>
-          <a:lstStyle/>
-          <a:p>
-            <a:pPr indent="0" marL="0">
-              <a:lnSpc>
-                <a:spcPts val="2000"/>
-              </a:lnSpc>
-              <a:buNone/>
-            </a:pPr>
-            <a:r>
-              <a:rPr lang="en-US" sz="1450" dirty="0">
-                <a:solidFill>
-                  <a:srgbClr val="5C6F66"/>
-                </a:solidFill>
-                <a:latin typeface="Calibri" pitchFamily="34" charset="0"/>
-                <a:ea typeface="Calibri" pitchFamily="34" charset="-122"/>
-                <a:cs typeface="Calibri" pitchFamily="34" charset="-120"/>
-              </a:rPr>
-              <a:t>Not a maybe — a month. Built on the actual Canadian rules: FHSA, Home Buyers’ Plan, the stress test.</a:t>
-            </a:r>
-            <a:endParaRPr lang="en-US" sz="1450" dirty="0"/>
-          </a:p>
-        </p:txBody>
-      </p:sp>
-      <p:sp>
-        <p:nvSpPr>
-          <p:cNvPr id="12" name="Shape 10"/>
-          <p:cNvSpPr/>
-          <p:nvPr/>
-        </p:nvSpPr>
-        <p:spPr>
-          <a:xfrm>
-            <a:off x="685800" y="4754880"/>
-            <a:ext cx="566928" cy="566928"/>
+              <a:t>A real month</a:t>
+            </a:r>
+            <a:endParaRPr lang="en-US" sz="2800" dirty="0"/>
+          </a:p>
+        </p:txBody>
+      </p:sp>
+      <p:sp>
+        <p:nvSpPr>
+          <p:cNvPr id="10" name="Shape 8"/>
+          <p:cNvSpPr/>
+          <p:nvPr/>
+        </p:nvSpPr>
+        <p:spPr>
+          <a:xfrm>
+            <a:off x="685800" y="4526280"/>
+            <a:ext cx="640080" cy="640080"/>
           </a:xfrm>
           <a:prstGeom prst="ellipse">
             <a:avLst/>
@@ -3867,14 +3721,14 @@
       </p:sp>
       <p:sp>
         <p:nvSpPr>
-          <p:cNvPr id="13" name="Text 11"/>
-          <p:cNvSpPr/>
-          <p:nvPr/>
-        </p:nvSpPr>
-        <p:spPr>
-          <a:xfrm>
-            <a:off x="685800" y="4754880"/>
-            <a:ext cx="566928" cy="566928"/>
+          <p:cNvPr id="11" name="Text 9"/>
+          <p:cNvSpPr/>
+          <p:nvPr/>
+        </p:nvSpPr>
+        <p:spPr>
+          <a:xfrm>
+            <a:off x="685800" y="4526280"/>
+            <a:ext cx="640080" cy="640080"/>
           </a:xfrm>
           <a:prstGeom prst="rect">
             <a:avLst/>
@@ -3890,7 +3744,7 @@
               <a:buNone/>
             </a:pPr>
             <a:r>
-              <a:rPr lang="en-US" sz="2200" b="1" dirty="0">
+              <a:rPr lang="en-US" sz="2400" b="1" dirty="0">
                 <a:solidFill>
                   <a:srgbClr val="E8B84B"/>
                 </a:solidFill>
@@ -3900,20 +3754,20 @@
               </a:rPr>
               <a:t>3</a:t>
             </a:r>
-            <a:endParaRPr lang="en-US" sz="2200" dirty="0"/>
-          </a:p>
-        </p:txBody>
-      </p:sp>
-      <p:sp>
-        <p:nvSpPr>
-          <p:cNvPr id="14" name="Text 12"/>
-          <p:cNvSpPr/>
-          <p:nvPr/>
-        </p:nvSpPr>
-        <p:spPr>
-          <a:xfrm>
-            <a:off x="1554480" y="4709160"/>
-            <a:ext cx="3657600" cy="411480"/>
+            <a:endParaRPr lang="en-US" sz="2400" dirty="0"/>
+          </a:p>
+        </p:txBody>
+      </p:sp>
+      <p:sp>
+        <p:nvSpPr>
+          <p:cNvPr id="12" name="Text 10"/>
+          <p:cNvSpPr/>
+          <p:nvPr/>
+        </p:nvSpPr>
+        <p:spPr>
+          <a:xfrm>
+            <a:off x="1645920" y="4572000"/>
+            <a:ext cx="5852160" cy="548640"/>
           </a:xfrm>
           <a:prstGeom prst="rect">
             <a:avLst/>
@@ -3929,7 +3783,7 @@
               <a:buNone/>
             </a:pPr>
             <a:r>
-              <a:rPr lang="en-US" sz="2100" b="1" dirty="0">
+              <a:rPr lang="en-US" sz="2800" b="1" dirty="0">
                 <a:solidFill>
                   <a:srgbClr val="17302A"/>
                 </a:solidFill>
@@ -3939,66 +3793,24 @@
               </a:rPr>
               <a:t>Watch it get closer</a:t>
             </a:r>
-            <a:endParaRPr lang="en-US" sz="2100" dirty="0"/>
-          </a:p>
-        </p:txBody>
-      </p:sp>
-      <p:sp>
-        <p:nvSpPr>
-          <p:cNvPr id="15" name="Text 13"/>
-          <p:cNvSpPr/>
-          <p:nvPr/>
-        </p:nvSpPr>
-        <p:spPr>
-          <a:xfrm>
-            <a:off x="1554480" y="5166360"/>
-            <a:ext cx="6309360" cy="731520"/>
-          </a:xfrm>
-          <a:prstGeom prst="rect">
-            <a:avLst/>
-          </a:prstGeom>
-          <a:noFill/>
-          <a:ln/>
-        </p:spPr>
-        <p:txBody>
-          <a:bodyPr wrap="square" lIns="0" tIns="0" rIns="0" bIns="0" rtlCol="0" anchor="ctr"/>
-          <a:lstStyle/>
-          <a:p>
-            <a:pPr indent="0" marL="0">
-              <a:lnSpc>
-                <a:spcPts val="2000"/>
-              </a:lnSpc>
-              <a:buNone/>
-            </a:pPr>
-            <a:r>
-              <a:rPr lang="en-US" sz="1450" dirty="0">
-                <a:solidFill>
-                  <a:srgbClr val="5C6F66"/>
-                </a:solidFill>
-                <a:latin typeface="Calibri" pitchFamily="34" charset="0"/>
-                <a:ea typeface="Calibri" pitchFamily="34" charset="-122"/>
-                <a:cs typeface="Calibri" pitchFamily="34" charset="-120"/>
-              </a:rPr>
-              <a:t>Every dollar you save builds your house on screen, piece by piece.</a:t>
-            </a:r>
-            <a:endParaRPr lang="en-US" sz="1450" dirty="0"/>
-          </a:p>
-        </p:txBody>
-      </p:sp>
-      <p:sp>
-        <p:nvSpPr>
-          <p:cNvPr id="16" name="Shape 14"/>
-          <p:cNvSpPr/>
-          <p:nvPr/>
-        </p:nvSpPr>
-        <p:spPr>
-          <a:xfrm>
-            <a:off x="8138160" y="1965960"/>
-            <a:ext cx="3364992" cy="3657600"/>
+            <a:endParaRPr lang="en-US" sz="2800" dirty="0"/>
+          </a:p>
+        </p:txBody>
+      </p:sp>
+      <p:sp>
+        <p:nvSpPr>
+          <p:cNvPr id="13" name="Shape 11"/>
+          <p:cNvSpPr/>
+          <p:nvPr/>
+        </p:nvSpPr>
+        <p:spPr>
+          <a:xfrm>
+            <a:off x="8138160" y="2148840"/>
+            <a:ext cx="3364992" cy="3246120"/>
           </a:xfrm>
           <a:prstGeom prst="roundRect">
             <a:avLst>
-              <a:gd name="adj" fmla="val 4891"/>
+              <a:gd name="adj" fmla="val 5070"/>
             </a:avLst>
           </a:prstGeom>
           <a:solidFill>
@@ -4014,13 +3826,13 @@
       </p:sp>
       <p:sp>
         <p:nvSpPr>
-          <p:cNvPr id="17" name="Text 15"/>
-          <p:cNvSpPr/>
-          <p:nvPr/>
-        </p:nvSpPr>
-        <p:spPr>
-          <a:xfrm>
-            <a:off x="8458200" y="2395728"/>
+          <p:cNvPr id="14" name="Text 12"/>
+          <p:cNvSpPr/>
+          <p:nvPr/>
+        </p:nvSpPr>
+        <p:spPr>
+          <a:xfrm>
+            <a:off x="8458200" y="2560320"/>
             <a:ext cx="2743200" cy="274320"/>
           </a:xfrm>
           <a:prstGeom prst="rect">
@@ -4053,14 +3865,14 @@
       </p:sp>
       <p:sp>
         <p:nvSpPr>
-          <p:cNvPr id="18" name="Text 16"/>
-          <p:cNvSpPr/>
-          <p:nvPr/>
-        </p:nvSpPr>
-        <p:spPr>
-          <a:xfrm>
-            <a:off x="8458200" y="2761488"/>
-            <a:ext cx="2743200" cy="777240"/>
+          <p:cNvPr id="15" name="Text 13"/>
+          <p:cNvSpPr/>
+          <p:nvPr/>
+        </p:nvSpPr>
+        <p:spPr>
+          <a:xfrm>
+            <a:off x="8458200" y="2926080"/>
+            <a:ext cx="2834640" cy="822960"/>
           </a:xfrm>
           <a:prstGeom prst="rect">
             <a:avLst/>
@@ -4076,7 +3888,7 @@
               <a:buNone/>
             </a:pPr>
             <a:r>
-              <a:rPr lang="en-US" sz="3600" b="1" dirty="0">
+              <a:rPr lang="en-US" sz="3800" b="1" dirty="0">
                 <a:solidFill>
                   <a:srgbClr val="FFFFFF"/>
                 </a:solidFill>
@@ -4086,58 +3898,19 @@
               </a:rPr>
               <a:t>June 2029</a:t>
             </a:r>
-            <a:endParaRPr lang="en-US" sz="3600" dirty="0"/>
-          </a:p>
-        </p:txBody>
-      </p:sp>
-      <p:sp>
-        <p:nvSpPr>
-          <p:cNvPr id="19" name="Text 17"/>
-          <p:cNvSpPr/>
-          <p:nvPr/>
-        </p:nvSpPr>
-        <p:spPr>
-          <a:xfrm>
-            <a:off x="8458200" y="3584448"/>
-            <a:ext cx="2834640" cy="320040"/>
-          </a:xfrm>
-          <a:prstGeom prst="rect">
-            <a:avLst/>
-          </a:prstGeom>
-          <a:noFill/>
-          <a:ln/>
-        </p:spPr>
-        <p:txBody>
-          <a:bodyPr wrap="square" lIns="0" tIns="0" rIns="0" bIns="0" rtlCol="0" anchor="ctr"/>
-          <a:lstStyle/>
-          <a:p>
-            <a:pPr indent="0" marL="0">
-              <a:buNone/>
-            </a:pPr>
-            <a:r>
-              <a:rPr lang="en-US" sz="1200" dirty="0">
-                <a:solidFill>
-                  <a:srgbClr val="E3F2E9"/>
-                </a:solidFill>
-                <a:latin typeface="Calibri" pitchFamily="34" charset="0"/>
-                <a:ea typeface="Calibri" pitchFamily="34" charset="-122"/>
-                <a:cs typeface="Calibri" pitchFamily="34" charset="-120"/>
-              </a:rPr>
-              <a:t>likely window · Apr – Sep 2029</a:t>
-            </a:r>
-            <a:endParaRPr lang="en-US" sz="1200" dirty="0"/>
-          </a:p>
-        </p:txBody>
-      </p:sp>
-      <p:sp>
-        <p:nvSpPr>
-          <p:cNvPr id="20" name="Shape 18"/>
-          <p:cNvSpPr/>
-          <p:nvPr/>
-        </p:nvSpPr>
-        <p:spPr>
-          <a:xfrm>
-            <a:off x="8458200" y="4160520"/>
+            <a:endParaRPr lang="en-US" sz="3800" dirty="0"/>
+          </a:p>
+        </p:txBody>
+      </p:sp>
+      <p:sp>
+        <p:nvSpPr>
+          <p:cNvPr id="16" name="Shape 14"/>
+          <p:cNvSpPr/>
+          <p:nvPr/>
+        </p:nvSpPr>
+        <p:spPr>
+          <a:xfrm>
+            <a:off x="8458200" y="3977640"/>
             <a:ext cx="2743200" cy="256032"/>
           </a:xfrm>
           <a:prstGeom prst="roundRect">
@@ -4158,13 +3931,13 @@
       </p:sp>
       <p:sp>
         <p:nvSpPr>
-          <p:cNvPr id="21" name="Shape 19"/>
-          <p:cNvSpPr/>
-          <p:nvPr/>
-        </p:nvSpPr>
-        <p:spPr>
-          <a:xfrm>
-            <a:off x="8458200" y="4160520"/>
+          <p:cNvPr id="17" name="Shape 15"/>
+          <p:cNvSpPr/>
+          <p:nvPr/>
+        </p:nvSpPr>
+        <p:spPr>
+          <a:xfrm>
+            <a:off x="8458200" y="3977640"/>
             <a:ext cx="1591056" cy="256032"/>
           </a:xfrm>
           <a:prstGeom prst="roundRect">
@@ -4185,13 +3958,13 @@
       </p:sp>
       <p:sp>
         <p:nvSpPr>
-          <p:cNvPr id="22" name="Text 20"/>
-          <p:cNvSpPr/>
-          <p:nvPr/>
-        </p:nvSpPr>
-        <p:spPr>
-          <a:xfrm>
-            <a:off x="8458200" y="4526280"/>
+          <p:cNvPr id="18" name="Text 16"/>
+          <p:cNvSpPr/>
+          <p:nvPr/>
+        </p:nvSpPr>
+        <p:spPr>
+          <a:xfrm>
+            <a:off x="8458200" y="4370832"/>
             <a:ext cx="2834640" cy="320040"/>
           </a:xfrm>
           <a:prstGeom prst="rect">
@@ -4208,7 +3981,7 @@
               <a:buNone/>
             </a:pPr>
             <a:r>
-              <a:rPr lang="en-US" sz="1200" dirty="0">
+              <a:rPr lang="en-US" sz="1300" dirty="0">
                 <a:solidFill>
                   <a:srgbClr val="E3F2E9"/>
                 </a:solidFill>
@@ -4216,9 +3989,9 @@
                 <a:ea typeface="Calibri" pitchFamily="34" charset="-122"/>
                 <a:cs typeface="Calibri" pitchFamily="34" charset="-120"/>
               </a:rPr>
-              <a:t>$41K saved  ·  58% of the way there</a:t>
-            </a:r>
-            <a:endParaRPr lang="en-US" sz="1200" dirty="0"/>
+              <a:t>58% of the way there</a:t>
+            </a:r>
+            <a:endParaRPr lang="en-US" sz="1300" dirty="0"/>
           </a:p>
         </p:txBody>
       </p:sp>
@@ -4262,8 +4035,8 @@
         </p:nvSpPr>
         <p:spPr>
           <a:xfrm>
-            <a:off x="685800" y="475488"/>
-            <a:ext cx="7315200" cy="274320"/>
+            <a:off x="685800" y="502920"/>
+            <a:ext cx="9144000" cy="274320"/>
           </a:xfrm>
           <a:prstGeom prst="rect">
             <a:avLst/>
@@ -4301,8 +4074,8 @@
         </p:nvSpPr>
         <p:spPr>
           <a:xfrm>
-            <a:off x="685800" y="804672"/>
-            <a:ext cx="10817352" cy="868680"/>
+            <a:off x="685800" y="914400"/>
+            <a:ext cx="10607040" cy="822960"/>
           </a:xfrm>
           <a:prstGeom prst="rect">
             <a:avLst/>
@@ -4340,12 +4113,12 @@
         </p:nvSpPr>
         <p:spPr>
           <a:xfrm>
-            <a:off x="685800" y="2057400"/>
-            <a:ext cx="5074920" cy="2880360"/>
+            <a:off x="685800" y="2286000"/>
+            <a:ext cx="5074920" cy="2743200"/>
           </a:xfrm>
           <a:prstGeom prst="roundRect">
             <a:avLst>
-              <a:gd name="adj" fmla="val 5079"/>
+              <a:gd name="adj" fmla="val 5333"/>
             </a:avLst>
           </a:prstGeom>
           <a:solidFill>
@@ -4367,7 +4140,7 @@
         </p:nvSpPr>
         <p:spPr>
           <a:xfrm>
-            <a:off x="1097280" y="2377440"/>
+            <a:off x="1143000" y="2651760"/>
             <a:ext cx="4206240" cy="274320"/>
           </a:xfrm>
           <a:prstGeom prst="rect">
@@ -4406,8 +4179,8 @@
         </p:nvSpPr>
         <p:spPr>
           <a:xfrm>
-            <a:off x="1097280" y="2743200"/>
-            <a:ext cx="4297680" cy="1097280"/>
+            <a:off x="1143000" y="3063240"/>
+            <a:ext cx="4297680" cy="640080"/>
           </a:xfrm>
           <a:prstGeom prst="rect">
             <a:avLst/>
@@ -4420,13 +4193,10 @@
           <a:lstStyle/>
           <a:p>
             <a:pPr indent="0" marL="0">
-              <a:lnSpc>
-                <a:spcPts val="3400"/>
-              </a:lnSpc>
-              <a:buNone/>
-            </a:pPr>
-            <a:r>
-              <a:rPr lang="en-US" sz="2700" b="1" dirty="0">
+              <a:buNone/>
+            </a:pPr>
+            <a:r>
+              <a:rPr lang="en-US" sz="2800" b="1" dirty="0">
                 <a:solidFill>
                   <a:srgbClr val="5C6F66"/>
                 </a:solidFill>
@@ -4434,124 +4204,65 @@
                 <a:ea typeface="Cambria" pitchFamily="34" charset="-122"/>
                 <a:cs typeface="Cambria" pitchFamily="34" charset="-120"/>
               </a:rPr>
-              <a:t>“Can you afford it</a:t>
-            </a:r>
-            <a:endParaRPr lang="en-US" sz="2700" dirty="0"/>
-          </a:p>
+              <a:t>“Afford it today?”</a:t>
+            </a:r>
+            <a:endParaRPr lang="en-US" sz="2800" dirty="0"/>
+          </a:p>
+        </p:txBody>
+      </p:sp>
+      <p:sp>
+        <p:nvSpPr>
+          <p:cNvPr id="7" name="Text 5"/>
+          <p:cNvSpPr/>
+          <p:nvPr/>
+        </p:nvSpPr>
+        <p:spPr>
+          <a:xfrm>
+            <a:off x="1143000" y="3977640"/>
+            <a:ext cx="4206240" cy="640080"/>
+          </a:xfrm>
+          <a:prstGeom prst="rect">
+            <a:avLst/>
+          </a:prstGeom>
+          <a:noFill/>
+          <a:ln/>
+        </p:spPr>
+        <p:txBody>
+          <a:bodyPr wrap="square" lIns="0" tIns="0" rIns="0" bIns="0" rtlCol="0" anchor="ctr"/>
+          <a:lstStyle/>
           <a:p>
             <a:pPr indent="0" marL="0">
-              <a:lnSpc>
-                <a:spcPts val="3400"/>
-              </a:lnSpc>
-              <a:buNone/>
-            </a:pPr>
-            <a:r>
-              <a:rPr lang="en-US" sz="2700" b="1" dirty="0">
-                <a:solidFill>
-                  <a:srgbClr val="5C6F66"/>
+              <a:buNone/>
+            </a:pPr>
+            <a:r>
+              <a:rPr lang="en-US" sz="4000" b="1" dirty="0">
+                <a:solidFill>
+                  <a:srgbClr val="B4452F"/>
                 </a:solidFill>
                 <a:latin typeface="Cambria" pitchFamily="34" charset="0"/>
                 <a:ea typeface="Cambria" pitchFamily="34" charset="-122"/>
                 <a:cs typeface="Cambria" pitchFamily="34" charset="-120"/>
               </a:rPr>
-              <a:t>today?”</a:t>
-            </a:r>
-            <a:endParaRPr lang="en-US" sz="2700" dirty="0"/>
-          </a:p>
-        </p:txBody>
-      </p:sp>
-      <p:sp>
-        <p:nvSpPr>
-          <p:cNvPr id="7" name="Text 5"/>
-          <p:cNvSpPr/>
-          <p:nvPr/>
-        </p:nvSpPr>
-        <p:spPr>
-          <a:xfrm>
-            <a:off x="1097280" y="3913632"/>
-            <a:ext cx="4206240" cy="548640"/>
-          </a:xfrm>
-          <a:prstGeom prst="rect">
-            <a:avLst/>
-          </a:prstGeom>
-          <a:noFill/>
-          <a:ln/>
-        </p:spPr>
-        <p:txBody>
-          <a:bodyPr wrap="square" lIns="0" tIns="0" rIns="0" bIns="0" rtlCol="0" anchor="ctr"/>
-          <a:lstStyle/>
-          <a:p>
-            <a:pPr indent="0" marL="0">
-              <a:buNone/>
-            </a:pPr>
-            <a:r>
-              <a:rPr lang="en-US" sz="3200" b="1" dirty="0">
-                <a:solidFill>
-                  <a:srgbClr val="B4452F"/>
-                </a:solidFill>
-                <a:latin typeface="Cambria" pitchFamily="34" charset="0"/>
-                <a:ea typeface="Cambria" pitchFamily="34" charset="-122"/>
-                <a:cs typeface="Cambria" pitchFamily="34" charset="-120"/>
-              </a:rPr>
               <a:t>No.</a:t>
             </a:r>
-            <a:endParaRPr lang="en-US" sz="3200" dirty="0"/>
-          </a:p>
-        </p:txBody>
-      </p:sp>
-      <p:sp>
-        <p:nvSpPr>
-          <p:cNvPr id="8" name="Text 6"/>
-          <p:cNvSpPr/>
-          <p:nvPr/>
-        </p:nvSpPr>
-        <p:spPr>
-          <a:xfrm>
-            <a:off x="1097280" y="4498848"/>
-            <a:ext cx="4297680" cy="320040"/>
-          </a:xfrm>
-          <a:prstGeom prst="rect">
-            <a:avLst/>
-          </a:prstGeom>
-          <a:noFill/>
-          <a:ln/>
-        </p:spPr>
-        <p:txBody>
-          <a:bodyPr wrap="square" lIns="0" tIns="0" rIns="0" bIns="0" rtlCol="0" anchor="ctr"/>
-          <a:lstStyle/>
-          <a:p>
-            <a:pPr indent="0" marL="0">
-              <a:buNone/>
-            </a:pPr>
-            <a:r>
-              <a:rPr lang="en-US" sz="1300" dirty="0">
-                <a:solidFill>
-                  <a:srgbClr val="5C6F66"/>
-                </a:solidFill>
-                <a:latin typeface="Calibri" pitchFamily="34" charset="0"/>
-                <a:ea typeface="Calibri" pitchFamily="34" charset="-122"/>
-                <a:cs typeface="Calibri" pitchFamily="34" charset="-120"/>
-              </a:rPr>
-              <a:t>So they close the tab, and stop saving.</a:t>
-            </a:r>
-            <a:endParaRPr lang="en-US" sz="1300" dirty="0"/>
-          </a:p>
-        </p:txBody>
-      </p:sp>
-      <p:sp>
-        <p:nvSpPr>
-          <p:cNvPr id="9" name="Shape 7"/>
-          <p:cNvSpPr/>
-          <p:nvPr/>
-        </p:nvSpPr>
-        <p:spPr>
-          <a:xfrm>
-            <a:off x="6217920" y="2057400"/>
-            <a:ext cx="5074920" cy="2880360"/>
+            <a:endParaRPr lang="en-US" sz="4000" dirty="0"/>
+          </a:p>
+        </p:txBody>
+      </p:sp>
+      <p:sp>
+        <p:nvSpPr>
+          <p:cNvPr id="8" name="Shape 6"/>
+          <p:cNvSpPr/>
+          <p:nvPr/>
+        </p:nvSpPr>
+        <p:spPr>
+          <a:xfrm>
+            <a:off x="6217920" y="2286000"/>
+            <a:ext cx="5074920" cy="2743200"/>
           </a:xfrm>
           <a:prstGeom prst="roundRect">
             <a:avLst>
-              <a:gd name="adj" fmla="val 5079"/>
+              <a:gd name="adj" fmla="val 5333"/>
             </a:avLst>
           </a:prstGeom>
           <a:solidFill>
@@ -4567,13 +4278,13 @@
       </p:sp>
       <p:sp>
         <p:nvSpPr>
-          <p:cNvPr id="10" name="Text 8"/>
-          <p:cNvSpPr/>
-          <p:nvPr/>
-        </p:nvSpPr>
-        <p:spPr>
-          <a:xfrm>
-            <a:off x="6629400" y="2377440"/>
+          <p:cNvPr id="9" name="Text 7"/>
+          <p:cNvSpPr/>
+          <p:nvPr/>
+        </p:nvSpPr>
+        <p:spPr>
+          <a:xfrm>
+            <a:off x="6675120" y="2651760"/>
             <a:ext cx="4206240" cy="274320"/>
           </a:xfrm>
           <a:prstGeom prst="rect">
@@ -4606,14 +4317,14 @@
       </p:sp>
       <p:sp>
         <p:nvSpPr>
-          <p:cNvPr id="11" name="Text 9"/>
-          <p:cNvSpPr/>
-          <p:nvPr/>
-        </p:nvSpPr>
-        <p:spPr>
-          <a:xfrm>
-            <a:off x="6629400" y="2743200"/>
-            <a:ext cx="4297680" cy="1097280"/>
+          <p:cNvPr id="10" name="Text 8"/>
+          <p:cNvSpPr/>
+          <p:nvPr/>
+        </p:nvSpPr>
+        <p:spPr>
+          <a:xfrm>
+            <a:off x="6675120" y="3063240"/>
+            <a:ext cx="4297680" cy="640080"/>
           </a:xfrm>
           <a:prstGeom prst="rect">
             <a:avLst/>
@@ -4626,13 +4337,10 @@
           <a:lstStyle/>
           <a:p>
             <a:pPr indent="0" marL="0">
-              <a:lnSpc>
-                <a:spcPts val="3400"/>
-              </a:lnSpc>
-              <a:buNone/>
-            </a:pPr>
-            <a:r>
-              <a:rPr lang="en-US" sz="2700" b="1" dirty="0">
+              <a:buNone/>
+            </a:pPr>
+            <a:r>
+              <a:rPr lang="en-US" sz="2800" b="1" dirty="0">
                 <a:solidFill>
                   <a:srgbClr val="FFFFFF"/>
                 </a:solidFill>
@@ -4642,20 +4350,20 @@
               </a:rPr>
               <a:t>“When?”</a:t>
             </a:r>
-            <a:endParaRPr lang="en-US" sz="2700" dirty="0"/>
-          </a:p>
-        </p:txBody>
-      </p:sp>
-      <p:sp>
-        <p:nvSpPr>
-          <p:cNvPr id="12" name="Text 10"/>
-          <p:cNvSpPr/>
-          <p:nvPr/>
-        </p:nvSpPr>
-        <p:spPr>
-          <a:xfrm>
-            <a:off x="6629400" y="3913632"/>
-            <a:ext cx="4206240" cy="548640"/>
+            <a:endParaRPr lang="en-US" sz="2800" dirty="0"/>
+          </a:p>
+        </p:txBody>
+      </p:sp>
+      <p:sp>
+        <p:nvSpPr>
+          <p:cNvPr id="11" name="Text 9"/>
+          <p:cNvSpPr/>
+          <p:nvPr/>
+        </p:nvSpPr>
+        <p:spPr>
+          <a:xfrm>
+            <a:off x="6675120" y="3977640"/>
+            <a:ext cx="4206240" cy="640080"/>
           </a:xfrm>
           <a:prstGeom prst="rect">
             <a:avLst/>
@@ -4671,7 +4379,7 @@
               <a:buNone/>
             </a:pPr>
             <a:r>
-              <a:rPr lang="en-US" sz="3200" b="1" dirty="0">
+              <a:rPr lang="en-US" sz="4000" b="1" dirty="0">
                 <a:solidFill>
                   <a:srgbClr val="3FA672"/>
                 </a:solidFill>
@@ -4681,85 +4389,7 @@
               </a:rPr>
               <a:t>June 2029.</a:t>
             </a:r>
-            <a:endParaRPr lang="en-US" sz="3200" dirty="0"/>
-          </a:p>
-        </p:txBody>
-      </p:sp>
-      <p:sp>
-        <p:nvSpPr>
-          <p:cNvPr id="13" name="Text 11"/>
-          <p:cNvSpPr/>
-          <p:nvPr/>
-        </p:nvSpPr>
-        <p:spPr>
-          <a:xfrm>
-            <a:off x="6629400" y="4498848"/>
-            <a:ext cx="4297680" cy="320040"/>
-          </a:xfrm>
-          <a:prstGeom prst="rect">
-            <a:avLst/>
-          </a:prstGeom>
-          <a:noFill/>
-          <a:ln/>
-        </p:spPr>
-        <p:txBody>
-          <a:bodyPr wrap="square" lIns="0" tIns="0" rIns="0" bIns="0" rtlCol="0" anchor="ctr"/>
-          <a:lstStyle/>
-          <a:p>
-            <a:pPr indent="0" marL="0">
-              <a:buNone/>
-            </a:pPr>
-            <a:r>
-              <a:rPr lang="en-US" sz="1300" dirty="0">
-                <a:solidFill>
-                  <a:srgbClr val="E3F2E9"/>
-                </a:solidFill>
-                <a:latin typeface="Calibri" pitchFamily="34" charset="0"/>
-                <a:ea typeface="Calibri" pitchFamily="34" charset="-122"/>
-                <a:cs typeface="Calibri" pitchFamily="34" charset="-120"/>
-              </a:rPr>
-              <a:t>So they keep going — and the date moves closer.</a:t>
-            </a:r>
-            <a:endParaRPr lang="en-US" sz="1300" dirty="0"/>
-          </a:p>
-        </p:txBody>
-      </p:sp>
-      <p:sp>
-        <p:nvSpPr>
-          <p:cNvPr id="14" name="Text 12"/>
-          <p:cNvSpPr/>
-          <p:nvPr/>
-        </p:nvSpPr>
-        <p:spPr>
-          <a:xfrm>
-            <a:off x="685800" y="5349240"/>
-            <a:ext cx="10817352" cy="457200"/>
-          </a:xfrm>
-          <a:prstGeom prst="rect">
-            <a:avLst/>
-          </a:prstGeom>
-          <a:noFill/>
-          <a:ln/>
-        </p:spPr>
-        <p:txBody>
-          <a:bodyPr wrap="square" lIns="0" tIns="0" rIns="0" bIns="0" rtlCol="0" anchor="ctr"/>
-          <a:lstStyle/>
-          <a:p>
-            <a:pPr indent="0" marL="0">
-              <a:buNone/>
-            </a:pPr>
-            <a:r>
-              <a:rPr lang="en-US" sz="2000" i="1" dirty="0">
-                <a:solidFill>
-                  <a:srgbClr val="1E4D3B"/>
-                </a:solidFill>
-                <a:latin typeface="Cambria" pitchFamily="34" charset="0"/>
-                <a:ea typeface="Cambria" pitchFamily="34" charset="-122"/>
-                <a:cs typeface="Cambria" pitchFamily="34" charset="-120"/>
-              </a:rPr>
-              <a:t>I can’t make the house cheaper. I can give people the answer I never got.</a:t>
-            </a:r>
-            <a:endParaRPr lang="en-US" sz="2000" dirty="0"/>
+            <a:endParaRPr lang="en-US" sz="4000" dirty="0"/>
           </a:p>
         </p:txBody>
       </p:sp>
@@ -4803,8 +4433,8 @@
         </p:nvSpPr>
         <p:spPr>
           <a:xfrm>
-            <a:off x="685800" y="475488"/>
-            <a:ext cx="7315200" cy="274320"/>
+            <a:off x="685800" y="502920"/>
+            <a:ext cx="9144000" cy="274320"/>
           </a:xfrm>
           <a:prstGeom prst="rect">
             <a:avLst/>
@@ -4842,8 +4472,8 @@
         </p:nvSpPr>
         <p:spPr>
           <a:xfrm>
-            <a:off x="685800" y="804672"/>
-            <a:ext cx="10817352" cy="868680"/>
+            <a:off x="685800" y="914400"/>
+            <a:ext cx="10607040" cy="822960"/>
           </a:xfrm>
           <a:prstGeom prst="rect">
             <a:avLst/>
@@ -4875,60 +4505,18 @@
       </p:sp>
       <p:sp>
         <p:nvSpPr>
-          <p:cNvPr id="4" name="Text 2"/>
-          <p:cNvSpPr/>
-          <p:nvPr/>
-        </p:nvSpPr>
-        <p:spPr>
-          <a:xfrm>
-            <a:off x="685800" y="1920240"/>
-            <a:ext cx="10607040" cy="822960"/>
-          </a:xfrm>
-          <a:prstGeom prst="rect">
-            <a:avLst/>
-          </a:prstGeom>
-          <a:noFill/>
-          <a:ln/>
-        </p:spPr>
-        <p:txBody>
-          <a:bodyPr wrap="square" lIns="0" tIns="0" rIns="0" bIns="0" rtlCol="0" anchor="ctr"/>
-          <a:lstStyle/>
-          <a:p>
-            <a:pPr indent="0" marL="0">
-              <a:lnSpc>
-                <a:spcPts val="2400"/>
-              </a:lnSpc>
-              <a:buNone/>
-            </a:pPr>
-            <a:r>
-              <a:rPr lang="en-US" sz="1600" dirty="0">
-                <a:solidFill>
-                  <a:srgbClr val="17302A"/>
-                </a:solidFill>
-                <a:latin typeface="Calibri" pitchFamily="34" charset="0"/>
-                <a:ea typeface="Calibri" pitchFamily="34" charset="-122"/>
-                <a:cs typeface="Calibri" pitchFamily="34" charset="-120"/>
-              </a:rPr>
-              <a:t>When people can’t see a path, they stop building wealth entirely. That’s a household problem and a national one — renters instead of owners, wealth that never compounds.</a:t>
-            </a:r>
-            <a:endParaRPr lang="en-US" sz="1600" dirty="0"/>
-          </a:p>
-        </p:txBody>
-      </p:sp>
-      <p:sp>
-        <p:nvSpPr>
-          <p:cNvPr id="5" name="Shape 3"/>
-          <p:cNvSpPr/>
-          <p:nvPr/>
-        </p:nvSpPr>
-        <p:spPr>
-          <a:xfrm>
-            <a:off x="685800" y="2971800"/>
-            <a:ext cx="1975104" cy="914400"/>
+          <p:cNvPr id="4" name="Shape 2"/>
+          <p:cNvSpPr/>
+          <p:nvPr/>
+        </p:nvSpPr>
+        <p:spPr>
+          <a:xfrm>
+            <a:off x="685800" y="2423160"/>
+            <a:ext cx="1975104" cy="1051560"/>
           </a:xfrm>
           <a:prstGeom prst="roundRect">
             <a:avLst>
-              <a:gd name="adj" fmla="val 12000"/>
+              <a:gd name="adj" fmla="val 10435"/>
             </a:avLst>
           </a:prstGeom>
           <a:solidFill>
@@ -4944,14 +4532,14 @@
       </p:sp>
       <p:sp>
         <p:nvSpPr>
-          <p:cNvPr id="6" name="Text 4"/>
-          <p:cNvSpPr/>
-          <p:nvPr/>
-        </p:nvSpPr>
-        <p:spPr>
-          <a:xfrm>
-            <a:off x="685800" y="2971800"/>
-            <a:ext cx="1975104" cy="914400"/>
+          <p:cNvPr id="5" name="Text 3"/>
+          <p:cNvSpPr/>
+          <p:nvPr/>
+        </p:nvSpPr>
+        <p:spPr>
+          <a:xfrm>
+            <a:off x="685800" y="2423160"/>
+            <a:ext cx="1975104" cy="1051560"/>
           </a:xfrm>
           <a:prstGeom prst="rect">
             <a:avLst/>
@@ -4967,7 +4555,7 @@
               <a:buNone/>
             </a:pPr>
             <a:r>
-              <a:rPr lang="en-US" sz="1400" b="1" dirty="0">
+              <a:rPr lang="en-US" sz="1500" b="1" dirty="0">
                 <a:solidFill>
                   <a:srgbClr val="FFFFFF"/>
                 </a:solidFill>
@@ -4977,24 +4565,24 @@
               </a:rPr>
               <a:t>Canada</a:t>
             </a:r>
-            <a:endParaRPr lang="en-US" sz="1400" dirty="0"/>
-          </a:p>
-        </p:txBody>
-      </p:sp>
-      <p:sp>
-        <p:nvSpPr>
-          <p:cNvPr id="7" name="Shape 5"/>
-          <p:cNvSpPr/>
-          <p:nvPr/>
-        </p:nvSpPr>
-        <p:spPr>
-          <a:xfrm>
-            <a:off x="2807208" y="2971800"/>
-            <a:ext cx="1975104" cy="914400"/>
+            <a:endParaRPr lang="en-US" sz="1500" dirty="0"/>
+          </a:p>
+        </p:txBody>
+      </p:sp>
+      <p:sp>
+        <p:nvSpPr>
+          <p:cNvPr id="6" name="Shape 4"/>
+          <p:cNvSpPr/>
+          <p:nvPr/>
+        </p:nvSpPr>
+        <p:spPr>
+          <a:xfrm>
+            <a:off x="2807208" y="2423160"/>
+            <a:ext cx="1975104" cy="1051560"/>
           </a:xfrm>
           <a:prstGeom prst="roundRect">
             <a:avLst>
-              <a:gd name="adj" fmla="val 12000"/>
+              <a:gd name="adj" fmla="val 10435"/>
             </a:avLst>
           </a:prstGeom>
           <a:solidFill>
@@ -5010,14 +4598,14 @@
       </p:sp>
       <p:sp>
         <p:nvSpPr>
-          <p:cNvPr id="8" name="Text 6"/>
-          <p:cNvSpPr/>
-          <p:nvPr/>
-        </p:nvSpPr>
-        <p:spPr>
-          <a:xfrm>
-            <a:off x="2807208" y="2971800"/>
-            <a:ext cx="1975104" cy="914400"/>
+          <p:cNvPr id="7" name="Text 5"/>
+          <p:cNvSpPr/>
+          <p:nvPr/>
+        </p:nvSpPr>
+        <p:spPr>
+          <a:xfrm>
+            <a:off x="2807208" y="2423160"/>
+            <a:ext cx="1975104" cy="1051560"/>
           </a:xfrm>
           <a:prstGeom prst="rect">
             <a:avLst/>
@@ -5033,7 +4621,7 @@
               <a:buNone/>
             </a:pPr>
             <a:r>
-              <a:rPr lang="en-US" sz="1400" b="1" dirty="0">
+              <a:rPr lang="en-US" sz="1500" b="1" dirty="0">
                 <a:solidFill>
                   <a:srgbClr val="17302A"/>
                 </a:solidFill>
@@ -5043,24 +4631,24 @@
               </a:rPr>
               <a:t>Australia</a:t>
             </a:r>
-            <a:endParaRPr lang="en-US" sz="1400" dirty="0"/>
-          </a:p>
-        </p:txBody>
-      </p:sp>
-      <p:sp>
-        <p:nvSpPr>
-          <p:cNvPr id="9" name="Shape 7"/>
-          <p:cNvSpPr/>
-          <p:nvPr/>
-        </p:nvSpPr>
-        <p:spPr>
-          <a:xfrm>
-            <a:off x="4928616" y="2971800"/>
-            <a:ext cx="1975104" cy="914400"/>
+            <a:endParaRPr lang="en-US" sz="1500" dirty="0"/>
+          </a:p>
+        </p:txBody>
+      </p:sp>
+      <p:sp>
+        <p:nvSpPr>
+          <p:cNvPr id="8" name="Shape 6"/>
+          <p:cNvSpPr/>
+          <p:nvPr/>
+        </p:nvSpPr>
+        <p:spPr>
+          <a:xfrm>
+            <a:off x="4928616" y="2423160"/>
+            <a:ext cx="1975104" cy="1051560"/>
           </a:xfrm>
           <a:prstGeom prst="roundRect">
             <a:avLst>
-              <a:gd name="adj" fmla="val 12000"/>
+              <a:gd name="adj" fmla="val 10435"/>
             </a:avLst>
           </a:prstGeom>
           <a:solidFill>
@@ -5076,14 +4664,14 @@
       </p:sp>
       <p:sp>
         <p:nvSpPr>
-          <p:cNvPr id="10" name="Text 8"/>
-          <p:cNvSpPr/>
-          <p:nvPr/>
-        </p:nvSpPr>
-        <p:spPr>
-          <a:xfrm>
-            <a:off x="4928616" y="2971800"/>
-            <a:ext cx="1975104" cy="914400"/>
+          <p:cNvPr id="9" name="Text 7"/>
+          <p:cNvSpPr/>
+          <p:nvPr/>
+        </p:nvSpPr>
+        <p:spPr>
+          <a:xfrm>
+            <a:off x="4928616" y="2423160"/>
+            <a:ext cx="1975104" cy="1051560"/>
           </a:xfrm>
           <a:prstGeom prst="rect">
             <a:avLst/>
@@ -5099,7 +4687,7 @@
               <a:buNone/>
             </a:pPr>
             <a:r>
-              <a:rPr lang="en-US" sz="1400" b="1" dirty="0">
+              <a:rPr lang="en-US" sz="1500" b="1" dirty="0">
                 <a:solidFill>
                   <a:srgbClr val="17302A"/>
                 </a:solidFill>
@@ -5107,26 +4695,26 @@
                 <a:ea typeface="Calibri" pitchFamily="34" charset="-122"/>
                 <a:cs typeface="Calibri" pitchFamily="34" charset="-120"/>
               </a:rPr>
-              <a:t>United Kingdom</a:t>
-            </a:r>
-            <a:endParaRPr lang="en-US" sz="1400" dirty="0"/>
-          </a:p>
-        </p:txBody>
-      </p:sp>
-      <p:sp>
-        <p:nvSpPr>
-          <p:cNvPr id="11" name="Shape 9"/>
-          <p:cNvSpPr/>
-          <p:nvPr/>
-        </p:nvSpPr>
-        <p:spPr>
-          <a:xfrm>
-            <a:off x="7050024" y="2971800"/>
-            <a:ext cx="1975104" cy="914400"/>
+              <a:t>UK</a:t>
+            </a:r>
+            <a:endParaRPr lang="en-US" sz="1500" dirty="0"/>
+          </a:p>
+        </p:txBody>
+      </p:sp>
+      <p:sp>
+        <p:nvSpPr>
+          <p:cNvPr id="10" name="Shape 8"/>
+          <p:cNvSpPr/>
+          <p:nvPr/>
+        </p:nvSpPr>
+        <p:spPr>
+          <a:xfrm>
+            <a:off x="7050024" y="2423160"/>
+            <a:ext cx="1975104" cy="1051560"/>
           </a:xfrm>
           <a:prstGeom prst="roundRect">
             <a:avLst>
-              <a:gd name="adj" fmla="val 12000"/>
+              <a:gd name="adj" fmla="val 10435"/>
             </a:avLst>
           </a:prstGeom>
           <a:solidFill>
@@ -5142,14 +4730,14 @@
       </p:sp>
       <p:sp>
         <p:nvSpPr>
-          <p:cNvPr id="12" name="Text 10"/>
-          <p:cNvSpPr/>
-          <p:nvPr/>
-        </p:nvSpPr>
-        <p:spPr>
-          <a:xfrm>
-            <a:off x="7050024" y="2971800"/>
-            <a:ext cx="1975104" cy="914400"/>
+          <p:cNvPr id="11" name="Text 9"/>
+          <p:cNvSpPr/>
+          <p:nvPr/>
+        </p:nvSpPr>
+        <p:spPr>
+          <a:xfrm>
+            <a:off x="7050024" y="2423160"/>
+            <a:ext cx="1975104" cy="1051560"/>
           </a:xfrm>
           <a:prstGeom prst="rect">
             <a:avLst/>
@@ -5165,7 +4753,7 @@
               <a:buNone/>
             </a:pPr>
             <a:r>
-              <a:rPr lang="en-US" sz="1400" b="1" dirty="0">
+              <a:rPr lang="en-US" sz="1500" b="1" dirty="0">
                 <a:solidFill>
                   <a:srgbClr val="17302A"/>
                 </a:solidFill>
@@ -5175,24 +4763,24 @@
               </a:rPr>
               <a:t>Ireland</a:t>
             </a:r>
-            <a:endParaRPr lang="en-US" sz="1400" dirty="0"/>
-          </a:p>
-        </p:txBody>
-      </p:sp>
-      <p:sp>
-        <p:nvSpPr>
-          <p:cNvPr id="13" name="Shape 11"/>
-          <p:cNvSpPr/>
-          <p:nvPr/>
-        </p:nvSpPr>
-        <p:spPr>
-          <a:xfrm>
-            <a:off x="9171432" y="2971800"/>
-            <a:ext cx="1975104" cy="914400"/>
+            <a:endParaRPr lang="en-US" sz="1500" dirty="0"/>
+          </a:p>
+        </p:txBody>
+      </p:sp>
+      <p:sp>
+        <p:nvSpPr>
+          <p:cNvPr id="12" name="Shape 10"/>
+          <p:cNvSpPr/>
+          <p:nvPr/>
+        </p:nvSpPr>
+        <p:spPr>
+          <a:xfrm>
+            <a:off x="9171432" y="2423160"/>
+            <a:ext cx="1975104" cy="1051560"/>
           </a:xfrm>
           <a:prstGeom prst="roundRect">
             <a:avLst>
-              <a:gd name="adj" fmla="val 12000"/>
+              <a:gd name="adj" fmla="val 10435"/>
             </a:avLst>
           </a:prstGeom>
           <a:solidFill>
@@ -5208,14 +4796,14 @@
       </p:sp>
       <p:sp>
         <p:nvSpPr>
-          <p:cNvPr id="14" name="Text 12"/>
-          <p:cNvSpPr/>
-          <p:nvPr/>
-        </p:nvSpPr>
-        <p:spPr>
-          <a:xfrm>
-            <a:off x="9171432" y="2971800"/>
-            <a:ext cx="1975104" cy="914400"/>
+          <p:cNvPr id="13" name="Text 11"/>
+          <p:cNvSpPr/>
+          <p:nvPr/>
+        </p:nvSpPr>
+        <p:spPr>
+          <a:xfrm>
+            <a:off x="9171432" y="2423160"/>
+            <a:ext cx="1975104" cy="1051560"/>
           </a:xfrm>
           <a:prstGeom prst="rect">
             <a:avLst/>
@@ -5231,7 +4819,7 @@
               <a:buNone/>
             </a:pPr>
             <a:r>
-              <a:rPr lang="en-US" sz="1400" b="1" dirty="0">
+              <a:rPr lang="en-US" sz="1500" b="1" dirty="0">
                 <a:solidFill>
                   <a:srgbClr val="17302A"/>
                 </a:solidFill>
@@ -5241,63 +4829,24 @@
               </a:rPr>
               <a:t>New Zealand</a:t>
             </a:r>
-            <a:endParaRPr lang="en-US" sz="1400" dirty="0"/>
-          </a:p>
-        </p:txBody>
-      </p:sp>
-      <p:sp>
-        <p:nvSpPr>
-          <p:cNvPr id="15" name="Text 13"/>
-          <p:cNvSpPr/>
-          <p:nvPr/>
-        </p:nvSpPr>
-        <p:spPr>
-          <a:xfrm>
-            <a:off x="685800" y="4224528"/>
-            <a:ext cx="10607040" cy="457200"/>
-          </a:xfrm>
-          <a:prstGeom prst="rect">
-            <a:avLst/>
-          </a:prstGeom>
-          <a:noFill/>
-          <a:ln/>
-        </p:spPr>
-        <p:txBody>
-          <a:bodyPr wrap="square" lIns="0" tIns="0" rIns="0" bIns="0" rtlCol="0" anchor="ctr"/>
-          <a:lstStyle/>
-          <a:p>
-            <a:pPr indent="0" marL="0">
-              <a:buNone/>
-            </a:pPr>
-            <a:r>
-              <a:rPr lang="en-US" sz="1400" dirty="0">
-                <a:solidFill>
-                  <a:srgbClr val="5C6F66"/>
-                </a:solidFill>
-                <a:latin typeface="Calibri" pitchFamily="34" charset="0"/>
-                <a:ea typeface="Calibri" pitchFamily="34" charset="-122"/>
-                <a:cs typeface="Calibri" pitchFamily="34" charset="-120"/>
-              </a:rPr>
-              <a:t>Same two problems everywhere: a generation priced out, and a tangle of government programs almost nobody understands.</a:t>
-            </a:r>
-            <a:endParaRPr lang="en-US" sz="1400" dirty="0"/>
-          </a:p>
-        </p:txBody>
-      </p:sp>
-      <p:sp>
-        <p:nvSpPr>
-          <p:cNvPr id="16" name="Shape 14"/>
-          <p:cNvSpPr/>
-          <p:nvPr/>
-        </p:nvSpPr>
-        <p:spPr>
-          <a:xfrm>
-            <a:off x="685800" y="4754880"/>
-            <a:ext cx="10607040" cy="1051560"/>
+            <a:endParaRPr lang="en-US" sz="1500" dirty="0"/>
+          </a:p>
+        </p:txBody>
+      </p:sp>
+      <p:sp>
+        <p:nvSpPr>
+          <p:cNvPr id="14" name="Shape 12"/>
+          <p:cNvSpPr/>
+          <p:nvPr/>
+        </p:nvSpPr>
+        <p:spPr>
+          <a:xfrm>
+            <a:off x="685800" y="4114800"/>
+            <a:ext cx="10607040" cy="1371600"/>
           </a:xfrm>
           <a:prstGeom prst="roundRect">
             <a:avLst>
-              <a:gd name="adj" fmla="val 12174"/>
+              <a:gd name="adj" fmla="val 10667"/>
             </a:avLst>
           </a:prstGeom>
           <a:solidFill>
@@ -5313,14 +4862,14 @@
       </p:sp>
       <p:sp>
         <p:nvSpPr>
-          <p:cNvPr id="17" name="Text 15"/>
-          <p:cNvSpPr/>
-          <p:nvPr/>
-        </p:nvSpPr>
-        <p:spPr>
-          <a:xfrm>
-            <a:off x="1143000" y="4754880"/>
-            <a:ext cx="9692640" cy="1051560"/>
+          <p:cNvPr id="15" name="Text 13"/>
+          <p:cNvSpPr/>
+          <p:nvPr/>
+        </p:nvSpPr>
+        <p:spPr>
+          <a:xfrm>
+            <a:off x="1234440" y="4114800"/>
+            <a:ext cx="9509760" cy="1371600"/>
           </a:xfrm>
           <a:prstGeom prst="rect">
             <a:avLst/>
@@ -5336,7 +4885,7 @@
               <a:buNone/>
             </a:pPr>
             <a:r>
-              <a:rPr lang="en-US" sz="2100" dirty="0">
+              <a:rPr lang="en-US" sz="3000" dirty="0">
                 <a:solidFill>
                   <a:srgbClr val="E3F2E9"/>
                 </a:solidFill>
@@ -5344,13 +4893,13 @@
                 <a:ea typeface="Cambria" pitchFamily="34" charset="-122"/>
                 <a:cs typeface="Cambria" pitchFamily="34" charset="-120"/>
               </a:rPr>
-              <a:t>KeyDate is a rules engine with a Canadian rulebook loaded. </a:t>
+              <a:t>The engine stays. </a:t>
             </a:r>
             <a:pPr indent="0" marL="0">
               <a:buNone/>
             </a:pPr>
             <a:r>
-              <a:rPr lang="en-US" sz="2100" b="1" dirty="0">
+              <a:rPr lang="en-US" sz="3000" b="1" dirty="0">
                 <a:solidFill>
                   <a:srgbClr val="E8B84B"/>
                 </a:solidFill>
@@ -5358,9 +4907,9 @@
                 <a:ea typeface="Cambria" pitchFamily="34" charset="-122"/>
                 <a:cs typeface="Cambria" pitchFamily="34" charset="-120"/>
               </a:rPr>
-              <a:t>The engine stays. The rulebook swaps.</a:t>
-            </a:r>
-            <a:endParaRPr lang="en-US" sz="2100" dirty="0"/>
+              <a:t>The rulebook swaps.</a:t>
+            </a:r>
+            <a:endParaRPr lang="en-US" sz="3000" dirty="0"/>
           </a:p>
         </p:txBody>
       </p:sp>
@@ -5404,8 +4953,8 @@
         </p:nvSpPr>
         <p:spPr>
           <a:xfrm>
-            <a:off x="685800" y="475488"/>
-            <a:ext cx="7315200" cy="274320"/>
+            <a:off x="685800" y="502920"/>
+            <a:ext cx="9144000" cy="274320"/>
           </a:xfrm>
           <a:prstGeom prst="rect">
             <a:avLst/>
@@ -5443,8 +4992,8 @@
         </p:nvSpPr>
         <p:spPr>
           <a:xfrm>
-            <a:off x="685800" y="804672"/>
-            <a:ext cx="10817352" cy="868680"/>
+            <a:off x="685800" y="914400"/>
+            <a:ext cx="10607040" cy="822960"/>
           </a:xfrm>
           <a:prstGeom prst="rect">
             <a:avLst/>
@@ -5476,99 +5025,18 @@
       </p:sp>
       <p:sp>
         <p:nvSpPr>
-          <p:cNvPr id="4" name="Text 2"/>
-          <p:cNvSpPr/>
-          <p:nvPr/>
-        </p:nvSpPr>
-        <p:spPr>
-          <a:xfrm>
-            <a:off x="685800" y="1874520"/>
-            <a:ext cx="10607040" cy="822960"/>
-          </a:xfrm>
-          <a:prstGeom prst="rect">
-            <a:avLst/>
-          </a:prstGeom>
-          <a:noFill/>
-          <a:ln/>
-        </p:spPr>
-        <p:txBody>
-          <a:bodyPr wrap="square" lIns="0" tIns="0" rIns="0" bIns="0" rtlCol="0" anchor="ctr"/>
-          <a:lstStyle/>
-          <a:p>
-            <a:pPr indent="0" marL="0">
-              <a:lnSpc>
-                <a:spcPts val="2400"/>
-              </a:lnSpc>
-              <a:buNone/>
-            </a:pPr>
-            <a:r>
-              <a:rPr lang="en-US" sz="1600" dirty="0">
-                <a:solidFill>
-                  <a:srgbClr val="E3F2E9"/>
-                </a:solidFill>
-                <a:latin typeface="Calibri" pitchFamily="34" charset="0"/>
-                <a:ea typeface="Calibri" pitchFamily="34" charset="-122"/>
-                <a:cs typeface="Calibri" pitchFamily="34" charset="-120"/>
-              </a:rPr>
-              <a:t>The obvious way to monetise this is to sell these users to mortgage brokers. People who just told you their income, their savings, and exactly when they’ll need a mortgage.</a:t>
-            </a:r>
-            <a:endParaRPr lang="en-US" sz="1600" dirty="0"/>
-          </a:p>
-        </p:txBody>
-      </p:sp>
-      <p:sp>
-        <p:nvSpPr>
-          <p:cNvPr id="5" name="Text 3"/>
-          <p:cNvSpPr/>
-          <p:nvPr/>
-        </p:nvSpPr>
-        <p:spPr>
-          <a:xfrm>
-            <a:off x="685800" y="2697480"/>
-            <a:ext cx="10607040" cy="411480"/>
-          </a:xfrm>
-          <a:prstGeom prst="rect">
-            <a:avLst/>
-          </a:prstGeom>
-          <a:noFill/>
-          <a:ln/>
-        </p:spPr>
-        <p:txBody>
-          <a:bodyPr wrap="square" lIns="0" tIns="0" rIns="0" bIns="0" rtlCol="0" anchor="ctr"/>
-          <a:lstStyle/>
-          <a:p>
-            <a:pPr indent="0" marL="0">
-              <a:buNone/>
-            </a:pPr>
-            <a:r>
-              <a:rPr lang="en-US" sz="2000" i="1" dirty="0">
-                <a:solidFill>
-                  <a:srgbClr val="FFFFFF"/>
-                </a:solidFill>
-                <a:latin typeface="Cambria" pitchFamily="34" charset="0"/>
-                <a:ea typeface="Cambria" pitchFamily="34" charset="-122"/>
-                <a:cs typeface="Cambria" pitchFamily="34" charset="-120"/>
-              </a:rPr>
-              <a:t>It is the most valuable lead list in the country.</a:t>
-            </a:r>
-            <a:endParaRPr lang="en-US" sz="2000" dirty="0"/>
-          </a:p>
-        </p:txBody>
-      </p:sp>
-      <p:sp>
-        <p:nvSpPr>
-          <p:cNvPr id="6" name="Shape 4"/>
-          <p:cNvSpPr/>
-          <p:nvPr/>
-        </p:nvSpPr>
-        <p:spPr>
-          <a:xfrm>
-            <a:off x="685800" y="3337560"/>
-            <a:ext cx="5074920" cy="1965960"/>
+          <p:cNvPr id="4" name="Shape 2"/>
+          <p:cNvSpPr/>
+          <p:nvPr/>
+        </p:nvSpPr>
+        <p:spPr>
+          <a:xfrm>
+            <a:off x="685800" y="2331720"/>
+            <a:ext cx="5074920" cy="2194560"/>
           </a:xfrm>
           <a:prstGeom prst="roundRect">
             <a:avLst>
-              <a:gd name="adj" fmla="val 7442"/>
+              <a:gd name="adj" fmla="val 6667"/>
             </a:avLst>
           </a:prstGeom>
           <a:solidFill>
@@ -5584,14 +5052,14 @@
       </p:sp>
       <p:sp>
         <p:nvSpPr>
-          <p:cNvPr id="7" name="Text 5"/>
-          <p:cNvSpPr/>
-          <p:nvPr/>
-        </p:nvSpPr>
-        <p:spPr>
-          <a:xfrm>
-            <a:off x="1097280" y="3639312"/>
-            <a:ext cx="4297680" cy="777240"/>
+          <p:cNvPr id="5" name="Text 3"/>
+          <p:cNvSpPr/>
+          <p:nvPr/>
+        </p:nvSpPr>
+        <p:spPr>
+          <a:xfrm>
+            <a:off x="1143000" y="2331720"/>
+            <a:ext cx="4297680" cy="2194560"/>
           </a:xfrm>
           <a:prstGeom prst="rect">
             <a:avLst/>
@@ -5604,10 +5072,13 @@
           <a:lstStyle/>
           <a:p>
             <a:pPr indent="0" marL="0">
-              <a:buNone/>
-            </a:pPr>
-            <a:r>
-              <a:rPr lang="en-US" sz="2000" b="1" dirty="0">
+              <a:lnSpc>
+                <a:spcPts val="3400"/>
+              </a:lnSpc>
+              <a:buNone/>
+            </a:pPr>
+            <a:r>
+              <a:rPr lang="en-US" sz="2600" b="1" dirty="0">
                 <a:solidFill>
                   <a:srgbClr val="FFFFFF"/>
                 </a:solidFill>
@@ -5615,65 +5086,46 @@
                 <a:ea typeface="Cambria" pitchFamily="34" charset="-122"/>
                 <a:cs typeface="Cambria" pitchFamily="34" charset="-120"/>
               </a:rPr>
-              <a:t>Our privacy policy says we never will.</a:t>
-            </a:r>
-            <a:endParaRPr lang="en-US" sz="2000" dirty="0"/>
-          </a:p>
-        </p:txBody>
-      </p:sp>
-      <p:sp>
-        <p:nvSpPr>
-          <p:cNvPr id="8" name="Text 6"/>
-          <p:cNvSpPr/>
-          <p:nvPr/>
-        </p:nvSpPr>
-        <p:spPr>
-          <a:xfrm>
-            <a:off x="1097280" y="4498848"/>
-            <a:ext cx="4297680" cy="457200"/>
-          </a:xfrm>
-          <a:prstGeom prst="rect">
-            <a:avLst/>
-          </a:prstGeom>
-          <a:noFill/>
-          <a:ln/>
-        </p:spPr>
-        <p:txBody>
-          <a:bodyPr wrap="square" lIns="0" tIns="0" rIns="0" bIns="0" rtlCol="0" anchor="ctr"/>
-          <a:lstStyle/>
+              <a:t>We never sell you</a:t>
+            </a:r>
+            <a:endParaRPr lang="en-US" sz="2600" dirty="0"/>
+          </a:p>
           <a:p>
             <a:pPr indent="0" marL="0">
-              <a:buNone/>
-            </a:pPr>
-            <a:r>
-              <a:rPr lang="en-US" sz="1400" dirty="0">
-                <a:solidFill>
-                  <a:srgbClr val="E3F2E9"/>
-                </a:solidFill>
-                <a:latin typeface="Calibri" pitchFamily="34" charset="0"/>
-                <a:ea typeface="Calibri" pitchFamily="34" charset="-122"/>
-                <a:cs typeface="Calibri" pitchFamily="34" charset="-120"/>
-              </a:rPr>
-              <a:t>In writing. Live on the site today.</a:t>
-            </a:r>
-            <a:endParaRPr lang="en-US" sz="1400" dirty="0"/>
-          </a:p>
-        </p:txBody>
-      </p:sp>
-      <p:sp>
-        <p:nvSpPr>
-          <p:cNvPr id="9" name="Shape 7"/>
-          <p:cNvSpPr/>
-          <p:nvPr/>
-        </p:nvSpPr>
-        <p:spPr>
-          <a:xfrm>
-            <a:off x="6217920" y="3337560"/>
-            <a:ext cx="5074920" cy="1965960"/>
+              <a:lnSpc>
+                <a:spcPts val="3400"/>
+              </a:lnSpc>
+              <a:buNone/>
+            </a:pPr>
+            <a:r>
+              <a:rPr lang="en-US" sz="2600" b="1" dirty="0">
+                <a:solidFill>
+                  <a:srgbClr val="FFFFFF"/>
+                </a:solidFill>
+                <a:latin typeface="Cambria" pitchFamily="34" charset="0"/>
+                <a:ea typeface="Cambria" pitchFamily="34" charset="-122"/>
+                <a:cs typeface="Cambria" pitchFamily="34" charset="-120"/>
+              </a:rPr>
+              <a:t>to brokers.</a:t>
+            </a:r>
+            <a:endParaRPr lang="en-US" sz="2600" dirty="0"/>
+          </a:p>
+        </p:txBody>
+      </p:sp>
+      <p:sp>
+        <p:nvSpPr>
+          <p:cNvPr id="6" name="Shape 4"/>
+          <p:cNvSpPr/>
+          <p:nvPr/>
+        </p:nvSpPr>
+        <p:spPr>
+          <a:xfrm>
+            <a:off x="6217920" y="2331720"/>
+            <a:ext cx="5074920" cy="2194560"/>
           </a:xfrm>
           <a:prstGeom prst="roundRect">
             <a:avLst>
-              <a:gd name="adj" fmla="val 7442"/>
+              <a:gd name="adj" fmla="val 6667"/>
             </a:avLst>
           </a:prstGeom>
           <a:solidFill>
@@ -5689,14 +5141,14 @@
       </p:sp>
       <p:sp>
         <p:nvSpPr>
-          <p:cNvPr id="10" name="Text 8"/>
-          <p:cNvSpPr/>
-          <p:nvPr/>
-        </p:nvSpPr>
-        <p:spPr>
-          <a:xfrm>
-            <a:off x="6629400" y="3639312"/>
-            <a:ext cx="4297680" cy="777240"/>
+          <p:cNvPr id="7" name="Text 5"/>
+          <p:cNvSpPr/>
+          <p:nvPr/>
+        </p:nvSpPr>
+        <p:spPr>
+          <a:xfrm>
+            <a:off x="6675120" y="2331720"/>
+            <a:ext cx="4297680" cy="2194560"/>
           </a:xfrm>
           <a:prstGeom prst="rect">
             <a:avLst/>
@@ -5709,10 +5161,13 @@
           <a:lstStyle/>
           <a:p>
             <a:pPr indent="0" marL="0">
-              <a:buNone/>
-            </a:pPr>
-            <a:r>
-              <a:rPr lang="en-US" sz="2000" b="1" dirty="0">
+              <a:lnSpc>
+                <a:spcPts val="3400"/>
+              </a:lnSpc>
+              <a:buNone/>
+            </a:pPr>
+            <a:r>
+              <a:rPr lang="en-US" sz="2600" b="1" dirty="0">
                 <a:solidFill>
                   <a:srgbClr val="FFFFFF"/>
                 </a:solidFill>
@@ -5720,87 +5175,68 @@
                 <a:ea typeface="Cambria" pitchFamily="34" charset="-122"/>
                 <a:cs typeface="Cambria" pitchFamily="34" charset="-120"/>
               </a:rPr>
-              <a:t>We built the tool that tells you not to buy.</a:t>
-            </a:r>
-            <a:endParaRPr lang="en-US" sz="2000" dirty="0"/>
-          </a:p>
-        </p:txBody>
-      </p:sp>
-      <p:sp>
-        <p:nvSpPr>
-          <p:cNvPr id="11" name="Text 9"/>
-          <p:cNvSpPr/>
-          <p:nvPr/>
-        </p:nvSpPr>
-        <p:spPr>
-          <a:xfrm>
-            <a:off x="6629400" y="4498848"/>
-            <a:ext cx="4297680" cy="457200"/>
-          </a:xfrm>
-          <a:prstGeom prst="rect">
-            <a:avLst/>
-          </a:prstGeom>
-          <a:noFill/>
-          <a:ln/>
-        </p:spPr>
-        <p:txBody>
-          <a:bodyPr wrap="square" lIns="0" tIns="0" rIns="0" bIns="0" rtlCol="0" anchor="ctr"/>
-          <a:lstStyle/>
+              <a:t>We built the tool</a:t>
+            </a:r>
+            <a:endParaRPr lang="en-US" sz="2600" dirty="0"/>
+          </a:p>
           <a:p>
             <a:pPr indent="0" marL="0">
-              <a:buNone/>
-            </a:pPr>
-            <a:r>
-              <a:rPr lang="en-US" sz="1400" dirty="0">
-                <a:solidFill>
-                  <a:srgbClr val="E3F2E9"/>
-                </a:solidFill>
-                <a:latin typeface="Calibri" pitchFamily="34" charset="0"/>
-                <a:ea typeface="Calibri" pitchFamily="34" charset="-122"/>
-                <a:cs typeface="Calibri" pitchFamily="34" charset="-120"/>
-              </a:rPr>
-              <a:t>Rent-vs-buy says rent when the maths says rent.</a:t>
-            </a:r>
-            <a:endParaRPr lang="en-US" sz="1400" dirty="0"/>
-          </a:p>
-        </p:txBody>
-      </p:sp>
-      <p:sp>
-        <p:nvSpPr>
-          <p:cNvPr id="12" name="Text 10"/>
-          <p:cNvSpPr/>
-          <p:nvPr/>
-        </p:nvSpPr>
-        <p:spPr>
-          <a:xfrm>
-            <a:off x="685800" y="5577840"/>
-            <a:ext cx="10607040" cy="457200"/>
-          </a:xfrm>
-          <a:prstGeom prst="rect">
-            <a:avLst/>
-          </a:prstGeom>
-          <a:noFill/>
-          <a:ln/>
-        </p:spPr>
-        <p:txBody>
-          <a:bodyPr wrap="square" lIns="0" tIns="0" rIns="0" bIns="0" rtlCol="0" anchor="ctr"/>
-          <a:lstStyle/>
-          <a:p>
-            <a:pPr indent="0" marL="0">
-              <a:buNone/>
-            </a:pPr>
-            <a:r>
-              <a:rPr lang="en-US" sz="2100" i="1" dirty="0">
-                <a:solidFill>
-                  <a:srgbClr val="E8B84B"/>
+              <a:lnSpc>
+                <a:spcPts val="3400"/>
+              </a:lnSpc>
+              <a:buNone/>
+            </a:pPr>
+            <a:r>
+              <a:rPr lang="en-US" sz="2600" b="1" dirty="0">
+                <a:solidFill>
+                  <a:srgbClr val="FFFFFF"/>
                 </a:solidFill>
                 <a:latin typeface="Cambria" pitchFamily="34" charset="0"/>
                 <a:ea typeface="Cambria" pitchFamily="34" charset="-122"/>
                 <a:cs typeface="Cambria" pitchFamily="34" charset="-120"/>
               </a:rPr>
-              <a:t>A company built on referral fees can never say that sentence.</a:t>
-            </a:r>
-            <a:endParaRPr lang="en-US" sz="2100" dirty="0"/>
+              <a:t>that says don’t buy.</a:t>
+            </a:r>
+            <a:endParaRPr lang="en-US" sz="2600" dirty="0"/>
+          </a:p>
+        </p:txBody>
+      </p:sp>
+      <p:sp>
+        <p:nvSpPr>
+          <p:cNvPr id="8" name="Text 6"/>
+          <p:cNvSpPr/>
+          <p:nvPr/>
+        </p:nvSpPr>
+        <p:spPr>
+          <a:xfrm>
+            <a:off x="685800" y="5029200"/>
+            <a:ext cx="10607040" cy="640080"/>
+          </a:xfrm>
+          <a:prstGeom prst="rect">
+            <a:avLst/>
+          </a:prstGeom>
+          <a:noFill/>
+          <a:ln/>
+        </p:spPr>
+        <p:txBody>
+          <a:bodyPr wrap="square" lIns="0" tIns="0" rIns="0" bIns="0" rtlCol="0" anchor="ctr"/>
+          <a:lstStyle/>
+          <a:p>
+            <a:pPr indent="0" marL="0">
+              <a:buNone/>
+            </a:pPr>
+            <a:r>
+              <a:rPr lang="en-US" sz="2600" i="1" dirty="0">
+                <a:solidFill>
+                  <a:srgbClr val="E8B84B"/>
+                </a:solidFill>
+                <a:latin typeface="Cambria" pitchFamily="34" charset="0"/>
+                <a:ea typeface="Cambria" pitchFamily="34" charset="-122"/>
+                <a:cs typeface="Cambria" pitchFamily="34" charset="-120"/>
+              </a:rPr>
+              <a:t>A company on referral fees can never say that.</a:t>
+            </a:r>
+            <a:endParaRPr lang="en-US" sz="2600" dirty="0"/>
           </a:p>
         </p:txBody>
       </p:sp>
@@ -5844,8 +5280,8 @@
         </p:nvSpPr>
         <p:spPr>
           <a:xfrm>
-            <a:off x="685800" y="475488"/>
-            <a:ext cx="7315200" cy="274320"/>
+            <a:off x="685800" y="502920"/>
+            <a:ext cx="9144000" cy="274320"/>
           </a:xfrm>
           <a:prstGeom prst="rect">
             <a:avLst/>
@@ -5883,8 +5319,8 @@
         </p:nvSpPr>
         <p:spPr>
           <a:xfrm>
-            <a:off x="685800" y="804672"/>
-            <a:ext cx="10817352" cy="868680"/>
+            <a:off x="685800" y="914400"/>
+            <a:ext cx="10607040" cy="822960"/>
           </a:xfrm>
           <a:prstGeom prst="rect">
             <a:avLst/>
@@ -5908,7 +5344,7 @@
                 <a:ea typeface="Cambria" pitchFamily="34" charset="-122"/>
                 <a:cs typeface="Cambria" pitchFamily="34" charset="-120"/>
               </a:rPr>
-              <a:t>Built, shipped, and live</a:t>
+              <a:t>Built, shipped, live</a:t>
             </a:r>
             <a:endParaRPr lang="en-US" sz="4000" dirty="0"/>
           </a:p>
@@ -5922,12 +5358,12 @@
         </p:nvSpPr>
         <p:spPr>
           <a:xfrm>
-            <a:off x="685800" y="1965960"/>
-            <a:ext cx="3364992" cy="1920240"/>
+            <a:off x="685800" y="2286000"/>
+            <a:ext cx="3364992" cy="1874520"/>
           </a:xfrm>
           <a:prstGeom prst="roundRect">
             <a:avLst>
-              <a:gd name="adj" fmla="val 7619"/>
+              <a:gd name="adj" fmla="val 7805"/>
             </a:avLst>
           </a:prstGeom>
           <a:solidFill>
@@ -5949,8 +5385,8 @@
         </p:nvSpPr>
         <p:spPr>
           <a:xfrm>
-            <a:off x="1051560" y="2212848"/>
-            <a:ext cx="2651760" cy="777240"/>
+            <a:off x="1097280" y="2560320"/>
+            <a:ext cx="2651760" cy="822960"/>
           </a:xfrm>
           <a:prstGeom prst="rect">
             <a:avLst/>
@@ -5966,7 +5402,7 @@
               <a:buNone/>
             </a:pPr>
             <a:r>
-              <a:rPr lang="en-US" sz="4200" b="1" dirty="0">
+              <a:rPr lang="en-US" sz="4600" b="1" dirty="0">
                 <a:solidFill>
                   <a:srgbClr val="3FA672"/>
                 </a:solidFill>
@@ -5976,7 +5412,7 @@
               </a:rPr>
               <a:t>467</a:t>
             </a:r>
-            <a:endParaRPr lang="en-US" sz="4200" dirty="0"/>
+            <a:endParaRPr lang="en-US" sz="4600" dirty="0"/>
           </a:p>
         </p:txBody>
       </p:sp>
@@ -5988,8 +5424,8 @@
         </p:nvSpPr>
         <p:spPr>
           <a:xfrm>
-            <a:off x="1051560" y="3035808"/>
-            <a:ext cx="2697480" cy="685800"/>
+            <a:off x="1097280" y="3429000"/>
+            <a:ext cx="2697480" cy="365760"/>
           </a:xfrm>
           <a:prstGeom prst="rect">
             <a:avLst/>
@@ -6002,13 +5438,10 @@
           <a:lstStyle/>
           <a:p>
             <a:pPr indent="0" marL="0">
-              <a:lnSpc>
-                <a:spcPts val="1800"/>
-              </a:lnSpc>
-              <a:buNone/>
-            </a:pPr>
-            <a:r>
-              <a:rPr lang="en-US" sz="1350" dirty="0">
+              <a:buNone/>
+            </a:pPr>
+            <a:r>
+              <a:rPr lang="en-US" sz="1500" dirty="0">
                 <a:solidFill>
                   <a:srgbClr val="5C6F66"/>
                 </a:solidFill>
@@ -6016,29 +5449,9 @@
                 <a:ea typeface="Calibri" pitchFamily="34" charset="-122"/>
                 <a:cs typeface="Calibri" pitchFamily="34" charset="-120"/>
               </a:rPr>
-              <a:t>Canadian municipalities</a:t>
-            </a:r>
-            <a:endParaRPr lang="en-US" sz="1350" dirty="0"/>
-          </a:p>
-          <a:p>
-            <a:pPr indent="0" marL="0">
-              <a:lnSpc>
-                <a:spcPts val="1800"/>
-              </a:lnSpc>
-              <a:buNone/>
-            </a:pPr>
-            <a:r>
-              <a:rPr lang="en-US" sz="1350" dirty="0">
-                <a:solidFill>
-                  <a:srgbClr val="5C6F66"/>
-                </a:solidFill>
-                <a:latin typeface="Calibri" pitchFamily="34" charset="0"/>
-                <a:ea typeface="Calibri" pitchFamily="34" charset="-122"/>
-                <a:cs typeface="Calibri" pitchFamily="34" charset="-120"/>
-              </a:rPr>
-              <a:t>in the app today</a:t>
-            </a:r>
-            <a:endParaRPr lang="en-US" sz="1350" dirty="0"/>
+              <a:t>municipalities</a:t>
+            </a:r>
+            <a:endParaRPr lang="en-US" sz="1500" dirty="0"/>
           </a:p>
         </p:txBody>
       </p:sp>
@@ -6050,12 +5463,12 @@
         </p:nvSpPr>
         <p:spPr>
           <a:xfrm>
-            <a:off x="4306824" y="1965960"/>
-            <a:ext cx="3364992" cy="1920240"/>
+            <a:off x="4306824" y="2286000"/>
+            <a:ext cx="3364992" cy="1874520"/>
           </a:xfrm>
           <a:prstGeom prst="roundRect">
             <a:avLst>
-              <a:gd name="adj" fmla="val 7619"/>
+              <a:gd name="adj" fmla="val 7805"/>
             </a:avLst>
           </a:prstGeom>
           <a:solidFill>
@@ -6077,8 +5490,8 @@
         </p:nvSpPr>
         <p:spPr>
           <a:xfrm>
-            <a:off x="4672584" y="2212848"/>
-            <a:ext cx="2651760" cy="777240"/>
+            <a:off x="4718304" y="2560320"/>
+            <a:ext cx="2651760" cy="822960"/>
           </a:xfrm>
           <a:prstGeom prst="rect">
             <a:avLst/>
@@ -6094,7 +5507,7 @@
               <a:buNone/>
             </a:pPr>
             <a:r>
-              <a:rPr lang="en-US" sz="4200" b="1" dirty="0">
+              <a:rPr lang="en-US" sz="4600" b="1" dirty="0">
                 <a:solidFill>
                   <a:srgbClr val="3FA672"/>
                 </a:solidFill>
@@ -6104,7 +5517,7 @@
               </a:rPr>
               <a:t>~$0</a:t>
             </a:r>
-            <a:endParaRPr lang="en-US" sz="4200" dirty="0"/>
+            <a:endParaRPr lang="en-US" sz="4600" dirty="0"/>
           </a:p>
         </p:txBody>
       </p:sp>
@@ -6116,8 +5529,8 @@
         </p:nvSpPr>
         <p:spPr>
           <a:xfrm>
-            <a:off x="4672584" y="3035808"/>
-            <a:ext cx="2697480" cy="685800"/>
+            <a:off x="4718304" y="3429000"/>
+            <a:ext cx="2697480" cy="365760"/>
           </a:xfrm>
           <a:prstGeom prst="rect">
             <a:avLst/>
@@ -6130,13 +5543,10 @@
           <a:lstStyle/>
           <a:p>
             <a:pPr indent="0" marL="0">
-              <a:lnSpc>
-                <a:spcPts val="1800"/>
-              </a:lnSpc>
-              <a:buNone/>
-            </a:pPr>
-            <a:r>
-              <a:rPr lang="en-US" sz="1350" dirty="0">
+              <a:buNone/>
+            </a:pPr>
+            <a:r>
+              <a:rPr lang="en-US" sz="1500" dirty="0">
                 <a:solidFill>
                   <a:srgbClr val="5C6F66"/>
                 </a:solidFill>
@@ -6144,29 +5554,9 @@
                 <a:ea typeface="Calibri" pitchFamily="34" charset="-122"/>
                 <a:cs typeface="Calibri" pitchFamily="34" charset="-120"/>
               </a:rPr>
-              <a:t>marginal cost</a:t>
-            </a:r>
-            <a:endParaRPr lang="en-US" sz="1350" dirty="0"/>
-          </a:p>
-          <a:p>
-            <a:pPr indent="0" marL="0">
-              <a:lnSpc>
-                <a:spcPts val="1800"/>
-              </a:lnSpc>
-              <a:buNone/>
-            </a:pPr>
-            <a:r>
-              <a:rPr lang="en-US" sz="1350" dirty="0">
-                <a:solidFill>
-                  <a:srgbClr val="5C6F66"/>
-                </a:solidFill>
-                <a:latin typeface="Calibri" pitchFamily="34" charset="0"/>
-                <a:ea typeface="Calibri" pitchFamily="34" charset="-122"/>
-                <a:cs typeface="Calibri" pitchFamily="34" charset="-120"/>
-              </a:rPr>
-              <a:t>per new user</a:t>
-            </a:r>
-            <a:endParaRPr lang="en-US" sz="1350" dirty="0"/>
+              <a:t>cost per user</a:t>
+            </a:r>
+            <a:endParaRPr lang="en-US" sz="1500" dirty="0"/>
           </a:p>
         </p:txBody>
       </p:sp>
@@ -6178,12 +5568,12 @@
         </p:nvSpPr>
         <p:spPr>
           <a:xfrm>
-            <a:off x="7927848" y="1965960"/>
-            <a:ext cx="3364992" cy="1920240"/>
+            <a:off x="7927848" y="2286000"/>
+            <a:ext cx="3364992" cy="1874520"/>
           </a:xfrm>
           <a:prstGeom prst="roundRect">
             <a:avLst>
-              <a:gd name="adj" fmla="val 7619"/>
+              <a:gd name="adj" fmla="val 7805"/>
             </a:avLst>
           </a:prstGeom>
           <a:solidFill>
@@ -6205,8 +5595,8 @@
         </p:nvSpPr>
         <p:spPr>
           <a:xfrm>
-            <a:off x="8293608" y="2212848"/>
-            <a:ext cx="2651760" cy="777240"/>
+            <a:off x="8339328" y="2560320"/>
+            <a:ext cx="2651760" cy="822960"/>
           </a:xfrm>
           <a:prstGeom prst="rect">
             <a:avLst/>
@@ -6222,7 +5612,7 @@
               <a:buNone/>
             </a:pPr>
             <a:r>
-              <a:rPr lang="en-US" sz="4200" b="1" dirty="0">
+              <a:rPr lang="en-US" sz="4600" b="1" dirty="0">
                 <a:solidFill>
                   <a:srgbClr val="3FA672"/>
                 </a:solidFill>
@@ -6232,7 +5622,7 @@
               </a:rPr>
               <a:t>1</a:t>
             </a:r>
-            <a:endParaRPr lang="en-US" sz="4200" dirty="0"/>
+            <a:endParaRPr lang="en-US" sz="4600" dirty="0"/>
           </a:p>
         </p:txBody>
       </p:sp>
@@ -6244,8 +5634,8 @@
         </p:nvSpPr>
         <p:spPr>
           <a:xfrm>
-            <a:off x="8293608" y="3035808"/>
-            <a:ext cx="2697480" cy="685800"/>
+            <a:off x="8339328" y="3429000"/>
+            <a:ext cx="2697480" cy="365760"/>
           </a:xfrm>
           <a:prstGeom prst="rect">
             <a:avLst/>
@@ -6258,13 +5648,10 @@
           <a:lstStyle/>
           <a:p>
             <a:pPr indent="0" marL="0">
-              <a:lnSpc>
-                <a:spcPts val="1800"/>
-              </a:lnSpc>
-              <a:buNone/>
-            </a:pPr>
-            <a:r>
-              <a:rPr lang="en-US" sz="1350" dirty="0">
+              <a:buNone/>
+            </a:pPr>
+            <a:r>
+              <a:rPr lang="en-US" sz="1500" dirty="0">
                 <a:solidFill>
                   <a:srgbClr val="5C6F66"/>
                 </a:solidFill>
@@ -6272,29 +5659,9 @@
                 <a:ea typeface="Calibri" pitchFamily="34" charset="-122"/>
                 <a:cs typeface="Calibri" pitchFamily="34" charset="-120"/>
               </a:rPr>
-              <a:t>founder — built and</a:t>
-            </a:r>
-            <a:endParaRPr lang="en-US" sz="1350" dirty="0"/>
-          </a:p>
-          <a:p>
-            <a:pPr indent="0" marL="0">
-              <a:lnSpc>
-                <a:spcPts val="1800"/>
-              </a:lnSpc>
-              <a:buNone/>
-            </a:pPr>
-            <a:r>
-              <a:rPr lang="en-US" sz="1350" dirty="0">
-                <a:solidFill>
-                  <a:srgbClr val="5C6F66"/>
-                </a:solidFill>
-                <a:latin typeface="Calibri" pitchFamily="34" charset="0"/>
-                <a:ea typeface="Calibri" pitchFamily="34" charset="-122"/>
-                <a:cs typeface="Calibri" pitchFamily="34" charset="-120"/>
-              </a:rPr>
-              <a:t>shipped it end to end</a:t>
-            </a:r>
-            <a:endParaRPr lang="en-US" sz="1350" dirty="0"/>
+              <a:t>founder</a:t>
+            </a:r>
+            <a:endParaRPr lang="en-US" sz="1500" dirty="0"/>
           </a:p>
         </p:txBody>
       </p:sp>
@@ -6306,12 +5673,12 @@
         </p:nvSpPr>
         <p:spPr>
           <a:xfrm>
-            <a:off x="685800" y="4160520"/>
-            <a:ext cx="10607040" cy="1600200"/>
+            <a:off x="685800" y="4480560"/>
+            <a:ext cx="10607040" cy="1097280"/>
           </a:xfrm>
           <a:prstGeom prst="roundRect">
             <a:avLst>
-              <a:gd name="adj" fmla="val 9143"/>
+              <a:gd name="adj" fmla="val 13333"/>
             </a:avLst>
           </a:prstGeom>
           <a:solidFill>
@@ -6333,8 +5700,8 @@
         </p:nvSpPr>
         <p:spPr>
           <a:xfrm>
-            <a:off x="1143000" y="4407408"/>
-            <a:ext cx="9692640" cy="411480"/>
+            <a:off x="1234440" y="4480560"/>
+            <a:ext cx="9509760" cy="1097280"/>
           </a:xfrm>
           <a:prstGeom prst="rect">
             <a:avLst/>
@@ -6350,7 +5717,7 @@
               <a:buNone/>
             </a:pPr>
             <a:r>
-              <a:rPr lang="en-US" sz="2100" b="1" dirty="0">
+              <a:rPr lang="en-US" sz="2600" b="1" dirty="0">
                 <a:solidFill>
                   <a:srgbClr val="1E4D3B"/>
                 </a:solidFill>
@@ -6360,49 +5727,7 @@
               </a:rPr>
               <a:t>A new country is a rulebook, not a rebuild.</a:t>
             </a:r>
-            <a:endParaRPr lang="en-US" sz="2100" dirty="0"/>
-          </a:p>
-        </p:txBody>
-      </p:sp>
-      <p:sp>
-        <p:nvSpPr>
-          <p:cNvPr id="15" name="Text 13"/>
-          <p:cNvSpPr/>
-          <p:nvPr/>
-        </p:nvSpPr>
-        <p:spPr>
-          <a:xfrm>
-            <a:off x="1143000" y="4892040"/>
-            <a:ext cx="9692640" cy="731520"/>
-          </a:xfrm>
-          <a:prstGeom prst="rect">
-            <a:avLst/>
-          </a:prstGeom>
-          <a:noFill/>
-          <a:ln/>
-        </p:spPr>
-        <p:txBody>
-          <a:bodyPr wrap="square" lIns="0" tIns="0" rIns="0" bIns="0" rtlCol="0" anchor="ctr"/>
-          <a:lstStyle/>
-          <a:p>
-            <a:pPr indent="0" marL="0">
-              <a:lnSpc>
-                <a:spcPts val="2100"/>
-              </a:lnSpc>
-              <a:buNone/>
-            </a:pPr>
-            <a:r>
-              <a:rPr lang="en-US" sz="1450" dirty="0">
-                <a:solidFill>
-                  <a:srgbClr val="17302A"/>
-                </a:solidFill>
-                <a:latin typeface="Calibri" pitchFamily="34" charset="0"/>
-                <a:ea typeface="Calibri" pitchFamily="34" charset="-122"/>
-                <a:cs typeface="Calibri" pitchFamily="34" charset="-120"/>
-              </a:rPr>
-              <a:t>Live at keydate.ca  ·  incorporated  ·  privacy policy, terms and content moderation in place before the first user — because I’d rather be trusted than fast.</a:t>
-            </a:r>
-            <a:endParaRPr lang="en-US" sz="1450" dirty="0"/>
+            <a:endParaRPr lang="en-US" sz="2600" dirty="0"/>
           </a:p>
         </p:txBody>
       </p:sp>

</xml_diff>

<commit_message>
Set the pitch deck in Montserrat
Cambria and Calibri read as the Office defaults they are. Montserrat is a
geometric sans with a large x-height, which is what slide type wants —
one family across the deck with weight carrying the contrast instead of a
serif/sans pairing.

Montserrat sets noticeably wider than Cambria at the same point size, so
every display size above 24pt comes down about 12%. Verified by installing
the real font locally and re-rendering all ten slides rather than guessing
at substituted metrics — no line wraps or overflows anywhere.

Documents the catch: Montserrat is not bundled with Office, so the README
now says to install it on the presenting machine or export to PDF, and
names Century Gothic as the always-present fallback.

Co-Authored-By: Claude Opus 5 <noreply@anthropic.com>
Claude-Session: https://claude.ai/code/session_019WKzGoyENXa8KtvmiHdCC2
</commit_message>
<xml_diff>
--- a/apps/keydate/pitch/KeyDate-JCI-Edmonton.pptx
+++ b/apps/keydate/pitch/KeyDate-JCI-Edmonton.pptx
@@ -1798,13 +1798,13 @@
               <a:buNone/>
             </a:pPr>
             <a:r>
-              <a:rPr lang="en-US" sz="6600" b="1" dirty="0">
+              <a:rPr lang="en-US" sz="5800" b="1" dirty="0">
                 <a:solidFill>
                   <a:srgbClr val="FFFFFF"/>
                 </a:solidFill>
-                <a:latin typeface="Cambria" pitchFamily="34" charset="0"/>
-                <a:ea typeface="Cambria" pitchFamily="34" charset="-122"/>
-                <a:cs typeface="Cambria" pitchFamily="34" charset="-120"/>
+                <a:latin typeface="Montserrat" pitchFamily="34" charset="0"/>
+                <a:ea typeface="Montserrat" pitchFamily="34" charset="-122"/>
+                <a:cs typeface="Montserrat" pitchFamily="34" charset="-120"/>
               </a:rPr>
               <a:t>Key</a:t>
             </a:r>
@@ -1812,17 +1812,17 @@
               <a:buNone/>
             </a:pPr>
             <a:r>
-              <a:rPr lang="en-US" sz="6600" b="1" dirty="0">
+              <a:rPr lang="en-US" sz="5800" b="1" dirty="0">
                 <a:solidFill>
                   <a:srgbClr val="3FA672"/>
                 </a:solidFill>
-                <a:latin typeface="Cambria" pitchFamily="34" charset="0"/>
-                <a:ea typeface="Cambria" pitchFamily="34" charset="-122"/>
-                <a:cs typeface="Cambria" pitchFamily="34" charset="-120"/>
+                <a:latin typeface="Montserrat" pitchFamily="34" charset="0"/>
+                <a:ea typeface="Montserrat" pitchFamily="34" charset="-122"/>
+                <a:cs typeface="Montserrat" pitchFamily="34" charset="-120"/>
               </a:rPr>
               <a:t>Date</a:t>
             </a:r>
-            <a:endParaRPr lang="en-US" sz="6600" dirty="0"/>
+            <a:endParaRPr lang="en-US" sz="5800" dirty="0"/>
           </a:p>
         </p:txBody>
       </p:sp>
@@ -1854,17 +1854,17 @@
               <a:buNone/>
             </a:pPr>
             <a:r>
-              <a:rPr lang="en-US" sz="3200" dirty="0">
+              <a:rPr lang="en-US" sz="2800" dirty="0">
                 <a:solidFill>
                   <a:srgbClr val="E3F2E9"/>
                 </a:solidFill>
-                <a:latin typeface="Cambria" pitchFamily="34" charset="0"/>
-                <a:ea typeface="Cambria" pitchFamily="34" charset="-122"/>
-                <a:cs typeface="Cambria" pitchFamily="34" charset="-120"/>
+                <a:latin typeface="Montserrat" pitchFamily="34" charset="0"/>
+                <a:ea typeface="Montserrat" pitchFamily="34" charset="-122"/>
+                <a:cs typeface="Montserrat" pitchFamily="34" charset="-120"/>
               </a:rPr>
               <a:t>Owning a home isn’t impossible.</a:t>
             </a:r>
-            <a:endParaRPr lang="en-US" sz="3200" dirty="0"/>
+            <a:endParaRPr lang="en-US" sz="2800" dirty="0"/>
           </a:p>
           <a:p>
             <a:pPr indent="0" marL="0">
@@ -1874,17 +1874,17 @@
               <a:buNone/>
             </a:pPr>
             <a:r>
-              <a:rPr lang="en-US" sz="3200" dirty="0">
+              <a:rPr lang="en-US" sz="2800" dirty="0">
                 <a:solidFill>
                   <a:srgbClr val="E3F2E9"/>
                 </a:solidFill>
-                <a:latin typeface="Cambria" pitchFamily="34" charset="0"/>
-                <a:ea typeface="Cambria" pitchFamily="34" charset="-122"/>
-                <a:cs typeface="Cambria" pitchFamily="34" charset="-120"/>
+                <a:latin typeface="Montserrat" pitchFamily="34" charset="0"/>
+                <a:ea typeface="Montserrat" pitchFamily="34" charset="-122"/>
+                <a:cs typeface="Montserrat" pitchFamily="34" charset="-120"/>
               </a:rPr>
               <a:t>It has a date.</a:t>
             </a:r>
-            <a:endParaRPr lang="en-US" sz="3200" dirty="0"/>
+            <a:endParaRPr lang="en-US" sz="2800" dirty="0"/>
           </a:p>
         </p:txBody>
       </p:sp>
@@ -1917,9 +1917,9 @@
                 <a:solidFill>
                   <a:srgbClr val="E3F2E9"/>
                 </a:solidFill>
-                <a:latin typeface="Calibri" pitchFamily="34" charset="0"/>
-                <a:ea typeface="Calibri" pitchFamily="34" charset="-122"/>
-                <a:cs typeface="Calibri" pitchFamily="34" charset="-120"/>
+                <a:latin typeface="Montserrat" pitchFamily="34" charset="0"/>
+                <a:ea typeface="Montserrat" pitchFamily="34" charset="-122"/>
+                <a:cs typeface="Montserrat" pitchFamily="34" charset="-120"/>
               </a:rPr>
               <a:t>JCI Edmonton  ·  Creative Young Entrepreneur</a:t>
             </a:r>
@@ -1956,9 +1956,9 @@
                 <a:solidFill>
                   <a:srgbClr val="E8B84B"/>
                 </a:solidFill>
-                <a:latin typeface="Calibri" pitchFamily="34" charset="0"/>
-                <a:ea typeface="Calibri" pitchFamily="34" charset="-122"/>
-                <a:cs typeface="Calibri" pitchFamily="34" charset="-120"/>
+                <a:latin typeface="Montserrat" pitchFamily="34" charset="0"/>
+                <a:ea typeface="Montserrat" pitchFamily="34" charset="-122"/>
+                <a:cs typeface="Montserrat" pitchFamily="34" charset="-120"/>
               </a:rPr>
               <a:t>keydate.ca</a:t>
             </a:r>
@@ -2103,17 +2103,17 @@
               <a:buNone/>
             </a:pPr>
             <a:r>
-              <a:rPr lang="en-US" sz="4000" dirty="0">
+              <a:rPr lang="en-US" sz="3500" dirty="0">
                 <a:solidFill>
                   <a:srgbClr val="E3F2E9"/>
                 </a:solidFill>
-                <a:latin typeface="Cambria" pitchFamily="34" charset="0"/>
-                <a:ea typeface="Cambria" pitchFamily="34" charset="-122"/>
-                <a:cs typeface="Cambria" pitchFamily="34" charset="-120"/>
+                <a:latin typeface="Montserrat" pitchFamily="34" charset="0"/>
+                <a:ea typeface="Montserrat" pitchFamily="34" charset="-122"/>
+                <a:cs typeface="Montserrat" pitchFamily="34" charset="-120"/>
               </a:rPr>
               <a:t>It just doesn’t have</a:t>
             </a:r>
-            <a:endParaRPr lang="en-US" sz="4000" dirty="0"/>
+            <a:endParaRPr lang="en-US" sz="3500" dirty="0"/>
           </a:p>
           <a:p>
             <a:pPr indent="0" marL="0">
@@ -2123,17 +2123,17 @@
               <a:buNone/>
             </a:pPr>
             <a:r>
-              <a:rPr lang="en-US" sz="4000" dirty="0">
+              <a:rPr lang="en-US" sz="3500" dirty="0">
                 <a:solidFill>
                   <a:srgbClr val="E3F2E9"/>
                 </a:solidFill>
-                <a:latin typeface="Cambria" pitchFamily="34" charset="0"/>
-                <a:ea typeface="Cambria" pitchFamily="34" charset="-122"/>
-                <a:cs typeface="Cambria" pitchFamily="34" charset="-120"/>
+                <a:latin typeface="Montserrat" pitchFamily="34" charset="0"/>
+                <a:ea typeface="Montserrat" pitchFamily="34" charset="-122"/>
+                <a:cs typeface="Montserrat" pitchFamily="34" charset="-120"/>
               </a:rPr>
               <a:t>a date yet.</a:t>
             </a:r>
-            <a:endParaRPr lang="en-US" sz="4000" dirty="0"/>
+            <a:endParaRPr lang="en-US" sz="3500" dirty="0"/>
           </a:p>
         </p:txBody>
       </p:sp>
@@ -2162,17 +2162,17 @@
               <a:buNone/>
             </a:pPr>
             <a:r>
-              <a:rPr lang="en-US" sz="5400" b="1" dirty="0">
+              <a:rPr lang="en-US" sz="4800" b="1" dirty="0">
                 <a:solidFill>
                   <a:srgbClr val="E8B84B"/>
                 </a:solidFill>
-                <a:latin typeface="Cambria" pitchFamily="34" charset="0"/>
-                <a:ea typeface="Cambria" pitchFamily="34" charset="-122"/>
-                <a:cs typeface="Cambria" pitchFamily="34" charset="-120"/>
+                <a:latin typeface="Montserrat" pitchFamily="34" charset="0"/>
+                <a:ea typeface="Montserrat" pitchFamily="34" charset="-122"/>
+                <a:cs typeface="Montserrat" pitchFamily="34" charset="-120"/>
               </a:rPr>
               <a:t>We’re giving it one.</a:t>
             </a:r>
-            <a:endParaRPr lang="en-US" sz="5400" dirty="0"/>
+            <a:endParaRPr lang="en-US" sz="4800" dirty="0"/>
           </a:p>
         </p:txBody>
       </p:sp>
@@ -2205,9 +2205,9 @@
                 <a:solidFill>
                   <a:srgbClr val="E8B84B"/>
                 </a:solidFill>
-                <a:latin typeface="Calibri" pitchFamily="34" charset="0"/>
-                <a:ea typeface="Calibri" pitchFamily="34" charset="-122"/>
-                <a:cs typeface="Calibri" pitchFamily="34" charset="-120"/>
+                <a:latin typeface="Montserrat" pitchFamily="34" charset="0"/>
+                <a:ea typeface="Montserrat" pitchFamily="34" charset="-122"/>
+                <a:cs typeface="Montserrat" pitchFamily="34" charset="-120"/>
               </a:rPr>
               <a:t>keydate.ca</a:t>
             </a:r>
@@ -2244,9 +2244,9 @@
                 <a:solidFill>
                   <a:srgbClr val="E3F2E9"/>
                 </a:solidFill>
-                <a:latin typeface="Calibri" pitchFamily="34" charset="0"/>
-                <a:ea typeface="Calibri" pitchFamily="34" charset="-122"/>
-                <a:cs typeface="Calibri" pitchFamily="34" charset="-120"/>
+                <a:latin typeface="Montserrat" pitchFamily="34" charset="0"/>
+                <a:ea typeface="Montserrat" pitchFamily="34" charset="-122"/>
+                <a:cs typeface="Montserrat" pitchFamily="34" charset="-120"/>
               </a:rPr>
               <a:t>Edmonton beta opens this week</a:t>
             </a:r>
@@ -2315,9 +2315,9 @@
                 <a:solidFill>
                   <a:srgbClr val="3FA672"/>
                 </a:solidFill>
-                <a:latin typeface="Calibri" pitchFamily="34" charset="0"/>
-                <a:ea typeface="Calibri" pitchFamily="34" charset="-122"/>
-                <a:cs typeface="Calibri" pitchFamily="34" charset="-120"/>
+                <a:latin typeface="Montserrat" pitchFamily="34" charset="0"/>
+                <a:ea typeface="Montserrat" pitchFamily="34" charset="-122"/>
+                <a:cs typeface="Montserrat" pitchFamily="34" charset="-120"/>
               </a:rPr>
               <a:t>WHY I BUILT THIS</a:t>
             </a:r>
@@ -2350,17 +2350,17 @@
               <a:buNone/>
             </a:pPr>
             <a:r>
-              <a:rPr lang="en-US" sz="5000" b="1" dirty="0">
+              <a:rPr lang="en-US" sz="4400" b="1" dirty="0">
                 <a:solidFill>
                   <a:srgbClr val="17302A"/>
                 </a:solidFill>
-                <a:latin typeface="Cambria" pitchFamily="34" charset="0"/>
-                <a:ea typeface="Cambria" pitchFamily="34" charset="-122"/>
-                <a:cs typeface="Cambria" pitchFamily="34" charset="-120"/>
+                <a:latin typeface="Montserrat" pitchFamily="34" charset="0"/>
+                <a:ea typeface="Montserrat" pitchFamily="34" charset="-122"/>
+                <a:cs typeface="Montserrat" pitchFamily="34" charset="-120"/>
               </a:rPr>
               <a:t>I bought my first place.</a:t>
             </a:r>
-            <a:endParaRPr lang="en-US" sz="5000" dirty="0"/>
+            <a:endParaRPr lang="en-US" sz="4400" dirty="0"/>
           </a:p>
         </p:txBody>
       </p:sp>
@@ -2389,17 +2389,17 @@
               <a:buNone/>
             </a:pPr>
             <a:r>
-              <a:rPr lang="en-US" sz="4200" b="1" dirty="0">
+              <a:rPr lang="en-US" sz="3700" b="1" dirty="0">
                 <a:solidFill>
                   <a:srgbClr val="1E4D3B"/>
                 </a:solidFill>
-                <a:latin typeface="Cambria" pitchFamily="34" charset="0"/>
-                <a:ea typeface="Cambria" pitchFamily="34" charset="-122"/>
-                <a:cs typeface="Cambria" pitchFamily="34" charset="-120"/>
+                <a:latin typeface="Montserrat" pitchFamily="34" charset="0"/>
+                <a:ea typeface="Montserrat" pitchFamily="34" charset="-122"/>
+                <a:cs typeface="Montserrat" pitchFamily="34" charset="-120"/>
               </a:rPr>
               <a:t>I was guessing the whole way.</a:t>
             </a:r>
-            <a:endParaRPr lang="en-US" sz="4200" dirty="0"/>
+            <a:endParaRPr lang="en-US" sz="3700" dirty="0"/>
           </a:p>
         </p:txBody>
       </p:sp>
@@ -2459,9 +2459,9 @@
                 <a:solidFill>
                   <a:srgbClr val="1E4D3B"/>
                 </a:solidFill>
-                <a:latin typeface="Calibri" pitchFamily="34" charset="0"/>
-                <a:ea typeface="Calibri" pitchFamily="34" charset="-122"/>
-                <a:cs typeface="Calibri" pitchFamily="34" charset="-120"/>
+                <a:latin typeface="Montserrat" pitchFamily="34" charset="0"/>
+                <a:ea typeface="Montserrat" pitchFamily="34" charset="-122"/>
+                <a:cs typeface="Montserrat" pitchFamily="34" charset="-120"/>
               </a:rPr>
               <a:t>Spreadsheets</a:t>
             </a:r>
@@ -2525,9 +2525,9 @@
                 <a:solidFill>
                   <a:srgbClr val="1E4D3B"/>
                 </a:solidFill>
-                <a:latin typeface="Calibri" pitchFamily="34" charset="0"/>
-                <a:ea typeface="Calibri" pitchFamily="34" charset="-122"/>
-                <a:cs typeface="Calibri" pitchFamily="34" charset="-120"/>
+                <a:latin typeface="Montserrat" pitchFamily="34" charset="0"/>
+                <a:ea typeface="Montserrat" pitchFamily="34" charset="-122"/>
+                <a:cs typeface="Montserrat" pitchFamily="34" charset="-120"/>
               </a:rPr>
               <a:t>Contradictory advice</a:t>
             </a:r>
@@ -2591,9 +2591,9 @@
                 <a:solidFill>
                   <a:srgbClr val="1E4D3B"/>
                 </a:solidFill>
-                <a:latin typeface="Calibri" pitchFamily="34" charset="0"/>
-                <a:ea typeface="Calibri" pitchFamily="34" charset="-122"/>
-                <a:cs typeface="Calibri" pitchFamily="34" charset="-120"/>
+                <a:latin typeface="Montserrat" pitchFamily="34" charset="0"/>
+                <a:ea typeface="Montserrat" pitchFamily="34" charset="-122"/>
+                <a:cs typeface="Montserrat" pitchFamily="34" charset="-120"/>
               </a:rPr>
               <a:t>A goal that kept moving</a:t>
             </a:r>
@@ -2735,17 +2735,17 @@
               <a:buNone/>
             </a:pPr>
             <a:r>
-              <a:rPr lang="en-US" sz="5000" b="1" dirty="0">
+              <a:rPr lang="en-US" sz="4400" b="1" dirty="0">
                 <a:solidFill>
                   <a:srgbClr val="E8B84B"/>
                 </a:solidFill>
-                <a:latin typeface="Cambria" pitchFamily="34" charset="0"/>
-                <a:ea typeface="Cambria" pitchFamily="34" charset="-122"/>
-                <a:cs typeface="Cambria" pitchFamily="34" charset="-120"/>
+                <a:latin typeface="Montserrat" pitchFamily="34" charset="0"/>
+                <a:ea typeface="Montserrat" pitchFamily="34" charset="-122"/>
+                <a:cs typeface="Montserrat" pitchFamily="34" charset="-120"/>
               </a:rPr>
               <a:t>Nobody could tell me when.</a:t>
             </a:r>
-            <a:endParaRPr lang="en-US" sz="5000" dirty="0"/>
+            <a:endParaRPr lang="en-US" sz="4400" dirty="0"/>
           </a:p>
         </p:txBody>
       </p:sp>
@@ -2799,17 +2799,17 @@
               <a:buNone/>
             </a:pPr>
             <a:r>
-              <a:rPr lang="en-US" sz="2800" dirty="0">
+              <a:rPr lang="en-US" sz="2500" dirty="0">
                 <a:solidFill>
                   <a:srgbClr val="E3F2E9"/>
                 </a:solidFill>
-                <a:latin typeface="Cambria" pitchFamily="34" charset="0"/>
-                <a:ea typeface="Cambria" pitchFamily="34" charset="-122"/>
-                <a:cs typeface="Cambria" pitchFamily="34" charset="-120"/>
+                <a:latin typeface="Montserrat" pitchFamily="34" charset="0"/>
+                <a:ea typeface="Montserrat" pitchFamily="34" charset="-122"/>
+                <a:cs typeface="Montserrat" pitchFamily="34" charset="-120"/>
               </a:rPr>
               <a:t>How much do I actually need?</a:t>
             </a:r>
-            <a:endParaRPr lang="en-US" sz="2800" dirty="0"/>
+            <a:endParaRPr lang="en-US" sz="2500" dirty="0"/>
           </a:p>
         </p:txBody>
       </p:sp>
@@ -2863,17 +2863,17 @@
               <a:buNone/>
             </a:pPr>
             <a:r>
-              <a:rPr lang="en-US" sz="2800" dirty="0">
+              <a:rPr lang="en-US" sz="2500" dirty="0">
                 <a:solidFill>
                   <a:srgbClr val="E3F2E9"/>
                 </a:solidFill>
-                <a:latin typeface="Cambria" pitchFamily="34" charset="0"/>
-                <a:ea typeface="Cambria" pitchFamily="34" charset="-122"/>
-                <a:cs typeface="Cambria" pitchFamily="34" charset="-120"/>
+                <a:latin typeface="Montserrat" pitchFamily="34" charset="0"/>
+                <a:ea typeface="Montserrat" pitchFamily="34" charset="-122"/>
+                <a:cs typeface="Montserrat" pitchFamily="34" charset="-120"/>
               </a:rPr>
               <a:t>Am I even close?</a:t>
             </a:r>
-            <a:endParaRPr lang="en-US" sz="2800" dirty="0"/>
+            <a:endParaRPr lang="en-US" sz="2500" dirty="0"/>
           </a:p>
         </p:txBody>
       </p:sp>
@@ -2927,17 +2927,17 @@
               <a:buNone/>
             </a:pPr>
             <a:r>
-              <a:rPr lang="en-US" sz="2800" dirty="0">
+              <a:rPr lang="en-US" sz="2500" dirty="0">
                 <a:solidFill>
                   <a:srgbClr val="E3F2E9"/>
                 </a:solidFill>
-                <a:latin typeface="Cambria" pitchFamily="34" charset="0"/>
-                <a:ea typeface="Cambria" pitchFamily="34" charset="-122"/>
-                <a:cs typeface="Cambria" pitchFamily="34" charset="-120"/>
+                <a:latin typeface="Montserrat" pitchFamily="34" charset="0"/>
+                <a:ea typeface="Montserrat" pitchFamily="34" charset="-122"/>
+                <a:cs typeface="Montserrat" pitchFamily="34" charset="-120"/>
               </a:rPr>
               <a:t>Is this the year, or five years away?</a:t>
             </a:r>
-            <a:endParaRPr lang="en-US" sz="2800" dirty="0"/>
+            <a:endParaRPr lang="en-US" sz="2500" dirty="0"/>
           </a:p>
         </p:txBody>
       </p:sp>
@@ -3002,9 +3002,9 @@
                 <a:solidFill>
                   <a:srgbClr val="3FA672"/>
                 </a:solidFill>
-                <a:latin typeface="Calibri" pitchFamily="34" charset="0"/>
-                <a:ea typeface="Calibri" pitchFamily="34" charset="-122"/>
-                <a:cs typeface="Calibri" pitchFamily="34" charset="-120"/>
+                <a:latin typeface="Montserrat" pitchFamily="34" charset="0"/>
+                <a:ea typeface="Montserrat" pitchFamily="34" charset="-122"/>
+                <a:cs typeface="Montserrat" pitchFamily="34" charset="-120"/>
               </a:rPr>
               <a:t>AND I HAD IT EASIER THAN THE PEOPLE BEHIND ME</a:t>
             </a:r>
@@ -3037,17 +3037,17 @@
               <a:buNone/>
             </a:pPr>
             <a:r>
-              <a:rPr lang="en-US" sz="4000" b="1" dirty="0">
+              <a:rPr lang="en-US" sz="3500" b="1" dirty="0">
                 <a:solidFill>
                   <a:srgbClr val="17302A"/>
                 </a:solidFill>
-                <a:latin typeface="Cambria" pitchFamily="34" charset="0"/>
-                <a:ea typeface="Cambria" pitchFamily="34" charset="-122"/>
-                <a:cs typeface="Cambria" pitchFamily="34" charset="-120"/>
+                <a:latin typeface="Montserrat" pitchFamily="34" charset="0"/>
+                <a:ea typeface="Montserrat" pitchFamily="34" charset="-122"/>
+                <a:cs typeface="Montserrat" pitchFamily="34" charset="-120"/>
               </a:rPr>
               <a:t>One generation apart</a:t>
             </a:r>
-            <a:endParaRPr lang="en-US" sz="4000" dirty="0"/>
+            <a:endParaRPr lang="en-US" sz="3500" dirty="0"/>
           </a:p>
         </p:txBody>
       </p:sp>
@@ -3107,9 +3107,9 @@
                 <a:solidFill>
                   <a:srgbClr val="5C6F66"/>
                 </a:solidFill>
-                <a:latin typeface="Calibri" pitchFamily="34" charset="0"/>
-                <a:ea typeface="Calibri" pitchFamily="34" charset="-122"/>
-                <a:cs typeface="Calibri" pitchFamily="34" charset="-120"/>
+                <a:latin typeface="Montserrat" pitchFamily="34" charset="0"/>
+                <a:ea typeface="Montserrat" pitchFamily="34" charset="-122"/>
+                <a:cs typeface="Montserrat" pitchFamily="34" charset="-120"/>
               </a:rPr>
               <a:t>2006</a:t>
             </a:r>
@@ -3142,17 +3142,17 @@
               <a:buNone/>
             </a:pPr>
             <a:r>
-              <a:rPr lang="en-US" sz="4800" b="1" dirty="0">
+              <a:rPr lang="en-US" sz="4200" b="1" dirty="0">
                 <a:solidFill>
                   <a:srgbClr val="17302A"/>
                 </a:solidFill>
-                <a:latin typeface="Cambria" pitchFamily="34" charset="0"/>
-                <a:ea typeface="Cambria" pitchFamily="34" charset="-122"/>
-                <a:cs typeface="Cambria" pitchFamily="34" charset="-120"/>
+                <a:latin typeface="Montserrat" pitchFamily="34" charset="0"/>
+                <a:ea typeface="Montserrat" pitchFamily="34" charset="-122"/>
+                <a:cs typeface="Montserrat" pitchFamily="34" charset="-120"/>
               </a:rPr>
               <a:t>$276,974</a:t>
             </a:r>
-            <a:endParaRPr lang="en-US" sz="4800" dirty="0"/>
+            <a:endParaRPr lang="en-US" sz="4200" dirty="0"/>
           </a:p>
         </p:txBody>
       </p:sp>
@@ -3212,9 +3212,9 @@
                 <a:solidFill>
                   <a:srgbClr val="E8B84B"/>
                 </a:solidFill>
-                <a:latin typeface="Calibri" pitchFamily="34" charset="0"/>
-                <a:ea typeface="Calibri" pitchFamily="34" charset="-122"/>
-                <a:cs typeface="Calibri" pitchFamily="34" charset="-120"/>
+                <a:latin typeface="Montserrat" pitchFamily="34" charset="0"/>
+                <a:ea typeface="Montserrat" pitchFamily="34" charset="-122"/>
+                <a:cs typeface="Montserrat" pitchFamily="34" charset="-120"/>
               </a:rPr>
               <a:t>TODAY</a:t>
             </a:r>
@@ -3247,17 +3247,17 @@
               <a:buNone/>
             </a:pPr>
             <a:r>
-              <a:rPr lang="en-US" sz="4800" b="1" dirty="0">
+              <a:rPr lang="en-US" sz="4200" b="1" dirty="0">
                 <a:solidFill>
                   <a:srgbClr val="FFFFFF"/>
                 </a:solidFill>
-                <a:latin typeface="Cambria" pitchFamily="34" charset="0"/>
-                <a:ea typeface="Cambria" pitchFamily="34" charset="-122"/>
-                <a:cs typeface="Cambria" pitchFamily="34" charset="-120"/>
+                <a:latin typeface="Montserrat" pitchFamily="34" charset="0"/>
+                <a:ea typeface="Montserrat" pitchFamily="34" charset="-122"/>
+                <a:cs typeface="Montserrat" pitchFamily="34" charset="-120"/>
               </a:rPr>
               <a:t>$696,078</a:t>
             </a:r>
-            <a:endParaRPr lang="en-US" sz="4800" dirty="0"/>
+            <a:endParaRPr lang="en-US" sz="4200" dirty="0"/>
           </a:p>
         </p:txBody>
       </p:sp>
@@ -3286,17 +3286,17 @@
               <a:buNone/>
             </a:pPr>
             <a:r>
-              <a:rPr lang="en-US" sz="2600" b="1" dirty="0">
+              <a:rPr lang="en-US" sz="2300" b="1" dirty="0">
                 <a:solidFill>
                   <a:srgbClr val="3FA672"/>
                 </a:solidFill>
-                <a:latin typeface="Cambria" pitchFamily="34" charset="0"/>
-                <a:ea typeface="Cambria" pitchFamily="34" charset="-122"/>
-                <a:cs typeface="Cambria" pitchFamily="34" charset="-120"/>
+                <a:latin typeface="Montserrat" pitchFamily="34" charset="0"/>
+                <a:ea typeface="Montserrat" pitchFamily="34" charset="-122"/>
+                <a:cs typeface="Montserrat" pitchFamily="34" charset="-120"/>
               </a:rPr>
               <a:t>2.5×</a:t>
             </a:r>
-            <a:endParaRPr lang="en-US" sz="2600" dirty="0"/>
+            <a:endParaRPr lang="en-US" sz="2300" dirty="0"/>
           </a:p>
         </p:txBody>
       </p:sp>
@@ -3329,9 +3329,9 @@
                 <a:solidFill>
                   <a:srgbClr val="5C6F66"/>
                 </a:solidFill>
-                <a:latin typeface="Calibri" pitchFamily="34" charset="0"/>
-                <a:ea typeface="Calibri" pitchFamily="34" charset="-122"/>
-                <a:cs typeface="Calibri" pitchFamily="34" charset="-120"/>
+                <a:latin typeface="Montserrat" pitchFamily="34" charset="0"/>
+                <a:ea typeface="Montserrat" pitchFamily="34" charset="-122"/>
+                <a:cs typeface="Montserrat" pitchFamily="34" charset="-120"/>
               </a:rPr>
               <a:t>Average Canadian home</a:t>
             </a:r>
@@ -3368,9 +3368,9 @@
                 <a:solidFill>
                   <a:srgbClr val="5C6F66"/>
                 </a:solidFill>
-                <a:latin typeface="Calibri" pitchFamily="34" charset="0"/>
-                <a:ea typeface="Calibri" pitchFamily="34" charset="-122"/>
-                <a:cs typeface="Calibri" pitchFamily="34" charset="-120"/>
+                <a:latin typeface="Montserrat" pitchFamily="34" charset="0"/>
+                <a:ea typeface="Montserrat" pitchFamily="34" charset="-122"/>
+                <a:cs typeface="Montserrat" pitchFamily="34" charset="-120"/>
               </a:rPr>
               <a:t>Source: CREA (2006 average MLS price) · national average, June 2026</a:t>
             </a:r>
@@ -3439,9 +3439,9 @@
                 <a:solidFill>
                   <a:srgbClr val="3FA672"/>
                 </a:solidFill>
-                <a:latin typeface="Calibri" pitchFamily="34" charset="0"/>
-                <a:ea typeface="Calibri" pitchFamily="34" charset="-122"/>
-                <a:cs typeface="Calibri" pitchFamily="34" charset="-120"/>
+                <a:latin typeface="Montserrat" pitchFamily="34" charset="0"/>
+                <a:ea typeface="Montserrat" pitchFamily="34" charset="-122"/>
+                <a:cs typeface="Montserrat" pitchFamily="34" charset="-120"/>
               </a:rPr>
               <a:t>SO I BUILT THE THING I NEEDED</a:t>
             </a:r>
@@ -3474,17 +3474,17 @@
               <a:buNone/>
             </a:pPr>
             <a:r>
-              <a:rPr lang="en-US" sz="4000" b="1" dirty="0">
+              <a:rPr lang="en-US" sz="3500" b="1" dirty="0">
                 <a:solidFill>
                   <a:srgbClr val="17302A"/>
                 </a:solidFill>
-                <a:latin typeface="Cambria" pitchFamily="34" charset="0"/>
-                <a:ea typeface="Cambria" pitchFamily="34" charset="-122"/>
-                <a:cs typeface="Cambria" pitchFamily="34" charset="-120"/>
+                <a:latin typeface="Montserrat" pitchFamily="34" charset="0"/>
+                <a:ea typeface="Montserrat" pitchFamily="34" charset="-122"/>
+                <a:cs typeface="Montserrat" pitchFamily="34" charset="-120"/>
               </a:rPr>
               <a:t>Sixty seconds in. A real date out.</a:t>
             </a:r>
-            <a:endParaRPr lang="en-US" sz="4000" dirty="0"/>
+            <a:endParaRPr lang="en-US" sz="3500" dirty="0"/>
           </a:p>
         </p:txBody>
       </p:sp>
@@ -3538,17 +3538,17 @@
               <a:buNone/>
             </a:pPr>
             <a:r>
-              <a:rPr lang="en-US" sz="2400" b="1" dirty="0">
+              <a:rPr lang="en-US" sz="2100" b="1" dirty="0">
                 <a:solidFill>
                   <a:srgbClr val="E8B84B"/>
                 </a:solidFill>
-                <a:latin typeface="Cambria" pitchFamily="34" charset="0"/>
-                <a:ea typeface="Cambria" pitchFamily="34" charset="-122"/>
-                <a:cs typeface="Cambria" pitchFamily="34" charset="-120"/>
+                <a:latin typeface="Montserrat" pitchFamily="34" charset="0"/>
+                <a:ea typeface="Montserrat" pitchFamily="34" charset="-122"/>
+                <a:cs typeface="Montserrat" pitchFamily="34" charset="-120"/>
               </a:rPr>
               <a:t>1</a:t>
             </a:r>
-            <a:endParaRPr lang="en-US" sz="2400" dirty="0"/>
+            <a:endParaRPr lang="en-US" sz="2100" dirty="0"/>
           </a:p>
         </p:txBody>
       </p:sp>
@@ -3577,17 +3577,17 @@
               <a:buNone/>
             </a:pPr>
             <a:r>
-              <a:rPr lang="en-US" sz="2800" b="1" dirty="0">
+              <a:rPr lang="en-US" sz="2500" b="1" dirty="0">
                 <a:solidFill>
                   <a:srgbClr val="17302A"/>
                 </a:solidFill>
-                <a:latin typeface="Cambria" pitchFamily="34" charset="0"/>
-                <a:ea typeface="Cambria" pitchFamily="34" charset="-122"/>
-                <a:cs typeface="Cambria" pitchFamily="34" charset="-120"/>
+                <a:latin typeface="Montserrat" pitchFamily="34" charset="0"/>
+                <a:ea typeface="Montserrat" pitchFamily="34" charset="-122"/>
+                <a:cs typeface="Montserrat" pitchFamily="34" charset="-120"/>
               </a:rPr>
               <a:t>Three questions</a:t>
             </a:r>
-            <a:endParaRPr lang="en-US" sz="2800" dirty="0"/>
+            <a:endParaRPr lang="en-US" sz="2500" dirty="0"/>
           </a:p>
         </p:txBody>
       </p:sp>
@@ -3641,17 +3641,17 @@
               <a:buNone/>
             </a:pPr>
             <a:r>
-              <a:rPr lang="en-US" sz="2400" b="1" dirty="0">
+              <a:rPr lang="en-US" sz="2100" b="1" dirty="0">
                 <a:solidFill>
                   <a:srgbClr val="E8B84B"/>
                 </a:solidFill>
-                <a:latin typeface="Cambria" pitchFamily="34" charset="0"/>
-                <a:ea typeface="Cambria" pitchFamily="34" charset="-122"/>
-                <a:cs typeface="Cambria" pitchFamily="34" charset="-120"/>
+                <a:latin typeface="Montserrat" pitchFamily="34" charset="0"/>
+                <a:ea typeface="Montserrat" pitchFamily="34" charset="-122"/>
+                <a:cs typeface="Montserrat" pitchFamily="34" charset="-120"/>
               </a:rPr>
               <a:t>2</a:t>
             </a:r>
-            <a:endParaRPr lang="en-US" sz="2400" dirty="0"/>
+            <a:endParaRPr lang="en-US" sz="2100" dirty="0"/>
           </a:p>
         </p:txBody>
       </p:sp>
@@ -3680,17 +3680,17 @@
               <a:buNone/>
             </a:pPr>
             <a:r>
-              <a:rPr lang="en-US" sz="2800" b="1" dirty="0">
+              <a:rPr lang="en-US" sz="2500" b="1" dirty="0">
                 <a:solidFill>
                   <a:srgbClr val="17302A"/>
                 </a:solidFill>
-                <a:latin typeface="Cambria" pitchFamily="34" charset="0"/>
-                <a:ea typeface="Cambria" pitchFamily="34" charset="-122"/>
-                <a:cs typeface="Cambria" pitchFamily="34" charset="-120"/>
+                <a:latin typeface="Montserrat" pitchFamily="34" charset="0"/>
+                <a:ea typeface="Montserrat" pitchFamily="34" charset="-122"/>
+                <a:cs typeface="Montserrat" pitchFamily="34" charset="-120"/>
               </a:rPr>
               <a:t>A real month</a:t>
             </a:r>
-            <a:endParaRPr lang="en-US" sz="2800" dirty="0"/>
+            <a:endParaRPr lang="en-US" sz="2500" dirty="0"/>
           </a:p>
         </p:txBody>
       </p:sp>
@@ -3744,17 +3744,17 @@
               <a:buNone/>
             </a:pPr>
             <a:r>
-              <a:rPr lang="en-US" sz="2400" b="1" dirty="0">
+              <a:rPr lang="en-US" sz="2100" b="1" dirty="0">
                 <a:solidFill>
                   <a:srgbClr val="E8B84B"/>
                 </a:solidFill>
-                <a:latin typeface="Cambria" pitchFamily="34" charset="0"/>
-                <a:ea typeface="Cambria" pitchFamily="34" charset="-122"/>
-                <a:cs typeface="Cambria" pitchFamily="34" charset="-120"/>
+                <a:latin typeface="Montserrat" pitchFamily="34" charset="0"/>
+                <a:ea typeface="Montserrat" pitchFamily="34" charset="-122"/>
+                <a:cs typeface="Montserrat" pitchFamily="34" charset="-120"/>
               </a:rPr>
               <a:t>3</a:t>
             </a:r>
-            <a:endParaRPr lang="en-US" sz="2400" dirty="0"/>
+            <a:endParaRPr lang="en-US" sz="2100" dirty="0"/>
           </a:p>
         </p:txBody>
       </p:sp>
@@ -3783,17 +3783,17 @@
               <a:buNone/>
             </a:pPr>
             <a:r>
-              <a:rPr lang="en-US" sz="2800" b="1" dirty="0">
+              <a:rPr lang="en-US" sz="2500" b="1" dirty="0">
                 <a:solidFill>
                   <a:srgbClr val="17302A"/>
                 </a:solidFill>
-                <a:latin typeface="Cambria" pitchFamily="34" charset="0"/>
-                <a:ea typeface="Cambria" pitchFamily="34" charset="-122"/>
-                <a:cs typeface="Cambria" pitchFamily="34" charset="-120"/>
+                <a:latin typeface="Montserrat" pitchFamily="34" charset="0"/>
+                <a:ea typeface="Montserrat" pitchFamily="34" charset="-122"/>
+                <a:cs typeface="Montserrat" pitchFamily="34" charset="-120"/>
               </a:rPr>
               <a:t>Watch it get closer</a:t>
             </a:r>
-            <a:endParaRPr lang="en-US" sz="2800" dirty="0"/>
+            <a:endParaRPr lang="en-US" sz="2500" dirty="0"/>
           </a:p>
         </p:txBody>
       </p:sp>
@@ -3853,9 +3853,9 @@
                 <a:solidFill>
                   <a:srgbClr val="E8B84B"/>
                 </a:solidFill>
-                <a:latin typeface="Calibri" pitchFamily="34" charset="0"/>
-                <a:ea typeface="Calibri" pitchFamily="34" charset="-122"/>
-                <a:cs typeface="Calibri" pitchFamily="34" charset="-120"/>
+                <a:latin typeface="Montserrat" pitchFamily="34" charset="0"/>
+                <a:ea typeface="Montserrat" pitchFamily="34" charset="-122"/>
+                <a:cs typeface="Montserrat" pitchFamily="34" charset="-120"/>
               </a:rPr>
               <a:t>KEYS IN HAND</a:t>
             </a:r>
@@ -3888,17 +3888,17 @@
               <a:buNone/>
             </a:pPr>
             <a:r>
-              <a:rPr lang="en-US" sz="3800" b="1" dirty="0">
+              <a:rPr lang="en-US" sz="3300" b="1" dirty="0">
                 <a:solidFill>
                   <a:srgbClr val="FFFFFF"/>
                 </a:solidFill>
-                <a:latin typeface="Cambria" pitchFamily="34" charset="0"/>
-                <a:ea typeface="Cambria" pitchFamily="34" charset="-122"/>
-                <a:cs typeface="Cambria" pitchFamily="34" charset="-120"/>
+                <a:latin typeface="Montserrat" pitchFamily="34" charset="0"/>
+                <a:ea typeface="Montserrat" pitchFamily="34" charset="-122"/>
+                <a:cs typeface="Montserrat" pitchFamily="34" charset="-120"/>
               </a:rPr>
               <a:t>June 2029</a:t>
             </a:r>
-            <a:endParaRPr lang="en-US" sz="3800" dirty="0"/>
+            <a:endParaRPr lang="en-US" sz="3300" dirty="0"/>
           </a:p>
         </p:txBody>
       </p:sp>
@@ -3985,9 +3985,9 @@
                 <a:solidFill>
                   <a:srgbClr val="E3F2E9"/>
                 </a:solidFill>
-                <a:latin typeface="Calibri" pitchFamily="34" charset="0"/>
-                <a:ea typeface="Calibri" pitchFamily="34" charset="-122"/>
-                <a:cs typeface="Calibri" pitchFamily="34" charset="-120"/>
+                <a:latin typeface="Montserrat" pitchFamily="34" charset="0"/>
+                <a:ea typeface="Montserrat" pitchFamily="34" charset="-122"/>
+                <a:cs typeface="Montserrat" pitchFamily="34" charset="-120"/>
               </a:rPr>
               <a:t>58% of the way there</a:t>
             </a:r>
@@ -4056,9 +4056,9 @@
                 <a:solidFill>
                   <a:srgbClr val="3FA672"/>
                 </a:solidFill>
-                <a:latin typeface="Calibri" pitchFamily="34" charset="0"/>
-                <a:ea typeface="Calibri" pitchFamily="34" charset="-122"/>
-                <a:cs typeface="Calibri" pitchFamily="34" charset="-120"/>
+                <a:latin typeface="Montserrat" pitchFamily="34" charset="0"/>
+                <a:ea typeface="Montserrat" pitchFamily="34" charset="-122"/>
+                <a:cs typeface="Montserrat" pitchFamily="34" charset="-120"/>
               </a:rPr>
               <a:t>INNOVATION</a:t>
             </a:r>
@@ -4091,17 +4091,17 @@
               <a:buNone/>
             </a:pPr>
             <a:r>
-              <a:rPr lang="en-US" sz="4000" b="1" dirty="0">
+              <a:rPr lang="en-US" sz="3500" b="1" dirty="0">
                 <a:solidFill>
                   <a:srgbClr val="17302A"/>
                 </a:solidFill>
-                <a:latin typeface="Cambria" pitchFamily="34" charset="0"/>
-                <a:ea typeface="Cambria" pitchFamily="34" charset="-122"/>
-                <a:cs typeface="Cambria" pitchFamily="34" charset="-120"/>
+                <a:latin typeface="Montserrat" pitchFamily="34" charset="0"/>
+                <a:ea typeface="Montserrat" pitchFamily="34" charset="-122"/>
+                <a:cs typeface="Montserrat" pitchFamily="34" charset="-120"/>
               </a:rPr>
               <a:t>We changed the question</a:t>
             </a:r>
-            <a:endParaRPr lang="en-US" sz="4000" dirty="0"/>
+            <a:endParaRPr lang="en-US" sz="3500" dirty="0"/>
           </a:p>
         </p:txBody>
       </p:sp>
@@ -4161,9 +4161,9 @@
                 <a:solidFill>
                   <a:srgbClr val="5C6F66"/>
                 </a:solidFill>
-                <a:latin typeface="Calibri" pitchFamily="34" charset="0"/>
-                <a:ea typeface="Calibri" pitchFamily="34" charset="-122"/>
-                <a:cs typeface="Calibri" pitchFamily="34" charset="-120"/>
+                <a:latin typeface="Montserrat" pitchFamily="34" charset="0"/>
+                <a:ea typeface="Montserrat" pitchFamily="34" charset="-122"/>
+                <a:cs typeface="Montserrat" pitchFamily="34" charset="-120"/>
               </a:rPr>
               <a:t>EVERY OTHER TOOL</a:t>
             </a:r>
@@ -4196,17 +4196,17 @@
               <a:buNone/>
             </a:pPr>
             <a:r>
-              <a:rPr lang="en-US" sz="2800" b="1" dirty="0">
+              <a:rPr lang="en-US" sz="2500" b="1" dirty="0">
                 <a:solidFill>
                   <a:srgbClr val="5C6F66"/>
                 </a:solidFill>
-                <a:latin typeface="Cambria" pitchFamily="34" charset="0"/>
-                <a:ea typeface="Cambria" pitchFamily="34" charset="-122"/>
-                <a:cs typeface="Cambria" pitchFamily="34" charset="-120"/>
+                <a:latin typeface="Montserrat" pitchFamily="34" charset="0"/>
+                <a:ea typeface="Montserrat" pitchFamily="34" charset="-122"/>
+                <a:cs typeface="Montserrat" pitchFamily="34" charset="-120"/>
               </a:rPr>
               <a:t>“Afford it today?”</a:t>
             </a:r>
-            <a:endParaRPr lang="en-US" sz="2800" dirty="0"/>
+            <a:endParaRPr lang="en-US" sz="2500" dirty="0"/>
           </a:p>
         </p:txBody>
       </p:sp>
@@ -4235,17 +4235,17 @@
               <a:buNone/>
             </a:pPr>
             <a:r>
-              <a:rPr lang="en-US" sz="4000" b="1" dirty="0">
+              <a:rPr lang="en-US" sz="3500" b="1" dirty="0">
                 <a:solidFill>
                   <a:srgbClr val="B4452F"/>
                 </a:solidFill>
-                <a:latin typeface="Cambria" pitchFamily="34" charset="0"/>
-                <a:ea typeface="Cambria" pitchFamily="34" charset="-122"/>
-                <a:cs typeface="Cambria" pitchFamily="34" charset="-120"/>
+                <a:latin typeface="Montserrat" pitchFamily="34" charset="0"/>
+                <a:ea typeface="Montserrat" pitchFamily="34" charset="-122"/>
+                <a:cs typeface="Montserrat" pitchFamily="34" charset="-120"/>
               </a:rPr>
               <a:t>No.</a:t>
             </a:r>
-            <a:endParaRPr lang="en-US" sz="4000" dirty="0"/>
+            <a:endParaRPr lang="en-US" sz="3500" dirty="0"/>
           </a:p>
         </p:txBody>
       </p:sp>
@@ -4305,9 +4305,9 @@
                 <a:solidFill>
                   <a:srgbClr val="E8B84B"/>
                 </a:solidFill>
-                <a:latin typeface="Calibri" pitchFamily="34" charset="0"/>
-                <a:ea typeface="Calibri" pitchFamily="34" charset="-122"/>
-                <a:cs typeface="Calibri" pitchFamily="34" charset="-120"/>
+                <a:latin typeface="Montserrat" pitchFamily="34" charset="0"/>
+                <a:ea typeface="Montserrat" pitchFamily="34" charset="-122"/>
+                <a:cs typeface="Montserrat" pitchFamily="34" charset="-120"/>
               </a:rPr>
               <a:t>KEYDATE</a:t>
             </a:r>
@@ -4340,17 +4340,17 @@
               <a:buNone/>
             </a:pPr>
             <a:r>
-              <a:rPr lang="en-US" sz="2800" b="1" dirty="0">
+              <a:rPr lang="en-US" sz="2500" b="1" dirty="0">
                 <a:solidFill>
                   <a:srgbClr val="FFFFFF"/>
                 </a:solidFill>
-                <a:latin typeface="Cambria" pitchFamily="34" charset="0"/>
-                <a:ea typeface="Cambria" pitchFamily="34" charset="-122"/>
-                <a:cs typeface="Cambria" pitchFamily="34" charset="-120"/>
+                <a:latin typeface="Montserrat" pitchFamily="34" charset="0"/>
+                <a:ea typeface="Montserrat" pitchFamily="34" charset="-122"/>
+                <a:cs typeface="Montserrat" pitchFamily="34" charset="-120"/>
               </a:rPr>
               <a:t>“When?”</a:t>
             </a:r>
-            <a:endParaRPr lang="en-US" sz="2800" dirty="0"/>
+            <a:endParaRPr lang="en-US" sz="2500" dirty="0"/>
           </a:p>
         </p:txBody>
       </p:sp>
@@ -4379,17 +4379,17 @@
               <a:buNone/>
             </a:pPr>
             <a:r>
-              <a:rPr lang="en-US" sz="4000" b="1" dirty="0">
+              <a:rPr lang="en-US" sz="3500" b="1" dirty="0">
                 <a:solidFill>
                   <a:srgbClr val="3FA672"/>
                 </a:solidFill>
-                <a:latin typeface="Cambria" pitchFamily="34" charset="0"/>
-                <a:ea typeface="Cambria" pitchFamily="34" charset="-122"/>
-                <a:cs typeface="Cambria" pitchFamily="34" charset="-120"/>
+                <a:latin typeface="Montserrat" pitchFamily="34" charset="0"/>
+                <a:ea typeface="Montserrat" pitchFamily="34" charset="-122"/>
+                <a:cs typeface="Montserrat" pitchFamily="34" charset="-120"/>
               </a:rPr>
               <a:t>June 2029.</a:t>
             </a:r>
-            <a:endParaRPr lang="en-US" sz="4000" dirty="0"/>
+            <a:endParaRPr lang="en-US" sz="3500" dirty="0"/>
           </a:p>
         </p:txBody>
       </p:sp>
@@ -4454,9 +4454,9 @@
                 <a:solidFill>
                   <a:srgbClr val="3FA672"/>
                 </a:solidFill>
-                <a:latin typeface="Calibri" pitchFamily="34" charset="0"/>
-                <a:ea typeface="Calibri" pitchFamily="34" charset="-122"/>
-                <a:cs typeface="Calibri" pitchFamily="34" charset="-120"/>
+                <a:latin typeface="Montserrat" pitchFamily="34" charset="0"/>
+                <a:ea typeface="Montserrat" pitchFamily="34" charset="-122"/>
+                <a:cs typeface="Montserrat" pitchFamily="34" charset="-120"/>
               </a:rPr>
               <a:t>IT WAS NEVER JUST MY STORY</a:t>
             </a:r>
@@ -4489,17 +4489,17 @@
               <a:buNone/>
             </a:pPr>
             <a:r>
-              <a:rPr lang="en-US" sz="4000" b="1" dirty="0">
+              <a:rPr lang="en-US" sz="3500" b="1" dirty="0">
                 <a:solidFill>
                   <a:srgbClr val="17302A"/>
                 </a:solidFill>
-                <a:latin typeface="Cambria" pitchFamily="34" charset="0"/>
-                <a:ea typeface="Cambria" pitchFamily="34" charset="-122"/>
-                <a:cs typeface="Cambria" pitchFamily="34" charset="-120"/>
+                <a:latin typeface="Montserrat" pitchFamily="34" charset="0"/>
+                <a:ea typeface="Montserrat" pitchFamily="34" charset="-122"/>
+                <a:cs typeface="Montserrat" pitchFamily="34" charset="-120"/>
               </a:rPr>
               <a:t>The engine doesn’t change at the border</a:t>
             </a:r>
-            <a:endParaRPr lang="en-US" sz="4000" dirty="0"/>
+            <a:endParaRPr lang="en-US" sz="3500" dirty="0"/>
           </a:p>
         </p:txBody>
       </p:sp>
@@ -4559,9 +4559,9 @@
                 <a:solidFill>
                   <a:srgbClr val="FFFFFF"/>
                 </a:solidFill>
-                <a:latin typeface="Calibri" pitchFamily="34" charset="0"/>
-                <a:ea typeface="Calibri" pitchFamily="34" charset="-122"/>
-                <a:cs typeface="Calibri" pitchFamily="34" charset="-120"/>
+                <a:latin typeface="Montserrat" pitchFamily="34" charset="0"/>
+                <a:ea typeface="Montserrat" pitchFamily="34" charset="-122"/>
+                <a:cs typeface="Montserrat" pitchFamily="34" charset="-120"/>
               </a:rPr>
               <a:t>Canada</a:t>
             </a:r>
@@ -4625,9 +4625,9 @@
                 <a:solidFill>
                   <a:srgbClr val="17302A"/>
                 </a:solidFill>
-                <a:latin typeface="Calibri" pitchFamily="34" charset="0"/>
-                <a:ea typeface="Calibri" pitchFamily="34" charset="-122"/>
-                <a:cs typeface="Calibri" pitchFamily="34" charset="-120"/>
+                <a:latin typeface="Montserrat" pitchFamily="34" charset="0"/>
+                <a:ea typeface="Montserrat" pitchFamily="34" charset="-122"/>
+                <a:cs typeface="Montserrat" pitchFamily="34" charset="-120"/>
               </a:rPr>
               <a:t>Australia</a:t>
             </a:r>
@@ -4691,9 +4691,9 @@
                 <a:solidFill>
                   <a:srgbClr val="17302A"/>
                 </a:solidFill>
-                <a:latin typeface="Calibri" pitchFamily="34" charset="0"/>
-                <a:ea typeface="Calibri" pitchFamily="34" charset="-122"/>
-                <a:cs typeface="Calibri" pitchFamily="34" charset="-120"/>
+                <a:latin typeface="Montserrat" pitchFamily="34" charset="0"/>
+                <a:ea typeface="Montserrat" pitchFamily="34" charset="-122"/>
+                <a:cs typeface="Montserrat" pitchFamily="34" charset="-120"/>
               </a:rPr>
               <a:t>UK</a:t>
             </a:r>
@@ -4757,9 +4757,9 @@
                 <a:solidFill>
                   <a:srgbClr val="17302A"/>
                 </a:solidFill>
-                <a:latin typeface="Calibri" pitchFamily="34" charset="0"/>
-                <a:ea typeface="Calibri" pitchFamily="34" charset="-122"/>
-                <a:cs typeface="Calibri" pitchFamily="34" charset="-120"/>
+                <a:latin typeface="Montserrat" pitchFamily="34" charset="0"/>
+                <a:ea typeface="Montserrat" pitchFamily="34" charset="-122"/>
+                <a:cs typeface="Montserrat" pitchFamily="34" charset="-120"/>
               </a:rPr>
               <a:t>Ireland</a:t>
             </a:r>
@@ -4823,9 +4823,9 @@
                 <a:solidFill>
                   <a:srgbClr val="17302A"/>
                 </a:solidFill>
-                <a:latin typeface="Calibri" pitchFamily="34" charset="0"/>
-                <a:ea typeface="Calibri" pitchFamily="34" charset="-122"/>
-                <a:cs typeface="Calibri" pitchFamily="34" charset="-120"/>
+                <a:latin typeface="Montserrat" pitchFamily="34" charset="0"/>
+                <a:ea typeface="Montserrat" pitchFamily="34" charset="-122"/>
+                <a:cs typeface="Montserrat" pitchFamily="34" charset="-120"/>
               </a:rPr>
               <a:t>New Zealand</a:t>
             </a:r>
@@ -4885,13 +4885,13 @@
               <a:buNone/>
             </a:pPr>
             <a:r>
-              <a:rPr lang="en-US" sz="3000" dirty="0">
+              <a:rPr lang="en-US" sz="2600" dirty="0">
                 <a:solidFill>
                   <a:srgbClr val="E3F2E9"/>
                 </a:solidFill>
-                <a:latin typeface="Cambria" pitchFamily="34" charset="0"/>
-                <a:ea typeface="Cambria" pitchFamily="34" charset="-122"/>
-                <a:cs typeface="Cambria" pitchFamily="34" charset="-120"/>
+                <a:latin typeface="Montserrat" pitchFamily="34" charset="0"/>
+                <a:ea typeface="Montserrat" pitchFamily="34" charset="-122"/>
+                <a:cs typeface="Montserrat" pitchFamily="34" charset="-120"/>
               </a:rPr>
               <a:t>The engine stays. </a:t>
             </a:r>
@@ -4899,17 +4899,17 @@
               <a:buNone/>
             </a:pPr>
             <a:r>
-              <a:rPr lang="en-US" sz="3000" b="1" dirty="0">
+              <a:rPr lang="en-US" sz="2600" b="1" dirty="0">
                 <a:solidFill>
                   <a:srgbClr val="E8B84B"/>
                 </a:solidFill>
-                <a:latin typeface="Cambria" pitchFamily="34" charset="0"/>
-                <a:ea typeface="Cambria" pitchFamily="34" charset="-122"/>
-                <a:cs typeface="Cambria" pitchFamily="34" charset="-120"/>
+                <a:latin typeface="Montserrat" pitchFamily="34" charset="0"/>
+                <a:ea typeface="Montserrat" pitchFamily="34" charset="-122"/>
+                <a:cs typeface="Montserrat" pitchFamily="34" charset="-120"/>
               </a:rPr>
               <a:t>The rulebook swaps.</a:t>
             </a:r>
-            <a:endParaRPr lang="en-US" sz="3000" dirty="0"/>
+            <a:endParaRPr lang="en-US" sz="2600" dirty="0"/>
           </a:p>
         </p:txBody>
       </p:sp>
@@ -4974,9 +4974,9 @@
                 <a:solidFill>
                   <a:srgbClr val="E8B84B"/>
                 </a:solidFill>
-                <a:latin typeface="Calibri" pitchFamily="34" charset="0"/>
-                <a:ea typeface="Calibri" pitchFamily="34" charset="-122"/>
-                <a:cs typeface="Calibri" pitchFamily="34" charset="-120"/>
+                <a:latin typeface="Montserrat" pitchFamily="34" charset="0"/>
+                <a:ea typeface="Montserrat" pitchFamily="34" charset="-122"/>
+                <a:cs typeface="Montserrat" pitchFamily="34" charset="-120"/>
               </a:rPr>
               <a:t>COMMUNITY IMPACT &amp; SUSTAINABILITY</a:t>
             </a:r>
@@ -5009,17 +5009,17 @@
               <a:buNone/>
             </a:pPr>
             <a:r>
-              <a:rPr lang="en-US" sz="4000" b="1" dirty="0">
+              <a:rPr lang="en-US" sz="3500" b="1" dirty="0">
                 <a:solidFill>
                   <a:srgbClr val="FFFFFF"/>
                 </a:solidFill>
-                <a:latin typeface="Cambria" pitchFamily="34" charset="0"/>
-                <a:ea typeface="Cambria" pitchFamily="34" charset="-122"/>
-                <a:cs typeface="Cambria" pitchFamily="34" charset="-120"/>
+                <a:latin typeface="Montserrat" pitchFamily="34" charset="0"/>
+                <a:ea typeface="Montserrat" pitchFamily="34" charset="-122"/>
+                <a:cs typeface="Montserrat" pitchFamily="34" charset="-120"/>
               </a:rPr>
               <a:t>The money we refuse to take</a:t>
             </a:r>
-            <a:endParaRPr lang="en-US" sz="4000" dirty="0"/>
+            <a:endParaRPr lang="en-US" sz="3500" dirty="0"/>
           </a:p>
         </p:txBody>
       </p:sp>
@@ -5078,17 +5078,17 @@
               <a:buNone/>
             </a:pPr>
             <a:r>
-              <a:rPr lang="en-US" sz="2600" b="1" dirty="0">
+              <a:rPr lang="en-US" sz="2300" b="1" dirty="0">
                 <a:solidFill>
                   <a:srgbClr val="FFFFFF"/>
                 </a:solidFill>
-                <a:latin typeface="Cambria" pitchFamily="34" charset="0"/>
-                <a:ea typeface="Cambria" pitchFamily="34" charset="-122"/>
-                <a:cs typeface="Cambria" pitchFamily="34" charset="-120"/>
+                <a:latin typeface="Montserrat" pitchFamily="34" charset="0"/>
+                <a:ea typeface="Montserrat" pitchFamily="34" charset="-122"/>
+                <a:cs typeface="Montserrat" pitchFamily="34" charset="-120"/>
               </a:rPr>
               <a:t>We never sell you</a:t>
             </a:r>
-            <a:endParaRPr lang="en-US" sz="2600" dirty="0"/>
+            <a:endParaRPr lang="en-US" sz="2300" dirty="0"/>
           </a:p>
           <a:p>
             <a:pPr indent="0" marL="0">
@@ -5098,17 +5098,17 @@
               <a:buNone/>
             </a:pPr>
             <a:r>
-              <a:rPr lang="en-US" sz="2600" b="1" dirty="0">
+              <a:rPr lang="en-US" sz="2300" b="1" dirty="0">
                 <a:solidFill>
                   <a:srgbClr val="FFFFFF"/>
                 </a:solidFill>
-                <a:latin typeface="Cambria" pitchFamily="34" charset="0"/>
-                <a:ea typeface="Cambria" pitchFamily="34" charset="-122"/>
-                <a:cs typeface="Cambria" pitchFamily="34" charset="-120"/>
+                <a:latin typeface="Montserrat" pitchFamily="34" charset="0"/>
+                <a:ea typeface="Montserrat" pitchFamily="34" charset="-122"/>
+                <a:cs typeface="Montserrat" pitchFamily="34" charset="-120"/>
               </a:rPr>
               <a:t>to brokers.</a:t>
             </a:r>
-            <a:endParaRPr lang="en-US" sz="2600" dirty="0"/>
+            <a:endParaRPr lang="en-US" sz="2300" dirty="0"/>
           </a:p>
         </p:txBody>
       </p:sp>
@@ -5167,17 +5167,17 @@
               <a:buNone/>
             </a:pPr>
             <a:r>
-              <a:rPr lang="en-US" sz="2600" b="1" dirty="0">
+              <a:rPr lang="en-US" sz="2300" b="1" dirty="0">
                 <a:solidFill>
                   <a:srgbClr val="FFFFFF"/>
                 </a:solidFill>
-                <a:latin typeface="Cambria" pitchFamily="34" charset="0"/>
-                <a:ea typeface="Cambria" pitchFamily="34" charset="-122"/>
-                <a:cs typeface="Cambria" pitchFamily="34" charset="-120"/>
+                <a:latin typeface="Montserrat" pitchFamily="34" charset="0"/>
+                <a:ea typeface="Montserrat" pitchFamily="34" charset="-122"/>
+                <a:cs typeface="Montserrat" pitchFamily="34" charset="-120"/>
               </a:rPr>
               <a:t>We built the tool</a:t>
             </a:r>
-            <a:endParaRPr lang="en-US" sz="2600" dirty="0"/>
+            <a:endParaRPr lang="en-US" sz="2300" dirty="0"/>
           </a:p>
           <a:p>
             <a:pPr indent="0" marL="0">
@@ -5187,17 +5187,17 @@
               <a:buNone/>
             </a:pPr>
             <a:r>
-              <a:rPr lang="en-US" sz="2600" b="1" dirty="0">
+              <a:rPr lang="en-US" sz="2300" b="1" dirty="0">
                 <a:solidFill>
                   <a:srgbClr val="FFFFFF"/>
                 </a:solidFill>
-                <a:latin typeface="Cambria" pitchFamily="34" charset="0"/>
-                <a:ea typeface="Cambria" pitchFamily="34" charset="-122"/>
-                <a:cs typeface="Cambria" pitchFamily="34" charset="-120"/>
+                <a:latin typeface="Montserrat" pitchFamily="34" charset="0"/>
+                <a:ea typeface="Montserrat" pitchFamily="34" charset="-122"/>
+                <a:cs typeface="Montserrat" pitchFamily="34" charset="-120"/>
               </a:rPr>
               <a:t>that says don’t buy.</a:t>
             </a:r>
-            <a:endParaRPr lang="en-US" sz="2600" dirty="0"/>
+            <a:endParaRPr lang="en-US" sz="2300" dirty="0"/>
           </a:p>
         </p:txBody>
       </p:sp>
@@ -5226,17 +5226,17 @@
               <a:buNone/>
             </a:pPr>
             <a:r>
-              <a:rPr lang="en-US" sz="2600" i="1" dirty="0">
+              <a:rPr lang="en-US" sz="2300" i="1" dirty="0">
                 <a:solidFill>
                   <a:srgbClr val="E8B84B"/>
                 </a:solidFill>
-                <a:latin typeface="Cambria" pitchFamily="34" charset="0"/>
-                <a:ea typeface="Cambria" pitchFamily="34" charset="-122"/>
-                <a:cs typeface="Cambria" pitchFamily="34" charset="-120"/>
+                <a:latin typeface="Montserrat" pitchFamily="34" charset="0"/>
+                <a:ea typeface="Montserrat" pitchFamily="34" charset="-122"/>
+                <a:cs typeface="Montserrat" pitchFamily="34" charset="-120"/>
               </a:rPr>
               <a:t>A company on referral fees can never say that.</a:t>
             </a:r>
-            <a:endParaRPr lang="en-US" sz="2600" dirty="0"/>
+            <a:endParaRPr lang="en-US" sz="2300" dirty="0"/>
           </a:p>
         </p:txBody>
       </p:sp>
@@ -5301,9 +5301,9 @@
                 <a:solidFill>
                   <a:srgbClr val="3FA672"/>
                 </a:solidFill>
-                <a:latin typeface="Calibri" pitchFamily="34" charset="0"/>
-                <a:ea typeface="Calibri" pitchFamily="34" charset="-122"/>
-                <a:cs typeface="Calibri" pitchFamily="34" charset="-120"/>
+                <a:latin typeface="Montserrat" pitchFamily="34" charset="0"/>
+                <a:ea typeface="Montserrat" pitchFamily="34" charset="-122"/>
+                <a:cs typeface="Montserrat" pitchFamily="34" charset="-120"/>
               </a:rPr>
               <a:t>SCALABILITY &amp; LEADERSHIP</a:t>
             </a:r>
@@ -5336,17 +5336,17 @@
               <a:buNone/>
             </a:pPr>
             <a:r>
-              <a:rPr lang="en-US" sz="4000" b="1" dirty="0">
+              <a:rPr lang="en-US" sz="3500" b="1" dirty="0">
                 <a:solidFill>
                   <a:srgbClr val="17302A"/>
                 </a:solidFill>
-                <a:latin typeface="Cambria" pitchFamily="34" charset="0"/>
-                <a:ea typeface="Cambria" pitchFamily="34" charset="-122"/>
-                <a:cs typeface="Cambria" pitchFamily="34" charset="-120"/>
+                <a:latin typeface="Montserrat" pitchFamily="34" charset="0"/>
+                <a:ea typeface="Montserrat" pitchFamily="34" charset="-122"/>
+                <a:cs typeface="Montserrat" pitchFamily="34" charset="-120"/>
               </a:rPr>
               <a:t>Built, shipped, live</a:t>
             </a:r>
-            <a:endParaRPr lang="en-US" sz="4000" dirty="0"/>
+            <a:endParaRPr lang="en-US" sz="3500" dirty="0"/>
           </a:p>
         </p:txBody>
       </p:sp>
@@ -5402,17 +5402,17 @@
               <a:buNone/>
             </a:pPr>
             <a:r>
-              <a:rPr lang="en-US" sz="4600" b="1" dirty="0">
+              <a:rPr lang="en-US" sz="4000" b="1" dirty="0">
                 <a:solidFill>
                   <a:srgbClr val="3FA672"/>
                 </a:solidFill>
-                <a:latin typeface="Cambria" pitchFamily="34" charset="0"/>
-                <a:ea typeface="Cambria" pitchFamily="34" charset="-122"/>
-                <a:cs typeface="Cambria" pitchFamily="34" charset="-120"/>
+                <a:latin typeface="Montserrat" pitchFamily="34" charset="0"/>
+                <a:ea typeface="Montserrat" pitchFamily="34" charset="-122"/>
+                <a:cs typeface="Montserrat" pitchFamily="34" charset="-120"/>
               </a:rPr>
               <a:t>467</a:t>
             </a:r>
-            <a:endParaRPr lang="en-US" sz="4600" dirty="0"/>
+            <a:endParaRPr lang="en-US" sz="4000" dirty="0"/>
           </a:p>
         </p:txBody>
       </p:sp>
@@ -5445,9 +5445,9 @@
                 <a:solidFill>
                   <a:srgbClr val="5C6F66"/>
                 </a:solidFill>
-                <a:latin typeface="Calibri" pitchFamily="34" charset="0"/>
-                <a:ea typeface="Calibri" pitchFamily="34" charset="-122"/>
-                <a:cs typeface="Calibri" pitchFamily="34" charset="-120"/>
+                <a:latin typeface="Montserrat" pitchFamily="34" charset="0"/>
+                <a:ea typeface="Montserrat" pitchFamily="34" charset="-122"/>
+                <a:cs typeface="Montserrat" pitchFamily="34" charset="-120"/>
               </a:rPr>
               <a:t>municipalities</a:t>
             </a:r>
@@ -5507,17 +5507,17 @@
               <a:buNone/>
             </a:pPr>
             <a:r>
-              <a:rPr lang="en-US" sz="4600" b="1" dirty="0">
+              <a:rPr lang="en-US" sz="4000" b="1" dirty="0">
                 <a:solidFill>
                   <a:srgbClr val="3FA672"/>
                 </a:solidFill>
-                <a:latin typeface="Cambria" pitchFamily="34" charset="0"/>
-                <a:ea typeface="Cambria" pitchFamily="34" charset="-122"/>
-                <a:cs typeface="Cambria" pitchFamily="34" charset="-120"/>
+                <a:latin typeface="Montserrat" pitchFamily="34" charset="0"/>
+                <a:ea typeface="Montserrat" pitchFamily="34" charset="-122"/>
+                <a:cs typeface="Montserrat" pitchFamily="34" charset="-120"/>
               </a:rPr>
               <a:t>~$0</a:t>
             </a:r>
-            <a:endParaRPr lang="en-US" sz="4600" dirty="0"/>
+            <a:endParaRPr lang="en-US" sz="4000" dirty="0"/>
           </a:p>
         </p:txBody>
       </p:sp>
@@ -5550,9 +5550,9 @@
                 <a:solidFill>
                   <a:srgbClr val="5C6F66"/>
                 </a:solidFill>
-                <a:latin typeface="Calibri" pitchFamily="34" charset="0"/>
-                <a:ea typeface="Calibri" pitchFamily="34" charset="-122"/>
-                <a:cs typeface="Calibri" pitchFamily="34" charset="-120"/>
+                <a:latin typeface="Montserrat" pitchFamily="34" charset="0"/>
+                <a:ea typeface="Montserrat" pitchFamily="34" charset="-122"/>
+                <a:cs typeface="Montserrat" pitchFamily="34" charset="-120"/>
               </a:rPr>
               <a:t>cost per user</a:t>
             </a:r>
@@ -5612,17 +5612,17 @@
               <a:buNone/>
             </a:pPr>
             <a:r>
-              <a:rPr lang="en-US" sz="4600" b="1" dirty="0">
+              <a:rPr lang="en-US" sz="4000" b="1" dirty="0">
                 <a:solidFill>
                   <a:srgbClr val="3FA672"/>
                 </a:solidFill>
-                <a:latin typeface="Cambria" pitchFamily="34" charset="0"/>
-                <a:ea typeface="Cambria" pitchFamily="34" charset="-122"/>
-                <a:cs typeface="Cambria" pitchFamily="34" charset="-120"/>
+                <a:latin typeface="Montserrat" pitchFamily="34" charset="0"/>
+                <a:ea typeface="Montserrat" pitchFamily="34" charset="-122"/>
+                <a:cs typeface="Montserrat" pitchFamily="34" charset="-120"/>
               </a:rPr>
               <a:t>1</a:t>
             </a:r>
-            <a:endParaRPr lang="en-US" sz="4600" dirty="0"/>
+            <a:endParaRPr lang="en-US" sz="4000" dirty="0"/>
           </a:p>
         </p:txBody>
       </p:sp>
@@ -5655,9 +5655,9 @@
                 <a:solidFill>
                   <a:srgbClr val="5C6F66"/>
                 </a:solidFill>
-                <a:latin typeface="Calibri" pitchFamily="34" charset="0"/>
-                <a:ea typeface="Calibri" pitchFamily="34" charset="-122"/>
-                <a:cs typeface="Calibri" pitchFamily="34" charset="-120"/>
+                <a:latin typeface="Montserrat" pitchFamily="34" charset="0"/>
+                <a:ea typeface="Montserrat" pitchFamily="34" charset="-122"/>
+                <a:cs typeface="Montserrat" pitchFamily="34" charset="-120"/>
               </a:rPr>
               <a:t>founder</a:t>
             </a:r>
@@ -5717,17 +5717,17 @@
               <a:buNone/>
             </a:pPr>
             <a:r>
-              <a:rPr lang="en-US" sz="2600" b="1" dirty="0">
+              <a:rPr lang="en-US" sz="2300" b="1" dirty="0">
                 <a:solidFill>
                   <a:srgbClr val="1E4D3B"/>
                 </a:solidFill>
-                <a:latin typeface="Cambria" pitchFamily="34" charset="0"/>
-                <a:ea typeface="Cambria" pitchFamily="34" charset="-122"/>
-                <a:cs typeface="Cambria" pitchFamily="34" charset="-120"/>
+                <a:latin typeface="Montserrat" pitchFamily="34" charset="0"/>
+                <a:ea typeface="Montserrat" pitchFamily="34" charset="-122"/>
+                <a:cs typeface="Montserrat" pitchFamily="34" charset="-120"/>
               </a:rPr>
               <a:t>A new country is a rulebook, not a rebuild.</a:t>
             </a:r>
-            <a:endParaRPr lang="en-US" sz="2600" dirty="0"/>
+            <a:endParaRPr lang="en-US" sz="2300" dirty="0"/>
           </a:p>
         </p:txBody>
       </p:sp>

</xml_diff>

<commit_message>
Ship a Century Gothic build of the deck as the safe default
Montserrat renders correctly only where it is installed. On a venue laptop
that lacks it, PowerPoint substitutes silently and the layout moves —
during the pitch, with no chance to fix it. Century Gothic ships with
Office, so it is the one to walk in with.

The generator now produces both from the same layout, selected by
DECK_FONT, so the two can never drift apart. Century Gothic is the default
and keeps the original filename; Montserrat gets a suffixed one.

Century Gothic sets wider at the same point size, so rather than guessing
at the sizes, the Montserrat build was measured line against container:
71 of 72 lines carried 22% or more horizontal slack and one, the slide 7
title, carried 14%. That single line is scaled by tight(); nothing else
needed to move.

Co-Authored-By: Claude Opus 5 <noreply@anthropic.com>
Claude-Session: https://claude.ai/code/session_019WKzGoyENXa8KtvmiHdCC2
</commit_message>
<xml_diff>
--- a/apps/keydate/pitch/KeyDate-JCI-Edmonton.pptx
+++ b/apps/keydate/pitch/KeyDate-JCI-Edmonton.pptx
@@ -1802,9 +1802,9 @@
                 <a:solidFill>
                   <a:srgbClr val="FFFFFF"/>
                 </a:solidFill>
-                <a:latin typeface="Montserrat" pitchFamily="34" charset="0"/>
-                <a:ea typeface="Montserrat" pitchFamily="34" charset="-122"/>
-                <a:cs typeface="Montserrat" pitchFamily="34" charset="-120"/>
+                <a:latin typeface="Century Gothic" pitchFamily="34" charset="0"/>
+                <a:ea typeface="Century Gothic" pitchFamily="34" charset="-122"/>
+                <a:cs typeface="Century Gothic" pitchFamily="34" charset="-120"/>
               </a:rPr>
               <a:t>Key</a:t>
             </a:r>
@@ -1816,9 +1816,9 @@
                 <a:solidFill>
                   <a:srgbClr val="3FA672"/>
                 </a:solidFill>
-                <a:latin typeface="Montserrat" pitchFamily="34" charset="0"/>
-                <a:ea typeface="Montserrat" pitchFamily="34" charset="-122"/>
-                <a:cs typeface="Montserrat" pitchFamily="34" charset="-120"/>
+                <a:latin typeface="Century Gothic" pitchFamily="34" charset="0"/>
+                <a:ea typeface="Century Gothic" pitchFamily="34" charset="-122"/>
+                <a:cs typeface="Century Gothic" pitchFamily="34" charset="-120"/>
               </a:rPr>
               <a:t>Date</a:t>
             </a:r>
@@ -1858,9 +1858,9 @@
                 <a:solidFill>
                   <a:srgbClr val="E3F2E9"/>
                 </a:solidFill>
-                <a:latin typeface="Montserrat" pitchFamily="34" charset="0"/>
-                <a:ea typeface="Montserrat" pitchFamily="34" charset="-122"/>
-                <a:cs typeface="Montserrat" pitchFamily="34" charset="-120"/>
+                <a:latin typeface="Century Gothic" pitchFamily="34" charset="0"/>
+                <a:ea typeface="Century Gothic" pitchFamily="34" charset="-122"/>
+                <a:cs typeface="Century Gothic" pitchFamily="34" charset="-120"/>
               </a:rPr>
               <a:t>Owning a home isn’t impossible.</a:t>
             </a:r>
@@ -1878,9 +1878,9 @@
                 <a:solidFill>
                   <a:srgbClr val="E3F2E9"/>
                 </a:solidFill>
-                <a:latin typeface="Montserrat" pitchFamily="34" charset="0"/>
-                <a:ea typeface="Montserrat" pitchFamily="34" charset="-122"/>
-                <a:cs typeface="Montserrat" pitchFamily="34" charset="-120"/>
+                <a:latin typeface="Century Gothic" pitchFamily="34" charset="0"/>
+                <a:ea typeface="Century Gothic" pitchFamily="34" charset="-122"/>
+                <a:cs typeface="Century Gothic" pitchFamily="34" charset="-120"/>
               </a:rPr>
               <a:t>It has a date.</a:t>
             </a:r>
@@ -1917,9 +1917,9 @@
                 <a:solidFill>
                   <a:srgbClr val="E3F2E9"/>
                 </a:solidFill>
-                <a:latin typeface="Montserrat" pitchFamily="34" charset="0"/>
-                <a:ea typeface="Montserrat" pitchFamily="34" charset="-122"/>
-                <a:cs typeface="Montserrat" pitchFamily="34" charset="-120"/>
+                <a:latin typeface="Century Gothic" pitchFamily="34" charset="0"/>
+                <a:ea typeface="Century Gothic" pitchFamily="34" charset="-122"/>
+                <a:cs typeface="Century Gothic" pitchFamily="34" charset="-120"/>
               </a:rPr>
               <a:t>JCI Edmonton  ·  Creative Young Entrepreneur</a:t>
             </a:r>
@@ -1956,9 +1956,9 @@
                 <a:solidFill>
                   <a:srgbClr val="E8B84B"/>
                 </a:solidFill>
-                <a:latin typeface="Montserrat" pitchFamily="34" charset="0"/>
-                <a:ea typeface="Montserrat" pitchFamily="34" charset="-122"/>
-                <a:cs typeface="Montserrat" pitchFamily="34" charset="-120"/>
+                <a:latin typeface="Century Gothic" pitchFamily="34" charset="0"/>
+                <a:ea typeface="Century Gothic" pitchFamily="34" charset="-122"/>
+                <a:cs typeface="Century Gothic" pitchFamily="34" charset="-120"/>
               </a:rPr>
               <a:t>keydate.ca</a:t>
             </a:r>
@@ -2107,9 +2107,9 @@
                 <a:solidFill>
                   <a:srgbClr val="E3F2E9"/>
                 </a:solidFill>
-                <a:latin typeface="Montserrat" pitchFamily="34" charset="0"/>
-                <a:ea typeface="Montserrat" pitchFamily="34" charset="-122"/>
-                <a:cs typeface="Montserrat" pitchFamily="34" charset="-120"/>
+                <a:latin typeface="Century Gothic" pitchFamily="34" charset="0"/>
+                <a:ea typeface="Century Gothic" pitchFamily="34" charset="-122"/>
+                <a:cs typeface="Century Gothic" pitchFamily="34" charset="-120"/>
               </a:rPr>
               <a:t>It just doesn’t have</a:t>
             </a:r>
@@ -2127,9 +2127,9 @@
                 <a:solidFill>
                   <a:srgbClr val="E3F2E9"/>
                 </a:solidFill>
-                <a:latin typeface="Montserrat" pitchFamily="34" charset="0"/>
-                <a:ea typeface="Montserrat" pitchFamily="34" charset="-122"/>
-                <a:cs typeface="Montserrat" pitchFamily="34" charset="-120"/>
+                <a:latin typeface="Century Gothic" pitchFamily="34" charset="0"/>
+                <a:ea typeface="Century Gothic" pitchFamily="34" charset="-122"/>
+                <a:cs typeface="Century Gothic" pitchFamily="34" charset="-120"/>
               </a:rPr>
               <a:t>a date yet.</a:t>
             </a:r>
@@ -2166,9 +2166,9 @@
                 <a:solidFill>
                   <a:srgbClr val="E8B84B"/>
                 </a:solidFill>
-                <a:latin typeface="Montserrat" pitchFamily="34" charset="0"/>
-                <a:ea typeface="Montserrat" pitchFamily="34" charset="-122"/>
-                <a:cs typeface="Montserrat" pitchFamily="34" charset="-120"/>
+                <a:latin typeface="Century Gothic" pitchFamily="34" charset="0"/>
+                <a:ea typeface="Century Gothic" pitchFamily="34" charset="-122"/>
+                <a:cs typeface="Century Gothic" pitchFamily="34" charset="-120"/>
               </a:rPr>
               <a:t>We’re giving it one.</a:t>
             </a:r>
@@ -2205,9 +2205,9 @@
                 <a:solidFill>
                   <a:srgbClr val="E8B84B"/>
                 </a:solidFill>
-                <a:latin typeface="Montserrat" pitchFamily="34" charset="0"/>
-                <a:ea typeface="Montserrat" pitchFamily="34" charset="-122"/>
-                <a:cs typeface="Montserrat" pitchFamily="34" charset="-120"/>
+                <a:latin typeface="Century Gothic" pitchFamily="34" charset="0"/>
+                <a:ea typeface="Century Gothic" pitchFamily="34" charset="-122"/>
+                <a:cs typeface="Century Gothic" pitchFamily="34" charset="-120"/>
               </a:rPr>
               <a:t>keydate.ca</a:t>
             </a:r>
@@ -2244,9 +2244,9 @@
                 <a:solidFill>
                   <a:srgbClr val="E3F2E9"/>
                 </a:solidFill>
-                <a:latin typeface="Montserrat" pitchFamily="34" charset="0"/>
-                <a:ea typeface="Montserrat" pitchFamily="34" charset="-122"/>
-                <a:cs typeface="Montserrat" pitchFamily="34" charset="-120"/>
+                <a:latin typeface="Century Gothic" pitchFamily="34" charset="0"/>
+                <a:ea typeface="Century Gothic" pitchFamily="34" charset="-122"/>
+                <a:cs typeface="Century Gothic" pitchFamily="34" charset="-120"/>
               </a:rPr>
               <a:t>Edmonton beta opens this week</a:t>
             </a:r>
@@ -2315,9 +2315,9 @@
                 <a:solidFill>
                   <a:srgbClr val="3FA672"/>
                 </a:solidFill>
-                <a:latin typeface="Montserrat" pitchFamily="34" charset="0"/>
-                <a:ea typeface="Montserrat" pitchFamily="34" charset="-122"/>
-                <a:cs typeface="Montserrat" pitchFamily="34" charset="-120"/>
+                <a:latin typeface="Century Gothic" pitchFamily="34" charset="0"/>
+                <a:ea typeface="Century Gothic" pitchFamily="34" charset="-122"/>
+                <a:cs typeface="Century Gothic" pitchFamily="34" charset="-120"/>
               </a:rPr>
               <a:t>WHY I BUILT THIS</a:t>
             </a:r>
@@ -2354,9 +2354,9 @@
                 <a:solidFill>
                   <a:srgbClr val="17302A"/>
                 </a:solidFill>
-                <a:latin typeface="Montserrat" pitchFamily="34" charset="0"/>
-                <a:ea typeface="Montserrat" pitchFamily="34" charset="-122"/>
-                <a:cs typeface="Montserrat" pitchFamily="34" charset="-120"/>
+                <a:latin typeface="Century Gothic" pitchFamily="34" charset="0"/>
+                <a:ea typeface="Century Gothic" pitchFamily="34" charset="-122"/>
+                <a:cs typeface="Century Gothic" pitchFamily="34" charset="-120"/>
               </a:rPr>
               <a:t>I bought my first place.</a:t>
             </a:r>
@@ -2393,9 +2393,9 @@
                 <a:solidFill>
                   <a:srgbClr val="1E4D3B"/>
                 </a:solidFill>
-                <a:latin typeface="Montserrat" pitchFamily="34" charset="0"/>
-                <a:ea typeface="Montserrat" pitchFamily="34" charset="-122"/>
-                <a:cs typeface="Montserrat" pitchFamily="34" charset="-120"/>
+                <a:latin typeface="Century Gothic" pitchFamily="34" charset="0"/>
+                <a:ea typeface="Century Gothic" pitchFamily="34" charset="-122"/>
+                <a:cs typeface="Century Gothic" pitchFamily="34" charset="-120"/>
               </a:rPr>
               <a:t>I was guessing the whole way.</a:t>
             </a:r>
@@ -2459,9 +2459,9 @@
                 <a:solidFill>
                   <a:srgbClr val="1E4D3B"/>
                 </a:solidFill>
-                <a:latin typeface="Montserrat" pitchFamily="34" charset="0"/>
-                <a:ea typeface="Montserrat" pitchFamily="34" charset="-122"/>
-                <a:cs typeface="Montserrat" pitchFamily="34" charset="-120"/>
+                <a:latin typeface="Century Gothic" pitchFamily="34" charset="0"/>
+                <a:ea typeface="Century Gothic" pitchFamily="34" charset="-122"/>
+                <a:cs typeface="Century Gothic" pitchFamily="34" charset="-120"/>
               </a:rPr>
               <a:t>Spreadsheets</a:t>
             </a:r>
@@ -2525,9 +2525,9 @@
                 <a:solidFill>
                   <a:srgbClr val="1E4D3B"/>
                 </a:solidFill>
-                <a:latin typeface="Montserrat" pitchFamily="34" charset="0"/>
-                <a:ea typeface="Montserrat" pitchFamily="34" charset="-122"/>
-                <a:cs typeface="Montserrat" pitchFamily="34" charset="-120"/>
+                <a:latin typeface="Century Gothic" pitchFamily="34" charset="0"/>
+                <a:ea typeface="Century Gothic" pitchFamily="34" charset="-122"/>
+                <a:cs typeface="Century Gothic" pitchFamily="34" charset="-120"/>
               </a:rPr>
               <a:t>Contradictory advice</a:t>
             </a:r>
@@ -2591,9 +2591,9 @@
                 <a:solidFill>
                   <a:srgbClr val="1E4D3B"/>
                 </a:solidFill>
-                <a:latin typeface="Montserrat" pitchFamily="34" charset="0"/>
-                <a:ea typeface="Montserrat" pitchFamily="34" charset="-122"/>
-                <a:cs typeface="Montserrat" pitchFamily="34" charset="-120"/>
+                <a:latin typeface="Century Gothic" pitchFamily="34" charset="0"/>
+                <a:ea typeface="Century Gothic" pitchFamily="34" charset="-122"/>
+                <a:cs typeface="Century Gothic" pitchFamily="34" charset="-120"/>
               </a:rPr>
               <a:t>A goal that kept moving</a:t>
             </a:r>
@@ -2739,9 +2739,9 @@
                 <a:solidFill>
                   <a:srgbClr val="E8B84B"/>
                 </a:solidFill>
-                <a:latin typeface="Montserrat" pitchFamily="34" charset="0"/>
-                <a:ea typeface="Montserrat" pitchFamily="34" charset="-122"/>
-                <a:cs typeface="Montserrat" pitchFamily="34" charset="-120"/>
+                <a:latin typeface="Century Gothic" pitchFamily="34" charset="0"/>
+                <a:ea typeface="Century Gothic" pitchFamily="34" charset="-122"/>
+                <a:cs typeface="Century Gothic" pitchFamily="34" charset="-120"/>
               </a:rPr>
               <a:t>Nobody could tell me when.</a:t>
             </a:r>
@@ -2803,9 +2803,9 @@
                 <a:solidFill>
                   <a:srgbClr val="E3F2E9"/>
                 </a:solidFill>
-                <a:latin typeface="Montserrat" pitchFamily="34" charset="0"/>
-                <a:ea typeface="Montserrat" pitchFamily="34" charset="-122"/>
-                <a:cs typeface="Montserrat" pitchFamily="34" charset="-120"/>
+                <a:latin typeface="Century Gothic" pitchFamily="34" charset="0"/>
+                <a:ea typeface="Century Gothic" pitchFamily="34" charset="-122"/>
+                <a:cs typeface="Century Gothic" pitchFamily="34" charset="-120"/>
               </a:rPr>
               <a:t>How much do I actually need?</a:t>
             </a:r>
@@ -2867,9 +2867,9 @@
                 <a:solidFill>
                   <a:srgbClr val="E3F2E9"/>
                 </a:solidFill>
-                <a:latin typeface="Montserrat" pitchFamily="34" charset="0"/>
-                <a:ea typeface="Montserrat" pitchFamily="34" charset="-122"/>
-                <a:cs typeface="Montserrat" pitchFamily="34" charset="-120"/>
+                <a:latin typeface="Century Gothic" pitchFamily="34" charset="0"/>
+                <a:ea typeface="Century Gothic" pitchFamily="34" charset="-122"/>
+                <a:cs typeface="Century Gothic" pitchFamily="34" charset="-120"/>
               </a:rPr>
               <a:t>Am I even close?</a:t>
             </a:r>
@@ -2931,9 +2931,9 @@
                 <a:solidFill>
                   <a:srgbClr val="E3F2E9"/>
                 </a:solidFill>
-                <a:latin typeface="Montserrat" pitchFamily="34" charset="0"/>
-                <a:ea typeface="Montserrat" pitchFamily="34" charset="-122"/>
-                <a:cs typeface="Montserrat" pitchFamily="34" charset="-120"/>
+                <a:latin typeface="Century Gothic" pitchFamily="34" charset="0"/>
+                <a:ea typeface="Century Gothic" pitchFamily="34" charset="-122"/>
+                <a:cs typeface="Century Gothic" pitchFamily="34" charset="-120"/>
               </a:rPr>
               <a:t>Is this the year, or five years away?</a:t>
             </a:r>
@@ -3002,9 +3002,9 @@
                 <a:solidFill>
                   <a:srgbClr val="3FA672"/>
                 </a:solidFill>
-                <a:latin typeface="Montserrat" pitchFamily="34" charset="0"/>
-                <a:ea typeface="Montserrat" pitchFamily="34" charset="-122"/>
-                <a:cs typeface="Montserrat" pitchFamily="34" charset="-120"/>
+                <a:latin typeface="Century Gothic" pitchFamily="34" charset="0"/>
+                <a:ea typeface="Century Gothic" pitchFamily="34" charset="-122"/>
+                <a:cs typeface="Century Gothic" pitchFamily="34" charset="-120"/>
               </a:rPr>
               <a:t>AND I HAD IT EASIER THAN THE PEOPLE BEHIND ME</a:t>
             </a:r>
@@ -3041,9 +3041,9 @@
                 <a:solidFill>
                   <a:srgbClr val="17302A"/>
                 </a:solidFill>
-                <a:latin typeface="Montserrat" pitchFamily="34" charset="0"/>
-                <a:ea typeface="Montserrat" pitchFamily="34" charset="-122"/>
-                <a:cs typeface="Montserrat" pitchFamily="34" charset="-120"/>
+                <a:latin typeface="Century Gothic" pitchFamily="34" charset="0"/>
+                <a:ea typeface="Century Gothic" pitchFamily="34" charset="-122"/>
+                <a:cs typeface="Century Gothic" pitchFamily="34" charset="-120"/>
               </a:rPr>
               <a:t>One generation apart</a:t>
             </a:r>
@@ -3107,9 +3107,9 @@
                 <a:solidFill>
                   <a:srgbClr val="5C6F66"/>
                 </a:solidFill>
-                <a:latin typeface="Montserrat" pitchFamily="34" charset="0"/>
-                <a:ea typeface="Montserrat" pitchFamily="34" charset="-122"/>
-                <a:cs typeface="Montserrat" pitchFamily="34" charset="-120"/>
+                <a:latin typeface="Century Gothic" pitchFamily="34" charset="0"/>
+                <a:ea typeface="Century Gothic" pitchFamily="34" charset="-122"/>
+                <a:cs typeface="Century Gothic" pitchFamily="34" charset="-120"/>
               </a:rPr>
               <a:t>2006</a:t>
             </a:r>
@@ -3146,9 +3146,9 @@
                 <a:solidFill>
                   <a:srgbClr val="17302A"/>
                 </a:solidFill>
-                <a:latin typeface="Montserrat" pitchFamily="34" charset="0"/>
-                <a:ea typeface="Montserrat" pitchFamily="34" charset="-122"/>
-                <a:cs typeface="Montserrat" pitchFamily="34" charset="-120"/>
+                <a:latin typeface="Century Gothic" pitchFamily="34" charset="0"/>
+                <a:ea typeface="Century Gothic" pitchFamily="34" charset="-122"/>
+                <a:cs typeface="Century Gothic" pitchFamily="34" charset="-120"/>
               </a:rPr>
               <a:t>$276,974</a:t>
             </a:r>
@@ -3212,9 +3212,9 @@
                 <a:solidFill>
                   <a:srgbClr val="E8B84B"/>
                 </a:solidFill>
-                <a:latin typeface="Montserrat" pitchFamily="34" charset="0"/>
-                <a:ea typeface="Montserrat" pitchFamily="34" charset="-122"/>
-                <a:cs typeface="Montserrat" pitchFamily="34" charset="-120"/>
+                <a:latin typeface="Century Gothic" pitchFamily="34" charset="0"/>
+                <a:ea typeface="Century Gothic" pitchFamily="34" charset="-122"/>
+                <a:cs typeface="Century Gothic" pitchFamily="34" charset="-120"/>
               </a:rPr>
               <a:t>TODAY</a:t>
             </a:r>
@@ -3251,9 +3251,9 @@
                 <a:solidFill>
                   <a:srgbClr val="FFFFFF"/>
                 </a:solidFill>
-                <a:latin typeface="Montserrat" pitchFamily="34" charset="0"/>
-                <a:ea typeface="Montserrat" pitchFamily="34" charset="-122"/>
-                <a:cs typeface="Montserrat" pitchFamily="34" charset="-120"/>
+                <a:latin typeface="Century Gothic" pitchFamily="34" charset="0"/>
+                <a:ea typeface="Century Gothic" pitchFamily="34" charset="-122"/>
+                <a:cs typeface="Century Gothic" pitchFamily="34" charset="-120"/>
               </a:rPr>
               <a:t>$696,078</a:t>
             </a:r>
@@ -3290,9 +3290,9 @@
                 <a:solidFill>
                   <a:srgbClr val="3FA672"/>
                 </a:solidFill>
-                <a:latin typeface="Montserrat" pitchFamily="34" charset="0"/>
-                <a:ea typeface="Montserrat" pitchFamily="34" charset="-122"/>
-                <a:cs typeface="Montserrat" pitchFamily="34" charset="-120"/>
+                <a:latin typeface="Century Gothic" pitchFamily="34" charset="0"/>
+                <a:ea typeface="Century Gothic" pitchFamily="34" charset="-122"/>
+                <a:cs typeface="Century Gothic" pitchFamily="34" charset="-120"/>
               </a:rPr>
               <a:t>2.5×</a:t>
             </a:r>
@@ -3329,9 +3329,9 @@
                 <a:solidFill>
                   <a:srgbClr val="5C6F66"/>
                 </a:solidFill>
-                <a:latin typeface="Montserrat" pitchFamily="34" charset="0"/>
-                <a:ea typeface="Montserrat" pitchFamily="34" charset="-122"/>
-                <a:cs typeface="Montserrat" pitchFamily="34" charset="-120"/>
+                <a:latin typeface="Century Gothic" pitchFamily="34" charset="0"/>
+                <a:ea typeface="Century Gothic" pitchFamily="34" charset="-122"/>
+                <a:cs typeface="Century Gothic" pitchFamily="34" charset="-120"/>
               </a:rPr>
               <a:t>Average Canadian home</a:t>
             </a:r>
@@ -3368,9 +3368,9 @@
                 <a:solidFill>
                   <a:srgbClr val="5C6F66"/>
                 </a:solidFill>
-                <a:latin typeface="Montserrat" pitchFamily="34" charset="0"/>
-                <a:ea typeface="Montserrat" pitchFamily="34" charset="-122"/>
-                <a:cs typeface="Montserrat" pitchFamily="34" charset="-120"/>
+                <a:latin typeface="Century Gothic" pitchFamily="34" charset="0"/>
+                <a:ea typeface="Century Gothic" pitchFamily="34" charset="-122"/>
+                <a:cs typeface="Century Gothic" pitchFamily="34" charset="-120"/>
               </a:rPr>
               <a:t>Source: CREA (2006 average MLS price) · national average, June 2026</a:t>
             </a:r>
@@ -3439,9 +3439,9 @@
                 <a:solidFill>
                   <a:srgbClr val="3FA672"/>
                 </a:solidFill>
-                <a:latin typeface="Montserrat" pitchFamily="34" charset="0"/>
-                <a:ea typeface="Montserrat" pitchFamily="34" charset="-122"/>
-                <a:cs typeface="Montserrat" pitchFamily="34" charset="-120"/>
+                <a:latin typeface="Century Gothic" pitchFamily="34" charset="0"/>
+                <a:ea typeface="Century Gothic" pitchFamily="34" charset="-122"/>
+                <a:cs typeface="Century Gothic" pitchFamily="34" charset="-120"/>
               </a:rPr>
               <a:t>SO I BUILT THE THING I NEEDED</a:t>
             </a:r>
@@ -3478,9 +3478,9 @@
                 <a:solidFill>
                   <a:srgbClr val="17302A"/>
                 </a:solidFill>
-                <a:latin typeface="Montserrat" pitchFamily="34" charset="0"/>
-                <a:ea typeface="Montserrat" pitchFamily="34" charset="-122"/>
-                <a:cs typeface="Montserrat" pitchFamily="34" charset="-120"/>
+                <a:latin typeface="Century Gothic" pitchFamily="34" charset="0"/>
+                <a:ea typeface="Century Gothic" pitchFamily="34" charset="-122"/>
+                <a:cs typeface="Century Gothic" pitchFamily="34" charset="-120"/>
               </a:rPr>
               <a:t>Sixty seconds in. A real date out.</a:t>
             </a:r>
@@ -3542,9 +3542,9 @@
                 <a:solidFill>
                   <a:srgbClr val="E8B84B"/>
                 </a:solidFill>
-                <a:latin typeface="Montserrat" pitchFamily="34" charset="0"/>
-                <a:ea typeface="Montserrat" pitchFamily="34" charset="-122"/>
-                <a:cs typeface="Montserrat" pitchFamily="34" charset="-120"/>
+                <a:latin typeface="Century Gothic" pitchFamily="34" charset="0"/>
+                <a:ea typeface="Century Gothic" pitchFamily="34" charset="-122"/>
+                <a:cs typeface="Century Gothic" pitchFamily="34" charset="-120"/>
               </a:rPr>
               <a:t>1</a:t>
             </a:r>
@@ -3581,9 +3581,9 @@
                 <a:solidFill>
                   <a:srgbClr val="17302A"/>
                 </a:solidFill>
-                <a:latin typeface="Montserrat" pitchFamily="34" charset="0"/>
-                <a:ea typeface="Montserrat" pitchFamily="34" charset="-122"/>
-                <a:cs typeface="Montserrat" pitchFamily="34" charset="-120"/>
+                <a:latin typeface="Century Gothic" pitchFamily="34" charset="0"/>
+                <a:ea typeface="Century Gothic" pitchFamily="34" charset="-122"/>
+                <a:cs typeface="Century Gothic" pitchFamily="34" charset="-120"/>
               </a:rPr>
               <a:t>Three questions</a:t>
             </a:r>
@@ -3645,9 +3645,9 @@
                 <a:solidFill>
                   <a:srgbClr val="E8B84B"/>
                 </a:solidFill>
-                <a:latin typeface="Montserrat" pitchFamily="34" charset="0"/>
-                <a:ea typeface="Montserrat" pitchFamily="34" charset="-122"/>
-                <a:cs typeface="Montserrat" pitchFamily="34" charset="-120"/>
+                <a:latin typeface="Century Gothic" pitchFamily="34" charset="0"/>
+                <a:ea typeface="Century Gothic" pitchFamily="34" charset="-122"/>
+                <a:cs typeface="Century Gothic" pitchFamily="34" charset="-120"/>
               </a:rPr>
               <a:t>2</a:t>
             </a:r>
@@ -3684,9 +3684,9 @@
                 <a:solidFill>
                   <a:srgbClr val="17302A"/>
                 </a:solidFill>
-                <a:latin typeface="Montserrat" pitchFamily="34" charset="0"/>
-                <a:ea typeface="Montserrat" pitchFamily="34" charset="-122"/>
-                <a:cs typeface="Montserrat" pitchFamily="34" charset="-120"/>
+                <a:latin typeface="Century Gothic" pitchFamily="34" charset="0"/>
+                <a:ea typeface="Century Gothic" pitchFamily="34" charset="-122"/>
+                <a:cs typeface="Century Gothic" pitchFamily="34" charset="-120"/>
               </a:rPr>
               <a:t>A real month</a:t>
             </a:r>
@@ -3748,9 +3748,9 @@
                 <a:solidFill>
                   <a:srgbClr val="E8B84B"/>
                 </a:solidFill>
-                <a:latin typeface="Montserrat" pitchFamily="34" charset="0"/>
-                <a:ea typeface="Montserrat" pitchFamily="34" charset="-122"/>
-                <a:cs typeface="Montserrat" pitchFamily="34" charset="-120"/>
+                <a:latin typeface="Century Gothic" pitchFamily="34" charset="0"/>
+                <a:ea typeface="Century Gothic" pitchFamily="34" charset="-122"/>
+                <a:cs typeface="Century Gothic" pitchFamily="34" charset="-120"/>
               </a:rPr>
               <a:t>3</a:t>
             </a:r>
@@ -3787,9 +3787,9 @@
                 <a:solidFill>
                   <a:srgbClr val="17302A"/>
                 </a:solidFill>
-                <a:latin typeface="Montserrat" pitchFamily="34" charset="0"/>
-                <a:ea typeface="Montserrat" pitchFamily="34" charset="-122"/>
-                <a:cs typeface="Montserrat" pitchFamily="34" charset="-120"/>
+                <a:latin typeface="Century Gothic" pitchFamily="34" charset="0"/>
+                <a:ea typeface="Century Gothic" pitchFamily="34" charset="-122"/>
+                <a:cs typeface="Century Gothic" pitchFamily="34" charset="-120"/>
               </a:rPr>
               <a:t>Watch it get closer</a:t>
             </a:r>
@@ -3853,9 +3853,9 @@
                 <a:solidFill>
                   <a:srgbClr val="E8B84B"/>
                 </a:solidFill>
-                <a:latin typeface="Montserrat" pitchFamily="34" charset="0"/>
-                <a:ea typeface="Montserrat" pitchFamily="34" charset="-122"/>
-                <a:cs typeface="Montserrat" pitchFamily="34" charset="-120"/>
+                <a:latin typeface="Century Gothic" pitchFamily="34" charset="0"/>
+                <a:ea typeface="Century Gothic" pitchFamily="34" charset="-122"/>
+                <a:cs typeface="Century Gothic" pitchFamily="34" charset="-120"/>
               </a:rPr>
               <a:t>KEYS IN HAND</a:t>
             </a:r>
@@ -3892,9 +3892,9 @@
                 <a:solidFill>
                   <a:srgbClr val="FFFFFF"/>
                 </a:solidFill>
-                <a:latin typeface="Montserrat" pitchFamily="34" charset="0"/>
-                <a:ea typeface="Montserrat" pitchFamily="34" charset="-122"/>
-                <a:cs typeface="Montserrat" pitchFamily="34" charset="-120"/>
+                <a:latin typeface="Century Gothic" pitchFamily="34" charset="0"/>
+                <a:ea typeface="Century Gothic" pitchFamily="34" charset="-122"/>
+                <a:cs typeface="Century Gothic" pitchFamily="34" charset="-120"/>
               </a:rPr>
               <a:t>June 2029</a:t>
             </a:r>
@@ -3985,9 +3985,9 @@
                 <a:solidFill>
                   <a:srgbClr val="E3F2E9"/>
                 </a:solidFill>
-                <a:latin typeface="Montserrat" pitchFamily="34" charset="0"/>
-                <a:ea typeface="Montserrat" pitchFamily="34" charset="-122"/>
-                <a:cs typeface="Montserrat" pitchFamily="34" charset="-120"/>
+                <a:latin typeface="Century Gothic" pitchFamily="34" charset="0"/>
+                <a:ea typeface="Century Gothic" pitchFamily="34" charset="-122"/>
+                <a:cs typeface="Century Gothic" pitchFamily="34" charset="-120"/>
               </a:rPr>
               <a:t>58% of the way there</a:t>
             </a:r>
@@ -4056,9 +4056,9 @@
                 <a:solidFill>
                   <a:srgbClr val="3FA672"/>
                 </a:solidFill>
-                <a:latin typeface="Montserrat" pitchFamily="34" charset="0"/>
-                <a:ea typeface="Montserrat" pitchFamily="34" charset="-122"/>
-                <a:cs typeface="Montserrat" pitchFamily="34" charset="-120"/>
+                <a:latin typeface="Century Gothic" pitchFamily="34" charset="0"/>
+                <a:ea typeface="Century Gothic" pitchFamily="34" charset="-122"/>
+                <a:cs typeface="Century Gothic" pitchFamily="34" charset="-120"/>
               </a:rPr>
               <a:t>INNOVATION</a:t>
             </a:r>
@@ -4095,9 +4095,9 @@
                 <a:solidFill>
                   <a:srgbClr val="17302A"/>
                 </a:solidFill>
-                <a:latin typeface="Montserrat" pitchFamily="34" charset="0"/>
-                <a:ea typeface="Montserrat" pitchFamily="34" charset="-122"/>
-                <a:cs typeface="Montserrat" pitchFamily="34" charset="-120"/>
+                <a:latin typeface="Century Gothic" pitchFamily="34" charset="0"/>
+                <a:ea typeface="Century Gothic" pitchFamily="34" charset="-122"/>
+                <a:cs typeface="Century Gothic" pitchFamily="34" charset="-120"/>
               </a:rPr>
               <a:t>We changed the question</a:t>
             </a:r>
@@ -4161,9 +4161,9 @@
                 <a:solidFill>
                   <a:srgbClr val="5C6F66"/>
                 </a:solidFill>
-                <a:latin typeface="Montserrat" pitchFamily="34" charset="0"/>
-                <a:ea typeface="Montserrat" pitchFamily="34" charset="-122"/>
-                <a:cs typeface="Montserrat" pitchFamily="34" charset="-120"/>
+                <a:latin typeface="Century Gothic" pitchFamily="34" charset="0"/>
+                <a:ea typeface="Century Gothic" pitchFamily="34" charset="-122"/>
+                <a:cs typeface="Century Gothic" pitchFamily="34" charset="-120"/>
               </a:rPr>
               <a:t>EVERY OTHER TOOL</a:t>
             </a:r>
@@ -4200,9 +4200,9 @@
                 <a:solidFill>
                   <a:srgbClr val="5C6F66"/>
                 </a:solidFill>
-                <a:latin typeface="Montserrat" pitchFamily="34" charset="0"/>
-                <a:ea typeface="Montserrat" pitchFamily="34" charset="-122"/>
-                <a:cs typeface="Montserrat" pitchFamily="34" charset="-120"/>
+                <a:latin typeface="Century Gothic" pitchFamily="34" charset="0"/>
+                <a:ea typeface="Century Gothic" pitchFamily="34" charset="-122"/>
+                <a:cs typeface="Century Gothic" pitchFamily="34" charset="-120"/>
               </a:rPr>
               <a:t>“Afford it today?”</a:t>
             </a:r>
@@ -4239,9 +4239,9 @@
                 <a:solidFill>
                   <a:srgbClr val="B4452F"/>
                 </a:solidFill>
-                <a:latin typeface="Montserrat" pitchFamily="34" charset="0"/>
-                <a:ea typeface="Montserrat" pitchFamily="34" charset="-122"/>
-                <a:cs typeface="Montserrat" pitchFamily="34" charset="-120"/>
+                <a:latin typeface="Century Gothic" pitchFamily="34" charset="0"/>
+                <a:ea typeface="Century Gothic" pitchFamily="34" charset="-122"/>
+                <a:cs typeface="Century Gothic" pitchFamily="34" charset="-120"/>
               </a:rPr>
               <a:t>No.</a:t>
             </a:r>
@@ -4305,9 +4305,9 @@
                 <a:solidFill>
                   <a:srgbClr val="E8B84B"/>
                 </a:solidFill>
-                <a:latin typeface="Montserrat" pitchFamily="34" charset="0"/>
-                <a:ea typeface="Montserrat" pitchFamily="34" charset="-122"/>
-                <a:cs typeface="Montserrat" pitchFamily="34" charset="-120"/>
+                <a:latin typeface="Century Gothic" pitchFamily="34" charset="0"/>
+                <a:ea typeface="Century Gothic" pitchFamily="34" charset="-122"/>
+                <a:cs typeface="Century Gothic" pitchFamily="34" charset="-120"/>
               </a:rPr>
               <a:t>KEYDATE</a:t>
             </a:r>
@@ -4344,9 +4344,9 @@
                 <a:solidFill>
                   <a:srgbClr val="FFFFFF"/>
                 </a:solidFill>
-                <a:latin typeface="Montserrat" pitchFamily="34" charset="0"/>
-                <a:ea typeface="Montserrat" pitchFamily="34" charset="-122"/>
-                <a:cs typeface="Montserrat" pitchFamily="34" charset="-120"/>
+                <a:latin typeface="Century Gothic" pitchFamily="34" charset="0"/>
+                <a:ea typeface="Century Gothic" pitchFamily="34" charset="-122"/>
+                <a:cs typeface="Century Gothic" pitchFamily="34" charset="-120"/>
               </a:rPr>
               <a:t>“When?”</a:t>
             </a:r>
@@ -4383,9 +4383,9 @@
                 <a:solidFill>
                   <a:srgbClr val="3FA672"/>
                 </a:solidFill>
-                <a:latin typeface="Montserrat" pitchFamily="34" charset="0"/>
-                <a:ea typeface="Montserrat" pitchFamily="34" charset="-122"/>
-                <a:cs typeface="Montserrat" pitchFamily="34" charset="-120"/>
+                <a:latin typeface="Century Gothic" pitchFamily="34" charset="0"/>
+                <a:ea typeface="Century Gothic" pitchFamily="34" charset="-122"/>
+                <a:cs typeface="Century Gothic" pitchFamily="34" charset="-120"/>
               </a:rPr>
               <a:t>June 2029.</a:t>
             </a:r>
@@ -4454,9 +4454,9 @@
                 <a:solidFill>
                   <a:srgbClr val="3FA672"/>
                 </a:solidFill>
-                <a:latin typeface="Montserrat" pitchFamily="34" charset="0"/>
-                <a:ea typeface="Montserrat" pitchFamily="34" charset="-122"/>
-                <a:cs typeface="Montserrat" pitchFamily="34" charset="-120"/>
+                <a:latin typeface="Century Gothic" pitchFamily="34" charset="0"/>
+                <a:ea typeface="Century Gothic" pitchFamily="34" charset="-122"/>
+                <a:cs typeface="Century Gothic" pitchFamily="34" charset="-120"/>
               </a:rPr>
               <a:t>IT WAS NEVER JUST MY STORY</a:t>
             </a:r>
@@ -4489,17 +4489,17 @@
               <a:buNone/>
             </a:pPr>
             <a:r>
-              <a:rPr lang="en-US" sz="3500" b="1" dirty="0">
+              <a:rPr lang="en-US" sz="3200" b="1" dirty="0">
                 <a:solidFill>
                   <a:srgbClr val="17302A"/>
                 </a:solidFill>
-                <a:latin typeface="Montserrat" pitchFamily="34" charset="0"/>
-                <a:ea typeface="Montserrat" pitchFamily="34" charset="-122"/>
-                <a:cs typeface="Montserrat" pitchFamily="34" charset="-120"/>
+                <a:latin typeface="Century Gothic" pitchFamily="34" charset="0"/>
+                <a:ea typeface="Century Gothic" pitchFamily="34" charset="-122"/>
+                <a:cs typeface="Century Gothic" pitchFamily="34" charset="-120"/>
               </a:rPr>
               <a:t>The engine doesn’t change at the border</a:t>
             </a:r>
-            <a:endParaRPr lang="en-US" sz="3500" dirty="0"/>
+            <a:endParaRPr lang="en-US" sz="3200" dirty="0"/>
           </a:p>
         </p:txBody>
       </p:sp>
@@ -4559,9 +4559,9 @@
                 <a:solidFill>
                   <a:srgbClr val="FFFFFF"/>
                 </a:solidFill>
-                <a:latin typeface="Montserrat" pitchFamily="34" charset="0"/>
-                <a:ea typeface="Montserrat" pitchFamily="34" charset="-122"/>
-                <a:cs typeface="Montserrat" pitchFamily="34" charset="-120"/>
+                <a:latin typeface="Century Gothic" pitchFamily="34" charset="0"/>
+                <a:ea typeface="Century Gothic" pitchFamily="34" charset="-122"/>
+                <a:cs typeface="Century Gothic" pitchFamily="34" charset="-120"/>
               </a:rPr>
               <a:t>Canada</a:t>
             </a:r>
@@ -4625,9 +4625,9 @@
                 <a:solidFill>
                   <a:srgbClr val="17302A"/>
                 </a:solidFill>
-                <a:latin typeface="Montserrat" pitchFamily="34" charset="0"/>
-                <a:ea typeface="Montserrat" pitchFamily="34" charset="-122"/>
-                <a:cs typeface="Montserrat" pitchFamily="34" charset="-120"/>
+                <a:latin typeface="Century Gothic" pitchFamily="34" charset="0"/>
+                <a:ea typeface="Century Gothic" pitchFamily="34" charset="-122"/>
+                <a:cs typeface="Century Gothic" pitchFamily="34" charset="-120"/>
               </a:rPr>
               <a:t>Australia</a:t>
             </a:r>
@@ -4691,9 +4691,9 @@
                 <a:solidFill>
                   <a:srgbClr val="17302A"/>
                 </a:solidFill>
-                <a:latin typeface="Montserrat" pitchFamily="34" charset="0"/>
-                <a:ea typeface="Montserrat" pitchFamily="34" charset="-122"/>
-                <a:cs typeface="Montserrat" pitchFamily="34" charset="-120"/>
+                <a:latin typeface="Century Gothic" pitchFamily="34" charset="0"/>
+                <a:ea typeface="Century Gothic" pitchFamily="34" charset="-122"/>
+                <a:cs typeface="Century Gothic" pitchFamily="34" charset="-120"/>
               </a:rPr>
               <a:t>UK</a:t>
             </a:r>
@@ -4757,9 +4757,9 @@
                 <a:solidFill>
                   <a:srgbClr val="17302A"/>
                 </a:solidFill>
-                <a:latin typeface="Montserrat" pitchFamily="34" charset="0"/>
-                <a:ea typeface="Montserrat" pitchFamily="34" charset="-122"/>
-                <a:cs typeface="Montserrat" pitchFamily="34" charset="-120"/>
+                <a:latin typeface="Century Gothic" pitchFamily="34" charset="0"/>
+                <a:ea typeface="Century Gothic" pitchFamily="34" charset="-122"/>
+                <a:cs typeface="Century Gothic" pitchFamily="34" charset="-120"/>
               </a:rPr>
               <a:t>Ireland</a:t>
             </a:r>
@@ -4823,9 +4823,9 @@
                 <a:solidFill>
                   <a:srgbClr val="17302A"/>
                 </a:solidFill>
-                <a:latin typeface="Montserrat" pitchFamily="34" charset="0"/>
-                <a:ea typeface="Montserrat" pitchFamily="34" charset="-122"/>
-                <a:cs typeface="Montserrat" pitchFamily="34" charset="-120"/>
+                <a:latin typeface="Century Gothic" pitchFamily="34" charset="0"/>
+                <a:ea typeface="Century Gothic" pitchFamily="34" charset="-122"/>
+                <a:cs typeface="Century Gothic" pitchFamily="34" charset="-120"/>
               </a:rPr>
               <a:t>New Zealand</a:t>
             </a:r>
@@ -4889,9 +4889,9 @@
                 <a:solidFill>
                   <a:srgbClr val="E3F2E9"/>
                 </a:solidFill>
-                <a:latin typeface="Montserrat" pitchFamily="34" charset="0"/>
-                <a:ea typeface="Montserrat" pitchFamily="34" charset="-122"/>
-                <a:cs typeface="Montserrat" pitchFamily="34" charset="-120"/>
+                <a:latin typeface="Century Gothic" pitchFamily="34" charset="0"/>
+                <a:ea typeface="Century Gothic" pitchFamily="34" charset="-122"/>
+                <a:cs typeface="Century Gothic" pitchFamily="34" charset="-120"/>
               </a:rPr>
               <a:t>The engine stays. </a:t>
             </a:r>
@@ -4903,9 +4903,9 @@
                 <a:solidFill>
                   <a:srgbClr val="E8B84B"/>
                 </a:solidFill>
-                <a:latin typeface="Montserrat" pitchFamily="34" charset="0"/>
-                <a:ea typeface="Montserrat" pitchFamily="34" charset="-122"/>
-                <a:cs typeface="Montserrat" pitchFamily="34" charset="-120"/>
+                <a:latin typeface="Century Gothic" pitchFamily="34" charset="0"/>
+                <a:ea typeface="Century Gothic" pitchFamily="34" charset="-122"/>
+                <a:cs typeface="Century Gothic" pitchFamily="34" charset="-120"/>
               </a:rPr>
               <a:t>The rulebook swaps.</a:t>
             </a:r>
@@ -4974,9 +4974,9 @@
                 <a:solidFill>
                   <a:srgbClr val="E8B84B"/>
                 </a:solidFill>
-                <a:latin typeface="Montserrat" pitchFamily="34" charset="0"/>
-                <a:ea typeface="Montserrat" pitchFamily="34" charset="-122"/>
-                <a:cs typeface="Montserrat" pitchFamily="34" charset="-120"/>
+                <a:latin typeface="Century Gothic" pitchFamily="34" charset="0"/>
+                <a:ea typeface="Century Gothic" pitchFamily="34" charset="-122"/>
+                <a:cs typeface="Century Gothic" pitchFamily="34" charset="-120"/>
               </a:rPr>
               <a:t>COMMUNITY IMPACT &amp; SUSTAINABILITY</a:t>
             </a:r>
@@ -5013,9 +5013,9 @@
                 <a:solidFill>
                   <a:srgbClr val="FFFFFF"/>
                 </a:solidFill>
-                <a:latin typeface="Montserrat" pitchFamily="34" charset="0"/>
-                <a:ea typeface="Montserrat" pitchFamily="34" charset="-122"/>
-                <a:cs typeface="Montserrat" pitchFamily="34" charset="-120"/>
+                <a:latin typeface="Century Gothic" pitchFamily="34" charset="0"/>
+                <a:ea typeface="Century Gothic" pitchFamily="34" charset="-122"/>
+                <a:cs typeface="Century Gothic" pitchFamily="34" charset="-120"/>
               </a:rPr>
               <a:t>The money we refuse to take</a:t>
             </a:r>
@@ -5082,9 +5082,9 @@
                 <a:solidFill>
                   <a:srgbClr val="FFFFFF"/>
                 </a:solidFill>
-                <a:latin typeface="Montserrat" pitchFamily="34" charset="0"/>
-                <a:ea typeface="Montserrat" pitchFamily="34" charset="-122"/>
-                <a:cs typeface="Montserrat" pitchFamily="34" charset="-120"/>
+                <a:latin typeface="Century Gothic" pitchFamily="34" charset="0"/>
+                <a:ea typeface="Century Gothic" pitchFamily="34" charset="-122"/>
+                <a:cs typeface="Century Gothic" pitchFamily="34" charset="-120"/>
               </a:rPr>
               <a:t>We never sell you</a:t>
             </a:r>
@@ -5102,9 +5102,9 @@
                 <a:solidFill>
                   <a:srgbClr val="FFFFFF"/>
                 </a:solidFill>
-                <a:latin typeface="Montserrat" pitchFamily="34" charset="0"/>
-                <a:ea typeface="Montserrat" pitchFamily="34" charset="-122"/>
-                <a:cs typeface="Montserrat" pitchFamily="34" charset="-120"/>
+                <a:latin typeface="Century Gothic" pitchFamily="34" charset="0"/>
+                <a:ea typeface="Century Gothic" pitchFamily="34" charset="-122"/>
+                <a:cs typeface="Century Gothic" pitchFamily="34" charset="-120"/>
               </a:rPr>
               <a:t>to brokers.</a:t>
             </a:r>
@@ -5171,9 +5171,9 @@
                 <a:solidFill>
                   <a:srgbClr val="FFFFFF"/>
                 </a:solidFill>
-                <a:latin typeface="Montserrat" pitchFamily="34" charset="0"/>
-                <a:ea typeface="Montserrat" pitchFamily="34" charset="-122"/>
-                <a:cs typeface="Montserrat" pitchFamily="34" charset="-120"/>
+                <a:latin typeface="Century Gothic" pitchFamily="34" charset="0"/>
+                <a:ea typeface="Century Gothic" pitchFamily="34" charset="-122"/>
+                <a:cs typeface="Century Gothic" pitchFamily="34" charset="-120"/>
               </a:rPr>
               <a:t>We built the tool</a:t>
             </a:r>
@@ -5191,9 +5191,9 @@
                 <a:solidFill>
                   <a:srgbClr val="FFFFFF"/>
                 </a:solidFill>
-                <a:latin typeface="Montserrat" pitchFamily="34" charset="0"/>
-                <a:ea typeface="Montserrat" pitchFamily="34" charset="-122"/>
-                <a:cs typeface="Montserrat" pitchFamily="34" charset="-120"/>
+                <a:latin typeface="Century Gothic" pitchFamily="34" charset="0"/>
+                <a:ea typeface="Century Gothic" pitchFamily="34" charset="-122"/>
+                <a:cs typeface="Century Gothic" pitchFamily="34" charset="-120"/>
               </a:rPr>
               <a:t>that says don’t buy.</a:t>
             </a:r>
@@ -5230,9 +5230,9 @@
                 <a:solidFill>
                   <a:srgbClr val="E8B84B"/>
                 </a:solidFill>
-                <a:latin typeface="Montserrat" pitchFamily="34" charset="0"/>
-                <a:ea typeface="Montserrat" pitchFamily="34" charset="-122"/>
-                <a:cs typeface="Montserrat" pitchFamily="34" charset="-120"/>
+                <a:latin typeface="Century Gothic" pitchFamily="34" charset="0"/>
+                <a:ea typeface="Century Gothic" pitchFamily="34" charset="-122"/>
+                <a:cs typeface="Century Gothic" pitchFamily="34" charset="-120"/>
               </a:rPr>
               <a:t>A company on referral fees can never say that.</a:t>
             </a:r>
@@ -5301,9 +5301,9 @@
                 <a:solidFill>
                   <a:srgbClr val="3FA672"/>
                 </a:solidFill>
-                <a:latin typeface="Montserrat" pitchFamily="34" charset="0"/>
-                <a:ea typeface="Montserrat" pitchFamily="34" charset="-122"/>
-                <a:cs typeface="Montserrat" pitchFamily="34" charset="-120"/>
+                <a:latin typeface="Century Gothic" pitchFamily="34" charset="0"/>
+                <a:ea typeface="Century Gothic" pitchFamily="34" charset="-122"/>
+                <a:cs typeface="Century Gothic" pitchFamily="34" charset="-120"/>
               </a:rPr>
               <a:t>SCALABILITY &amp; LEADERSHIP</a:t>
             </a:r>
@@ -5340,9 +5340,9 @@
                 <a:solidFill>
                   <a:srgbClr val="17302A"/>
                 </a:solidFill>
-                <a:latin typeface="Montserrat" pitchFamily="34" charset="0"/>
-                <a:ea typeface="Montserrat" pitchFamily="34" charset="-122"/>
-                <a:cs typeface="Montserrat" pitchFamily="34" charset="-120"/>
+                <a:latin typeface="Century Gothic" pitchFamily="34" charset="0"/>
+                <a:ea typeface="Century Gothic" pitchFamily="34" charset="-122"/>
+                <a:cs typeface="Century Gothic" pitchFamily="34" charset="-120"/>
               </a:rPr>
               <a:t>Built, shipped, live</a:t>
             </a:r>
@@ -5406,9 +5406,9 @@
                 <a:solidFill>
                   <a:srgbClr val="3FA672"/>
                 </a:solidFill>
-                <a:latin typeface="Montserrat" pitchFamily="34" charset="0"/>
-                <a:ea typeface="Montserrat" pitchFamily="34" charset="-122"/>
-                <a:cs typeface="Montserrat" pitchFamily="34" charset="-120"/>
+                <a:latin typeface="Century Gothic" pitchFamily="34" charset="0"/>
+                <a:ea typeface="Century Gothic" pitchFamily="34" charset="-122"/>
+                <a:cs typeface="Century Gothic" pitchFamily="34" charset="-120"/>
               </a:rPr>
               <a:t>467</a:t>
             </a:r>
@@ -5445,9 +5445,9 @@
                 <a:solidFill>
                   <a:srgbClr val="5C6F66"/>
                 </a:solidFill>
-                <a:latin typeface="Montserrat" pitchFamily="34" charset="0"/>
-                <a:ea typeface="Montserrat" pitchFamily="34" charset="-122"/>
-                <a:cs typeface="Montserrat" pitchFamily="34" charset="-120"/>
+                <a:latin typeface="Century Gothic" pitchFamily="34" charset="0"/>
+                <a:ea typeface="Century Gothic" pitchFamily="34" charset="-122"/>
+                <a:cs typeface="Century Gothic" pitchFamily="34" charset="-120"/>
               </a:rPr>
               <a:t>municipalities</a:t>
             </a:r>
@@ -5511,9 +5511,9 @@
                 <a:solidFill>
                   <a:srgbClr val="3FA672"/>
                 </a:solidFill>
-                <a:latin typeface="Montserrat" pitchFamily="34" charset="0"/>
-                <a:ea typeface="Montserrat" pitchFamily="34" charset="-122"/>
-                <a:cs typeface="Montserrat" pitchFamily="34" charset="-120"/>
+                <a:latin typeface="Century Gothic" pitchFamily="34" charset="0"/>
+                <a:ea typeface="Century Gothic" pitchFamily="34" charset="-122"/>
+                <a:cs typeface="Century Gothic" pitchFamily="34" charset="-120"/>
               </a:rPr>
               <a:t>~$0</a:t>
             </a:r>
@@ -5550,9 +5550,9 @@
                 <a:solidFill>
                   <a:srgbClr val="5C6F66"/>
                 </a:solidFill>
-                <a:latin typeface="Montserrat" pitchFamily="34" charset="0"/>
-                <a:ea typeface="Montserrat" pitchFamily="34" charset="-122"/>
-                <a:cs typeface="Montserrat" pitchFamily="34" charset="-120"/>
+                <a:latin typeface="Century Gothic" pitchFamily="34" charset="0"/>
+                <a:ea typeface="Century Gothic" pitchFamily="34" charset="-122"/>
+                <a:cs typeface="Century Gothic" pitchFamily="34" charset="-120"/>
               </a:rPr>
               <a:t>cost per user</a:t>
             </a:r>
@@ -5616,9 +5616,9 @@
                 <a:solidFill>
                   <a:srgbClr val="3FA672"/>
                 </a:solidFill>
-                <a:latin typeface="Montserrat" pitchFamily="34" charset="0"/>
-                <a:ea typeface="Montserrat" pitchFamily="34" charset="-122"/>
-                <a:cs typeface="Montserrat" pitchFamily="34" charset="-120"/>
+                <a:latin typeface="Century Gothic" pitchFamily="34" charset="0"/>
+                <a:ea typeface="Century Gothic" pitchFamily="34" charset="-122"/>
+                <a:cs typeface="Century Gothic" pitchFamily="34" charset="-120"/>
               </a:rPr>
               <a:t>1</a:t>
             </a:r>
@@ -5655,9 +5655,9 @@
                 <a:solidFill>
                   <a:srgbClr val="5C6F66"/>
                 </a:solidFill>
-                <a:latin typeface="Montserrat" pitchFamily="34" charset="0"/>
-                <a:ea typeface="Montserrat" pitchFamily="34" charset="-122"/>
-                <a:cs typeface="Montserrat" pitchFamily="34" charset="-120"/>
+                <a:latin typeface="Century Gothic" pitchFamily="34" charset="0"/>
+                <a:ea typeface="Century Gothic" pitchFamily="34" charset="-122"/>
+                <a:cs typeface="Century Gothic" pitchFamily="34" charset="-120"/>
               </a:rPr>
               <a:t>founder</a:t>
             </a:r>
@@ -5721,9 +5721,9 @@
                 <a:solidFill>
                   <a:srgbClr val="1E4D3B"/>
                 </a:solidFill>
-                <a:latin typeface="Montserrat" pitchFamily="34" charset="0"/>
-                <a:ea typeface="Montserrat" pitchFamily="34" charset="-122"/>
-                <a:cs typeface="Montserrat" pitchFamily="34" charset="-120"/>
+                <a:latin typeface="Century Gothic" pitchFamily="34" charset="0"/>
+                <a:ea typeface="Century Gothic" pitchFamily="34" charset="-122"/>
+                <a:cs typeface="Century Gothic" pitchFamily="34" charset="-120"/>
               </a:rPr>
               <a:t>A new country is a rulebook, not a rebuild.</a:t>
             </a:r>

</xml_diff>